<commit_message>
DT122: B6 visual-first deck with Mermaid and pipeline overlay.
Seven diagram slides in three acts; render_b6_diagrams via npx mmdc and
Pillow; wire B6 Diagram fields through build, validate, and check-decks.

Co-authored-by: Cursor <cursoragent@cursor.com>
</commit_message>
<xml_diff>
--- a/dt122/bugatti-qos-ccc.pptx
+++ b/dt122/bugatti-qos-ccc.pptx
@@ -16,9 +16,6 @@
     <p:sldId id="262" r:id="rId11"/>
     <p:sldId id="263" r:id="rId12"/>
     <p:sldId id="264" r:id="rId13"/>
-    <p:sldId id="265" r:id="rId14"/>
-    <p:sldId id="266" r:id="rId15"/>
-    <p:sldId id="267" r:id="rId16"/>
   </p:sldIdLst>
   <p:sldSz cx="9144000" cy="5143500" type="screen16x9"/>
   <p:notesSz cx="5143500" cy="9144000"/>
@@ -1871,522 +1868,6 @@
             <a:fld id="{00000000-1234-1234-1234-123412341234}" type="slidenum">
               <a:rPr lang="en-US"/>
               <a:t>1</a:t>
-            </a:fld>
-            <a:endParaRPr/>
-          </a:p>
-        </p:txBody>
-      </p:sp>
-    </p:spTree>
-  </p:cSld>
-  <p:clrMapOvr>
-    <a:masterClrMapping/>
-  </p:clrMapOvr>
-</p:notes>
-</file>
-
-<file path=ppt/notesSlides/notesSlide10.xml><?xml version="1.0" encoding="utf-8"?>
-<p:notes xmlns:a="http://schemas.openxmlformats.org/drawingml/2006/main" xmlns:r="http://schemas.openxmlformats.org/officeDocument/2006/relationships" xmlns:p="http://schemas.openxmlformats.org/presentationml/2006/main" showMasterSp="0" showMasterPhAnim="0">
-  <p:cSld>
-    <p:spTree>
-      <p:nvGrpSpPr>
-        <p:cNvPr id="1" name="Shape 125"/>
-        <p:cNvGrpSpPr/>
-        <p:nvPr/>
-      </p:nvGrpSpPr>
-      <p:grpSpPr>
-        <a:xfrm>
-          <a:off x="0" y="0"/>
-          <a:ext cx="0" cy="0"/>
-          <a:chOff x="0" y="0"/>
-          <a:chExt cx="0" cy="0"/>
-        </a:xfrm>
-      </p:grpSpPr>
-      <p:sp>
-        <p:nvSpPr>
-          <p:cNvPr id="126" name="Google Shape;126;g38b39bbdc2a_0_41:notes"/>
-          <p:cNvSpPr>
-            <a:spLocks noGrp="1" noRot="1" noChangeAspect="1"/>
-          </p:cNvSpPr>
-          <p:nvPr>
-            <p:ph type="sldImg" idx="2"/>
-          </p:nvPr>
-        </p:nvSpPr>
-        <p:spPr>
-          <a:xfrm>
-            <a:off x="685800" y="1143000"/>
-            <a:ext cx="5486400" cy="3086100"/>
-          </a:xfrm>
-          <a:custGeom>
-            <a:avLst/>
-            <a:gdLst/>
-            <a:ahLst/>
-            <a:cxnLst/>
-            <a:rect l="l" t="t" r="r" b="b"/>
-            <a:pathLst>
-              <a:path w="120000" h="120000" extrusionOk="0">
-                <a:moveTo>
-                  <a:pt x="0" y="0"/>
-                </a:moveTo>
-                <a:lnTo>
-                  <a:pt x="120000" y="0"/>
-                </a:lnTo>
-                <a:lnTo>
-                  <a:pt x="120000" y="120000"/>
-                </a:lnTo>
-                <a:lnTo>
-                  <a:pt x="0" y="120000"/>
-                </a:lnTo>
-                <a:close/>
-              </a:path>
-            </a:pathLst>
-          </a:custGeom>
-          <a:noFill/>
-          <a:ln w="12700" cap="flat" cmpd="sng">
-            <a:solidFill>
-              <a:srgbClr val="000000"/>
-            </a:solidFill>
-            <a:prstDash val="solid"/>
-            <a:round/>
-            <a:headEnd type="none" w="sm" len="sm"/>
-            <a:tailEnd type="none" w="sm" len="sm"/>
-          </a:ln>
-        </p:spPr>
-      </p:sp>
-      <p:sp>
-        <p:nvSpPr>
-          <p:cNvPr id="127" name="Google Shape;127;g38b39bbdc2a_0_41:notes"/>
-          <p:cNvSpPr txBox="1">
-            <a:spLocks noGrp="1"/>
-          </p:cNvSpPr>
-          <p:nvPr>
-            <p:ph type="body" idx="1"/>
-          </p:nvPr>
-        </p:nvSpPr>
-        <p:spPr>
-          <a:xfrm>
-            <a:off x="685800" y="4400550"/>
-            <a:ext cx="5486400" cy="3600600"/>
-          </a:xfrm>
-          <a:prstGeom prst="rect">
-            <a:avLst/>
-          </a:prstGeom>
-          <a:noFill/>
-          <a:ln>
-            <a:noFill/>
-          </a:ln>
-        </p:spPr>
-        <p:txBody>
-          <a:bodyPr spcFirstLastPara="1" wrap="square" lIns="91425" tIns="45700" rIns="91425" bIns="45700" anchor="t" anchorCtr="0">
-            <a:noAutofit/>
-          </a:bodyPr>
-          <a:lstStyle/>
-          <a:p>
-            <a:pPr marL="0" lvl="0" indent="0" algn="l" rtl="0">
-              <a:lnSpc>
-                <a:spcPct val="100000"/>
-              </a:lnSpc>
-              <a:spcBef>
-                <a:spcPts val="0"/>
-              </a:spcBef>
-              <a:spcAft>
-                <a:spcPts val="0"/>
-              </a:spcAft>
-              <a:buSzPts val="1400"/>
-              <a:buNone/>
-            </a:pPr>
-            <a:endParaRPr/>
-          </a:p>
-        </p:txBody>
-      </p:sp>
-      <p:sp>
-        <p:nvSpPr>
-          <p:cNvPr id="128" name="Google Shape;128;g38b39bbdc2a_0_41:notes"/>
-          <p:cNvSpPr txBox="1">
-            <a:spLocks noGrp="1"/>
-          </p:cNvSpPr>
-          <p:nvPr>
-            <p:ph type="sldNum" idx="12"/>
-          </p:nvPr>
-        </p:nvSpPr>
-        <p:spPr>
-          <a:xfrm>
-            <a:off x="3884613" y="8685213"/>
-            <a:ext cx="2971800" cy="458700"/>
-          </a:xfrm>
-          <a:prstGeom prst="rect">
-            <a:avLst/>
-          </a:prstGeom>
-          <a:noFill/>
-          <a:ln>
-            <a:noFill/>
-          </a:ln>
-        </p:spPr>
-        <p:txBody>
-          <a:bodyPr spcFirstLastPara="1" wrap="square" lIns="91425" tIns="45700" rIns="91425" bIns="45700" anchor="b" anchorCtr="0">
-            <a:noAutofit/>
-          </a:bodyPr>
-          <a:lstStyle/>
-          <a:p>
-            <a:pPr marL="0" lvl="0" indent="0" algn="r" rtl="0">
-              <a:lnSpc>
-                <a:spcPct val="100000"/>
-              </a:lnSpc>
-              <a:spcBef>
-                <a:spcPts val="0"/>
-              </a:spcBef>
-              <a:spcAft>
-                <a:spcPts val="0"/>
-              </a:spcAft>
-              <a:buSzPts val="1400"/>
-              <a:buNone/>
-            </a:pPr>
-            <a:fld id="{00000000-1234-1234-1234-123412341234}" type="slidenum">
-              <a:rPr lang="en-US"/>
-              <a:t>10</a:t>
-            </a:fld>
-            <a:endParaRPr/>
-          </a:p>
-        </p:txBody>
-      </p:sp>
-    </p:spTree>
-  </p:cSld>
-  <p:clrMapOvr>
-    <a:masterClrMapping/>
-  </p:clrMapOvr>
-</p:notes>
-</file>
-
-<file path=ppt/notesSlides/notesSlide11.xml><?xml version="1.0" encoding="utf-8"?>
-<p:notes xmlns:a="http://schemas.openxmlformats.org/drawingml/2006/main" xmlns:r="http://schemas.openxmlformats.org/officeDocument/2006/relationships" xmlns:p="http://schemas.openxmlformats.org/presentationml/2006/main" showMasterSp="0" showMasterPhAnim="0">
-  <p:cSld>
-    <p:spTree>
-      <p:nvGrpSpPr>
-        <p:cNvPr id="1" name="Shape 136"/>
-        <p:cNvGrpSpPr/>
-        <p:nvPr/>
-      </p:nvGrpSpPr>
-      <p:grpSpPr>
-        <a:xfrm>
-          <a:off x="0" y="0"/>
-          <a:ext cx="0" cy="0"/>
-          <a:chOff x="0" y="0"/>
-          <a:chExt cx="0" cy="0"/>
-        </a:xfrm>
-      </p:grpSpPr>
-      <p:sp>
-        <p:nvSpPr>
-          <p:cNvPr id="137" name="Google Shape;137;g38b39bbdc2a_0_51:notes"/>
-          <p:cNvSpPr>
-            <a:spLocks noGrp="1" noRot="1" noChangeAspect="1"/>
-          </p:cNvSpPr>
-          <p:nvPr>
-            <p:ph type="sldImg" idx="2"/>
-          </p:nvPr>
-        </p:nvSpPr>
-        <p:spPr>
-          <a:xfrm>
-            <a:off x="685800" y="1143000"/>
-            <a:ext cx="5486400" cy="3086100"/>
-          </a:xfrm>
-          <a:custGeom>
-            <a:avLst/>
-            <a:gdLst/>
-            <a:ahLst/>
-            <a:cxnLst/>
-            <a:rect l="l" t="t" r="r" b="b"/>
-            <a:pathLst>
-              <a:path w="120000" h="120000" extrusionOk="0">
-                <a:moveTo>
-                  <a:pt x="0" y="0"/>
-                </a:moveTo>
-                <a:lnTo>
-                  <a:pt x="120000" y="0"/>
-                </a:lnTo>
-                <a:lnTo>
-                  <a:pt x="120000" y="120000"/>
-                </a:lnTo>
-                <a:lnTo>
-                  <a:pt x="0" y="120000"/>
-                </a:lnTo>
-                <a:close/>
-              </a:path>
-            </a:pathLst>
-          </a:custGeom>
-          <a:noFill/>
-          <a:ln w="12700" cap="flat" cmpd="sng">
-            <a:solidFill>
-              <a:srgbClr val="000000"/>
-            </a:solidFill>
-            <a:prstDash val="solid"/>
-            <a:round/>
-            <a:headEnd type="none" w="sm" len="sm"/>
-            <a:tailEnd type="none" w="sm" len="sm"/>
-          </a:ln>
-        </p:spPr>
-      </p:sp>
-      <p:sp>
-        <p:nvSpPr>
-          <p:cNvPr id="138" name="Google Shape;138;g38b39bbdc2a_0_51:notes"/>
-          <p:cNvSpPr txBox="1">
-            <a:spLocks noGrp="1"/>
-          </p:cNvSpPr>
-          <p:nvPr>
-            <p:ph type="body" idx="1"/>
-          </p:nvPr>
-        </p:nvSpPr>
-        <p:spPr>
-          <a:xfrm>
-            <a:off x="685800" y="4400550"/>
-            <a:ext cx="5486400" cy="3600600"/>
-          </a:xfrm>
-          <a:prstGeom prst="rect">
-            <a:avLst/>
-          </a:prstGeom>
-          <a:noFill/>
-          <a:ln>
-            <a:noFill/>
-          </a:ln>
-        </p:spPr>
-        <p:txBody>
-          <a:bodyPr spcFirstLastPara="1" wrap="square" lIns="91425" tIns="45700" rIns="91425" bIns="45700" anchor="t" anchorCtr="0">
-            <a:noAutofit/>
-          </a:bodyPr>
-          <a:lstStyle/>
-          <a:p>
-            <a:pPr marL="0" lvl="0" indent="0" algn="l" rtl="0">
-              <a:lnSpc>
-                <a:spcPct val="100000"/>
-              </a:lnSpc>
-              <a:spcBef>
-                <a:spcPts val="0"/>
-              </a:spcBef>
-              <a:spcAft>
-                <a:spcPts val="0"/>
-              </a:spcAft>
-              <a:buSzPts val="1400"/>
-              <a:buNone/>
-            </a:pPr>
-            <a:endParaRPr/>
-          </a:p>
-        </p:txBody>
-      </p:sp>
-      <p:sp>
-        <p:nvSpPr>
-          <p:cNvPr id="139" name="Google Shape;139;g38b39bbdc2a_0_51:notes"/>
-          <p:cNvSpPr txBox="1">
-            <a:spLocks noGrp="1"/>
-          </p:cNvSpPr>
-          <p:nvPr>
-            <p:ph type="sldNum" idx="12"/>
-          </p:nvPr>
-        </p:nvSpPr>
-        <p:spPr>
-          <a:xfrm>
-            <a:off x="3884613" y="8685213"/>
-            <a:ext cx="2971800" cy="458700"/>
-          </a:xfrm>
-          <a:prstGeom prst="rect">
-            <a:avLst/>
-          </a:prstGeom>
-          <a:noFill/>
-          <a:ln>
-            <a:noFill/>
-          </a:ln>
-        </p:spPr>
-        <p:txBody>
-          <a:bodyPr spcFirstLastPara="1" wrap="square" lIns="91425" tIns="45700" rIns="91425" bIns="45700" anchor="b" anchorCtr="0">
-            <a:noAutofit/>
-          </a:bodyPr>
-          <a:lstStyle/>
-          <a:p>
-            <a:pPr marL="0" lvl="0" indent="0" algn="r" rtl="0">
-              <a:lnSpc>
-                <a:spcPct val="100000"/>
-              </a:lnSpc>
-              <a:spcBef>
-                <a:spcPts val="0"/>
-              </a:spcBef>
-              <a:spcAft>
-                <a:spcPts val="0"/>
-              </a:spcAft>
-              <a:buSzPts val="1400"/>
-              <a:buNone/>
-            </a:pPr>
-            <a:fld id="{00000000-1234-1234-1234-123412341234}" type="slidenum">
-              <a:rPr lang="en-US"/>
-              <a:t>11</a:t>
-            </a:fld>
-            <a:endParaRPr/>
-          </a:p>
-        </p:txBody>
-      </p:sp>
-    </p:spTree>
-  </p:cSld>
-  <p:clrMapOvr>
-    <a:masterClrMapping/>
-  </p:clrMapOvr>
-</p:notes>
-</file>
-
-<file path=ppt/notesSlides/notesSlide12.xml><?xml version="1.0" encoding="utf-8"?>
-<p:notes xmlns:a="http://schemas.openxmlformats.org/drawingml/2006/main" xmlns:r="http://schemas.openxmlformats.org/officeDocument/2006/relationships" xmlns:p="http://schemas.openxmlformats.org/presentationml/2006/main" showMasterSp="0" showMasterPhAnim="0">
-  <p:cSld>
-    <p:spTree>
-      <p:nvGrpSpPr>
-        <p:cNvPr id="1" name="Shape 147"/>
-        <p:cNvGrpSpPr/>
-        <p:nvPr/>
-      </p:nvGrpSpPr>
-      <p:grpSpPr>
-        <a:xfrm>
-          <a:off x="0" y="0"/>
-          <a:ext cx="0" cy="0"/>
-          <a:chOff x="0" y="0"/>
-          <a:chExt cx="0" cy="0"/>
-        </a:xfrm>
-      </p:grpSpPr>
-      <p:sp>
-        <p:nvSpPr>
-          <p:cNvPr id="148" name="Google Shape;148;g38b39bbdc2a_0_61:notes"/>
-          <p:cNvSpPr>
-            <a:spLocks noGrp="1" noRot="1" noChangeAspect="1"/>
-          </p:cNvSpPr>
-          <p:nvPr>
-            <p:ph type="sldImg" idx="2"/>
-          </p:nvPr>
-        </p:nvSpPr>
-        <p:spPr>
-          <a:xfrm>
-            <a:off x="685800" y="1143000"/>
-            <a:ext cx="5486400" cy="3086100"/>
-          </a:xfrm>
-          <a:custGeom>
-            <a:avLst/>
-            <a:gdLst/>
-            <a:ahLst/>
-            <a:cxnLst/>
-            <a:rect l="l" t="t" r="r" b="b"/>
-            <a:pathLst>
-              <a:path w="120000" h="120000" extrusionOk="0">
-                <a:moveTo>
-                  <a:pt x="0" y="0"/>
-                </a:moveTo>
-                <a:lnTo>
-                  <a:pt x="120000" y="0"/>
-                </a:lnTo>
-                <a:lnTo>
-                  <a:pt x="120000" y="120000"/>
-                </a:lnTo>
-                <a:lnTo>
-                  <a:pt x="0" y="120000"/>
-                </a:lnTo>
-                <a:close/>
-              </a:path>
-            </a:pathLst>
-          </a:custGeom>
-          <a:noFill/>
-          <a:ln w="12700" cap="flat" cmpd="sng">
-            <a:solidFill>
-              <a:srgbClr val="000000"/>
-            </a:solidFill>
-            <a:prstDash val="solid"/>
-            <a:round/>
-            <a:headEnd type="none" w="sm" len="sm"/>
-            <a:tailEnd type="none" w="sm" len="sm"/>
-          </a:ln>
-        </p:spPr>
-      </p:sp>
-      <p:sp>
-        <p:nvSpPr>
-          <p:cNvPr id="149" name="Google Shape;149;g38b39bbdc2a_0_61:notes"/>
-          <p:cNvSpPr txBox="1">
-            <a:spLocks noGrp="1"/>
-          </p:cNvSpPr>
-          <p:nvPr>
-            <p:ph type="body" idx="1"/>
-          </p:nvPr>
-        </p:nvSpPr>
-        <p:spPr>
-          <a:xfrm>
-            <a:off x="685800" y="4400550"/>
-            <a:ext cx="5486400" cy="3600600"/>
-          </a:xfrm>
-          <a:prstGeom prst="rect">
-            <a:avLst/>
-          </a:prstGeom>
-          <a:noFill/>
-          <a:ln>
-            <a:noFill/>
-          </a:ln>
-        </p:spPr>
-        <p:txBody>
-          <a:bodyPr spcFirstLastPara="1" wrap="square" lIns="91425" tIns="45700" rIns="91425" bIns="45700" anchor="t" anchorCtr="0">
-            <a:noAutofit/>
-          </a:bodyPr>
-          <a:lstStyle/>
-          <a:p>
-            <a:pPr marL="0" lvl="0" indent="0" algn="l" rtl="0">
-              <a:lnSpc>
-                <a:spcPct val="100000"/>
-              </a:lnSpc>
-              <a:spcBef>
-                <a:spcPts val="0"/>
-              </a:spcBef>
-              <a:spcAft>
-                <a:spcPts val="0"/>
-              </a:spcAft>
-              <a:buSzPts val="1400"/>
-              <a:buNone/>
-            </a:pPr>
-            <a:endParaRPr/>
-          </a:p>
-        </p:txBody>
-      </p:sp>
-      <p:sp>
-        <p:nvSpPr>
-          <p:cNvPr id="150" name="Google Shape;150;g38b39bbdc2a_0_61:notes"/>
-          <p:cNvSpPr txBox="1">
-            <a:spLocks noGrp="1"/>
-          </p:cNvSpPr>
-          <p:nvPr>
-            <p:ph type="sldNum" idx="12"/>
-          </p:nvPr>
-        </p:nvSpPr>
-        <p:spPr>
-          <a:xfrm>
-            <a:off x="3884613" y="8685213"/>
-            <a:ext cx="2971800" cy="458700"/>
-          </a:xfrm>
-          <a:prstGeom prst="rect">
-            <a:avLst/>
-          </a:prstGeom>
-          <a:noFill/>
-          <a:ln>
-            <a:noFill/>
-          </a:ln>
-        </p:spPr>
-        <p:txBody>
-          <a:bodyPr spcFirstLastPara="1" wrap="square" lIns="91425" tIns="45700" rIns="91425" bIns="45700" anchor="b" anchorCtr="0">
-            <a:noAutofit/>
-          </a:bodyPr>
-          <a:lstStyle/>
-          <a:p>
-            <a:pPr marL="0" lvl="0" indent="0" algn="r" rtl="0">
-              <a:lnSpc>
-                <a:spcPct val="100000"/>
-              </a:lnSpc>
-              <a:spcBef>
-                <a:spcPts val="0"/>
-              </a:spcBef>
-              <a:spcAft>
-                <a:spcPts val="0"/>
-              </a:spcAft>
-              <a:buSzPts val="1400"/>
-              <a:buNone/>
-            </a:pPr>
-            <a:fld id="{00000000-1234-1234-1234-123412341234}" type="slidenum">
-              <a:rPr lang="en-US"/>
-              <a:t>12</a:t>
             </a:fld>
             <a:endParaRPr/>
           </a:p>
@@ -5608,7 +5089,7 @@
                 </a:solidFill>
                 <a:latin typeface="Calibri"/>
               </a:rPr>
-              <a:t>Walk: vision → draft plan → owners → pipeline</a:t>
+              <a:t>Walk: process → pipeline → alignment</a:t>
             </a:r>
             <a:endParaRPr sz="2200" b="0" i="0" u="none" strike="noStrike" cap="none">
               <a:solidFill>
@@ -5910,1497 +5391,6 @@
 </p:sld>
 </file>
 
-<file path=ppt/slides/slide10.xml><?xml version="1.0" encoding="utf-8"?>
-<p:sld xmlns:a="http://schemas.openxmlformats.org/drawingml/2006/main" xmlns:r="http://schemas.openxmlformats.org/officeDocument/2006/relationships" xmlns:p="http://schemas.openxmlformats.org/presentationml/2006/main">
-  <p:cSld>
-    <p:bg>
-      <p:bgPr>
-        <a:solidFill>
-          <a:srgbClr val="FFFFFF"/>
-        </a:solidFill>
-        <a:effectLst/>
-      </p:bgPr>
-    </p:bg>
-    <p:spTree>
-      <p:nvGrpSpPr>
-        <p:cNvPr id="1" name="Shape 129"/>
-        <p:cNvGrpSpPr/>
-        <p:nvPr/>
-      </p:nvGrpSpPr>
-      <p:grpSpPr>
-        <a:xfrm>
-          <a:off x="0" y="0"/>
-          <a:ext cx="0" cy="0"/>
-          <a:chOff x="0" y="0"/>
-          <a:chExt cx="0" cy="0"/>
-        </a:xfrm>
-      </p:grpSpPr>
-      <p:sp>
-        <p:nvSpPr>
-          <p:cNvPr id="130" name="Google Shape;130;g38b39bbdc2a_0_41"/>
-          <p:cNvSpPr/>
-          <p:nvPr/>
-        </p:nvSpPr>
-        <p:spPr>
-          <a:xfrm>
-            <a:off x="411480" y="201168"/>
-            <a:ext cx="8321100" cy="594300"/>
-          </a:xfrm>
-          <a:prstGeom prst="rect">
-            <a:avLst/>
-          </a:prstGeom>
-          <a:noFill/>
-          <a:ln>
-            <a:noFill/>
-          </a:ln>
-        </p:spPr>
-        <p:txBody>
-          <a:bodyPr spcFirstLastPara="1" wrap="square" lIns="91425" tIns="45700" rIns="91425" bIns="45700" anchor="t" anchorCtr="0">
-            <a:noAutofit/>
-          </a:bodyPr>
-          <a:lstStyle/>
-          <a:p>
-            <a:pPr marL="0" marR="0" lvl="0" indent="0" algn="l" rtl="0">
-              <a:lnSpc>
-                <a:spcPct val="100000"/>
-              </a:lnSpc>
-              <a:spcBef>
-                <a:spcPts val="0"/>
-              </a:spcBef>
-              <a:spcAft>
-                <a:spcPts val="0"/>
-              </a:spcAft>
-              <a:buClr>
-                <a:srgbClr val="051830"/>
-              </a:buClr>
-              <a:buSzPts val="3000"/>
-              <a:buFont typeface="Calibri"/>
-              <a:buNone/>
-            </a:pPr>
-            <a:r>
-              <a:rPr lang="en-US" sz="2600" b="0" i="0" u="none" strike="noStrike" cap="none">
-                <a:solidFill>
-                  <a:srgbClr val="051830"/>
-                </a:solidFill>
-                <a:latin typeface="Calibri"/>
-                <a:ea typeface="Calibri"/>
-                <a:cs typeface="Calibri"/>
-                <a:sym typeface="Calibri"/>
-              </a:rPr>
-              <a:t>Explicit deferrals (do not merge)</a:t>
-            </a:r>
-            <a:endParaRPr sz="3000" b="0" i="0" u="none" strike="noStrike" cap="none">
-              <a:solidFill>
-                <a:schemeClr val="dk1"/>
-              </a:solidFill>
-              <a:latin typeface="Calibri"/>
-              <a:ea typeface="Calibri"/>
-              <a:cs typeface="Calibri"/>
-              <a:sym typeface="Calibri"/>
-            </a:endParaRPr>
-          </a:p>
-        </p:txBody>
-      </p:sp>
-      <p:sp>
-        <p:nvSpPr>
-          <p:cNvPr id="131" name="Google Shape;131;g38b39bbdc2a_0_41"/>
-          <p:cNvSpPr/>
-          <p:nvPr/>
-        </p:nvSpPr>
-        <p:spPr>
-          <a:xfrm>
-            <a:off x="0" y="4850892"/>
-            <a:ext cx="9144000" cy="18300"/>
-          </a:xfrm>
-          <a:prstGeom prst="rect">
-            <a:avLst/>
-          </a:prstGeom>
-          <a:solidFill>
-            <a:srgbClr val="C8A85A"/>
-          </a:solidFill>
-          <a:ln w="12700" cap="flat" cmpd="sng">
-            <a:solidFill>
-              <a:srgbClr val="C8A85A"/>
-            </a:solidFill>
-            <a:prstDash val="solid"/>
-            <a:round/>
-            <a:headEnd type="none" w="sm" len="sm"/>
-            <a:tailEnd type="none" w="sm" len="sm"/>
-          </a:ln>
-        </p:spPr>
-        <p:txBody>
-          <a:bodyPr spcFirstLastPara="1" wrap="square" lIns="91425" tIns="91425" rIns="91425" bIns="91425" anchor="ctr" anchorCtr="0">
-            <a:noAutofit/>
-          </a:bodyPr>
-          <a:lstStyle/>
-          <a:p>
-            <a:pPr marL="0" marR="0" lvl="0" indent="0" algn="l" rtl="0">
-              <a:lnSpc>
-                <a:spcPct val="100000"/>
-              </a:lnSpc>
-              <a:spcBef>
-                <a:spcPts val="0"/>
-              </a:spcBef>
-              <a:spcAft>
-                <a:spcPts val="0"/>
-              </a:spcAft>
-              <a:buClr>
-                <a:srgbClr val="000000"/>
-              </a:buClr>
-              <a:buSzPts val="1400"/>
-              <a:buFont typeface="Arial"/>
-              <a:buNone/>
-            </a:pPr>
-            <a:endParaRPr sz="1400" b="0" i="0" u="none" strike="noStrike" cap="none">
-              <a:solidFill>
-                <a:srgbClr val="000000"/>
-              </a:solidFill>
-              <a:latin typeface="Arial"/>
-              <a:ea typeface="Arial"/>
-              <a:cs typeface="Arial"/>
-              <a:sym typeface="Arial"/>
-            </a:endParaRPr>
-          </a:p>
-        </p:txBody>
-      </p:sp>
-      <p:sp>
-        <p:nvSpPr>
-          <p:cNvPr id="132" name="Google Shape;132;g38b39bbdc2a_0_41"/>
-          <p:cNvSpPr/>
-          <p:nvPr/>
-        </p:nvSpPr>
-        <p:spPr>
-          <a:xfrm>
-            <a:off x="0" y="4869180"/>
-            <a:ext cx="9144000" cy="274200"/>
-          </a:xfrm>
-          <a:prstGeom prst="rect">
-            <a:avLst/>
-          </a:prstGeom>
-          <a:solidFill>
-            <a:srgbClr val="F4F6FA"/>
-          </a:solidFill>
-          <a:ln w="12700" cap="flat" cmpd="sng">
-            <a:solidFill>
-              <a:srgbClr val="F4F6FA"/>
-            </a:solidFill>
-            <a:prstDash val="solid"/>
-            <a:round/>
-            <a:headEnd type="none" w="sm" len="sm"/>
-            <a:tailEnd type="none" w="sm" len="sm"/>
-          </a:ln>
-        </p:spPr>
-        <p:txBody>
-          <a:bodyPr spcFirstLastPara="1" wrap="square" lIns="91425" tIns="91425" rIns="91425" bIns="91425" anchor="ctr" anchorCtr="0">
-            <a:noAutofit/>
-          </a:bodyPr>
-          <a:lstStyle/>
-          <a:p>
-            <a:pPr marL="0" marR="0" lvl="0" indent="0" algn="l" rtl="0">
-              <a:lnSpc>
-                <a:spcPct val="100000"/>
-              </a:lnSpc>
-              <a:spcBef>
-                <a:spcPts val="0"/>
-              </a:spcBef>
-              <a:spcAft>
-                <a:spcPts val="0"/>
-              </a:spcAft>
-              <a:buClr>
-                <a:srgbClr val="000000"/>
-              </a:buClr>
-              <a:buSzPts val="1400"/>
-              <a:buFont typeface="Arial"/>
-              <a:buNone/>
-            </a:pPr>
-            <a:endParaRPr sz="1400" b="0" i="0" u="none" strike="noStrike" cap="none">
-              <a:solidFill>
-                <a:srgbClr val="000000"/>
-              </a:solidFill>
-              <a:latin typeface="Arial"/>
-              <a:ea typeface="Arial"/>
-              <a:cs typeface="Arial"/>
-              <a:sym typeface="Arial"/>
-            </a:endParaRPr>
-          </a:p>
-        </p:txBody>
-      </p:sp>
-      <p:sp>
-        <p:nvSpPr>
-          <p:cNvPr id="133" name="Google Shape;133;g38b39bbdc2a_0_41"/>
-          <p:cNvSpPr/>
-          <p:nvPr/>
-        </p:nvSpPr>
-        <p:spPr>
-          <a:xfrm>
-            <a:off x="274320" y="4887468"/>
-            <a:ext cx="7772400" cy="201300"/>
-          </a:xfrm>
-          <a:prstGeom prst="rect">
-            <a:avLst/>
-          </a:prstGeom>
-          <a:noFill/>
-          <a:ln>
-            <a:noFill/>
-          </a:ln>
-        </p:spPr>
-        <p:txBody>
-          <a:bodyPr spcFirstLastPara="1" wrap="square" lIns="91425" tIns="45700" rIns="91425" bIns="45700" anchor="ctr" anchorCtr="0">
-            <a:noAutofit/>
-          </a:bodyPr>
-          <a:lstStyle/>
-          <a:p>
-            <a:pPr marL="0" marR="0" lvl="0" indent="0" algn="ctr" rtl="0">
-              <a:lnSpc>
-                <a:spcPct val="100000"/>
-              </a:lnSpc>
-              <a:spcBef>
-                <a:spcPts val="0"/>
-              </a:spcBef>
-              <a:spcAft>
-                <a:spcPts val="0"/>
-              </a:spcAft>
-              <a:buClr>
-                <a:srgbClr val="888888"/>
-              </a:buClr>
-              <a:buSzPts val="700"/>
-              <a:buFont typeface="Calibri"/>
-              <a:buNone/>
-            </a:pPr>
-            <a:r>
-              <a:rPr lang="en-US" sz="700" b="0" i="0" u="none" strike="noStrike" cap="none">
-                <a:solidFill>
-                  <a:srgbClr val="888888"/>
-                </a:solidFill>
-                <a:latin typeface="Calibri"/>
-                <a:ea typeface="Calibri"/>
-                <a:cs typeface="Calibri"/>
-                <a:sym typeface="Calibri"/>
-              </a:rPr>
-              <a:t>© 2026 Upscale AI – Proprietary and Confidential – Do Not Reproduce or Duplicate</a:t>
-            </a:r>
-            <a:endParaRPr sz="700" b="0" i="0" u="none" strike="noStrike" cap="none">
-              <a:solidFill>
-                <a:schemeClr val="dk1"/>
-              </a:solidFill>
-              <a:latin typeface="Calibri"/>
-              <a:ea typeface="Calibri"/>
-              <a:cs typeface="Calibri"/>
-              <a:sym typeface="Calibri"/>
-            </a:endParaRPr>
-          </a:p>
-        </p:txBody>
-      </p:sp>
-      <p:sp>
-        <p:nvSpPr>
-          <p:cNvPr id="134" name="Google Shape;134;g38b39bbdc2a_0_41"/>
-          <p:cNvSpPr/>
-          <p:nvPr/>
-        </p:nvSpPr>
-        <p:spPr>
-          <a:xfrm>
-            <a:off x="7863840" y="4887468"/>
-            <a:ext cx="1097400" cy="201300"/>
-          </a:xfrm>
-          <a:prstGeom prst="rect">
-            <a:avLst/>
-          </a:prstGeom>
-          <a:noFill/>
-          <a:ln>
-            <a:noFill/>
-          </a:ln>
-        </p:spPr>
-        <p:txBody>
-          <a:bodyPr spcFirstLastPara="1" wrap="square" lIns="91425" tIns="45700" rIns="91425" bIns="45700" anchor="ctr" anchorCtr="0">
-            <a:noAutofit/>
-          </a:bodyPr>
-          <a:lstStyle/>
-          <a:p>
-            <a:pPr marL="0" marR="0" lvl="0" indent="0" algn="r" rtl="0">
-              <a:lnSpc>
-                <a:spcPct val="100000"/>
-              </a:lnSpc>
-              <a:spcBef>
-                <a:spcPts val="0"/>
-              </a:spcBef>
-              <a:spcAft>
-                <a:spcPts val="0"/>
-              </a:spcAft>
-              <a:buClr>
-                <a:srgbClr val="FFE19E"/>
-              </a:buClr>
-              <a:buSzPts val="800"/>
-              <a:buFont typeface="Calibri"/>
-              <a:buNone/>
-            </a:pPr>
-            <a:r>
-              <a:rPr lang="en-US" sz="800" b="1" i="0" u="none" strike="noStrike" cap="none">
-                <a:solidFill>
-                  <a:srgbClr val="FFE19E"/>
-                </a:solidFill>
-                <a:latin typeface="Calibri"/>
-                <a:ea typeface="Calibri"/>
-                <a:cs typeface="Calibri"/>
-                <a:sym typeface="Calibri"/>
-              </a:rPr>
-              <a:t>UP </a:t>
-            </a:r>
-            <a:r>
-              <a:rPr lang="en-US" sz="900" b="1" i="0" u="none" strike="noStrike" cap="none">
-                <a:solidFill>
-                  <a:srgbClr val="FFE19E"/>
-                </a:solidFill>
-                <a:latin typeface="Calibri"/>
-                <a:ea typeface="Calibri"/>
-                <a:cs typeface="Calibri"/>
-                <a:sym typeface="Calibri"/>
-              </a:rPr>
-              <a:t>upscale </a:t>
-            </a:r>
-            <a:r>
-              <a:rPr lang="en-US" sz="900" b="0" i="0" u="none" strike="noStrike" cap="none">
-                <a:solidFill>
-                  <a:srgbClr val="FFE19E"/>
-                </a:solidFill>
-                <a:latin typeface="Calibri"/>
-                <a:ea typeface="Calibri"/>
-                <a:cs typeface="Calibri"/>
-                <a:sym typeface="Calibri"/>
-              </a:rPr>
-              <a:t>ai</a:t>
-            </a:r>
-            <a:endParaRPr sz="800" b="0" i="0" u="none" strike="noStrike" cap="none">
-              <a:solidFill>
-                <a:schemeClr val="dk1"/>
-              </a:solidFill>
-              <a:latin typeface="Calibri"/>
-              <a:ea typeface="Calibri"/>
-              <a:cs typeface="Calibri"/>
-              <a:sym typeface="Calibri"/>
-            </a:endParaRPr>
-          </a:p>
-        </p:txBody>
-      </p:sp>
-      <p:sp>
-        <p:nvSpPr>
-          <p:cNvPr id="135" name="Google Shape;135;g38b39bbdc2a_0_41"/>
-          <p:cNvSpPr txBox="1"/>
-          <p:nvPr/>
-        </p:nvSpPr>
-        <p:spPr>
-          <a:xfrm>
-            <a:off x="411475" y="795525"/>
-            <a:ext cx="8321100" cy="3032400"/>
-          </a:xfrm>
-          <a:prstGeom prst="rect">
-            <a:avLst/>
-          </a:prstGeom>
-          <a:noFill/>
-          <a:ln>
-            <a:noFill/>
-          </a:ln>
-        </p:spPr>
-        <p:txBody>
-          <a:bodyPr spcFirstLastPara="1" wrap="square" lIns="91425" tIns="91425" rIns="91425" bIns="91425" anchor="t" anchorCtr="0">
-            <a:spAutoFit/>
-          </a:bodyPr>
-          <a:lstStyle/>
-          <a:p>
-            <a:pPr marL="457200" marR="0" indent="-307975" algn="l" rtl="0">
-              <a:lnSpc>
-                <a:spcPct val="115000"/>
-              </a:lnSpc>
-              <a:spcBef>
-                <a:spcPts val="1200"/>
-              </a:spcBef>
-              <a:spcAft>
-                <a:spcPts val="0"/>
-              </a:spcAft>
-              <a:buClr>
-                <a:schemeClr val="dk1"/>
-              </a:buClr>
-              <a:buSzPts val="1250"/>
-              <a:buFont typeface="Arial"/>
-              <a:buChar char="●"/>
-            </a:pPr>
-            <a:r>
-              <a:rPr sz="1300">
-                <a:solidFill>
-                  <a:srgbClr val="333333"/>
-                </a:solidFill>
-                <a:latin typeface="Arial"/>
-              </a:rPr>
-              <a:t>Beat 5 · ~1 min</a:t>
-            </a:r>
-            <a:endParaRPr sz="1250" b="0" i="0" u="none" strike="noStrike" cap="none">
-              <a:solidFill>
-                <a:schemeClr val="dk1"/>
-              </a:solidFill>
-              <a:latin typeface="Arial"/>
-              <a:ea typeface="Arial"/>
-              <a:cs typeface="Arial"/>
-              <a:sym typeface="Arial"/>
-            </a:endParaRPr>
-          </a:p>
-          <a:p>
-            <a:pPr/>
-            <a:r>
-              <a:rPr sz="1300">
-                <a:solidFill>
-                  <a:srgbClr val="333333"/>
-                </a:solidFill>
-                <a:latin typeface="Arial"/>
-              </a:rPr>
-              <a:t>Out of this walk — weekly sync, not merged plans.</a:t>
-            </a:r>
-          </a:p>
-          <a:p>
-            <a:pPr/>
-          </a:p>
-          <a:p>
-            <a:pPr/>
-            <a:r>
-              <a:rPr sz="1300">
-                <a:solidFill>
-                  <a:srgbClr val="333333"/>
-                </a:solidFill>
-                <a:latin typeface="Arial"/>
-              </a:rPr>
-              <a:t>Rupa SDK/SAI/datapath layout — related, different plan; weekly sync</a:t>
-            </a:r>
-          </a:p>
-          <a:p>
-            <a:pPr/>
-            <a:r>
-              <a:rPr sz="1300">
-                <a:solidFill>
-                  <a:srgbClr val="333333"/>
-                </a:solidFill>
-                <a:latin typeface="Arial"/>
-              </a:rPr>
-              <a:t>OCP ESUN: coordinate with Rupa before vendor calls; company position through Gururaj</a:t>
-            </a:r>
-          </a:p>
-          <a:p>
-            <a:pPr/>
-            <a:r>
-              <a:rPr sz="1300">
-                <a:solidFill>
-                  <a:srgbClr val="333333"/>
-                </a:solidFill>
-                <a:latin typeface="Arial"/>
-              </a:rPr>
-              <a:t>Prabu execution mesh / bs-2 — round 2 unless you redirect</a:t>
-            </a:r>
-          </a:p>
-        </p:txBody>
-      </p:sp>
-    </p:spTree>
-  </p:cSld>
-  <p:clrMapOvr>
-    <a:masterClrMapping/>
-  </p:clrMapOvr>
-</p:sld>
-</file>
-
-<file path=ppt/slides/slide11.xml><?xml version="1.0" encoding="utf-8"?>
-<p:sld xmlns:a="http://schemas.openxmlformats.org/drawingml/2006/main" xmlns:r="http://schemas.openxmlformats.org/officeDocument/2006/relationships" xmlns:p="http://schemas.openxmlformats.org/presentationml/2006/main">
-  <p:cSld>
-    <p:bg>
-      <p:bgPr>
-        <a:solidFill>
-          <a:srgbClr val="FFFFFF"/>
-        </a:solidFill>
-        <a:effectLst/>
-      </p:bgPr>
-    </p:bg>
-    <p:spTree>
-      <p:nvGrpSpPr>
-        <p:cNvPr id="1" name="Shape 140"/>
-        <p:cNvGrpSpPr/>
-        <p:nvPr/>
-      </p:nvGrpSpPr>
-      <p:grpSpPr>
-        <a:xfrm>
-          <a:off x="0" y="0"/>
-          <a:ext cx="0" cy="0"/>
-          <a:chOff x="0" y="0"/>
-          <a:chExt cx="0" cy="0"/>
-        </a:xfrm>
-      </p:grpSpPr>
-      <p:sp>
-        <p:nvSpPr>
-          <p:cNvPr id="141" name="Google Shape;141;g38b39bbdc2a_0_51"/>
-          <p:cNvSpPr/>
-          <p:nvPr/>
-        </p:nvSpPr>
-        <p:spPr>
-          <a:xfrm>
-            <a:off x="411480" y="201168"/>
-            <a:ext cx="8321100" cy="594300"/>
-          </a:xfrm>
-          <a:prstGeom prst="rect">
-            <a:avLst/>
-          </a:prstGeom>
-          <a:noFill/>
-          <a:ln>
-            <a:noFill/>
-          </a:ln>
-        </p:spPr>
-        <p:txBody>
-          <a:bodyPr spcFirstLastPara="1" wrap="square" lIns="91425" tIns="45700" rIns="91425" bIns="45700" anchor="t" anchorCtr="0">
-            <a:noAutofit/>
-          </a:bodyPr>
-          <a:lstStyle/>
-          <a:p>
-            <a:pPr marL="0" marR="0" lvl="0" indent="0" algn="l" rtl="0">
-              <a:lnSpc>
-                <a:spcPct val="100000"/>
-              </a:lnSpc>
-              <a:spcBef>
-                <a:spcPts val="0"/>
-              </a:spcBef>
-              <a:spcAft>
-                <a:spcPts val="0"/>
-              </a:spcAft>
-              <a:buClr>
-                <a:srgbClr val="051830"/>
-              </a:buClr>
-              <a:buSzPts val="3000"/>
-              <a:buFont typeface="Calibri"/>
-              <a:buNone/>
-            </a:pPr>
-            <a:r>
-              <a:rPr lang="en-US" sz="2600" b="0" i="0" u="none" strike="noStrike" cap="none">
-                <a:solidFill>
-                  <a:srgbClr val="051830"/>
-                </a:solidFill>
-                <a:latin typeface="Calibri"/>
-                <a:ea typeface="Calibri"/>
-                <a:cs typeface="Calibri"/>
-                <a:sym typeface="Calibri"/>
-              </a:rPr>
-              <a:t>If you want me to drive — next beats</a:t>
-            </a:r>
-            <a:endParaRPr sz="3000" b="0" i="0" u="none" strike="noStrike" cap="none">
-              <a:solidFill>
-                <a:schemeClr val="dk1"/>
-              </a:solidFill>
-              <a:latin typeface="Calibri"/>
-              <a:ea typeface="Calibri"/>
-              <a:cs typeface="Calibri"/>
-              <a:sym typeface="Calibri"/>
-            </a:endParaRPr>
-          </a:p>
-        </p:txBody>
-      </p:sp>
-      <p:sp>
-        <p:nvSpPr>
-          <p:cNvPr id="142" name="Google Shape;142;g38b39bbdc2a_0_51"/>
-          <p:cNvSpPr/>
-          <p:nvPr/>
-        </p:nvSpPr>
-        <p:spPr>
-          <a:xfrm>
-            <a:off x="0" y="4850892"/>
-            <a:ext cx="9144000" cy="18300"/>
-          </a:xfrm>
-          <a:prstGeom prst="rect">
-            <a:avLst/>
-          </a:prstGeom>
-          <a:solidFill>
-            <a:srgbClr val="C8A85A"/>
-          </a:solidFill>
-          <a:ln w="12700" cap="flat" cmpd="sng">
-            <a:solidFill>
-              <a:srgbClr val="C8A85A"/>
-            </a:solidFill>
-            <a:prstDash val="solid"/>
-            <a:round/>
-            <a:headEnd type="none" w="sm" len="sm"/>
-            <a:tailEnd type="none" w="sm" len="sm"/>
-          </a:ln>
-        </p:spPr>
-        <p:txBody>
-          <a:bodyPr spcFirstLastPara="1" wrap="square" lIns="91425" tIns="91425" rIns="91425" bIns="91425" anchor="ctr" anchorCtr="0">
-            <a:noAutofit/>
-          </a:bodyPr>
-          <a:lstStyle/>
-          <a:p>
-            <a:pPr marL="0" marR="0" lvl="0" indent="0" algn="l" rtl="0">
-              <a:lnSpc>
-                <a:spcPct val="100000"/>
-              </a:lnSpc>
-              <a:spcBef>
-                <a:spcPts val="0"/>
-              </a:spcBef>
-              <a:spcAft>
-                <a:spcPts val="0"/>
-              </a:spcAft>
-              <a:buClr>
-                <a:srgbClr val="000000"/>
-              </a:buClr>
-              <a:buSzPts val="1400"/>
-              <a:buFont typeface="Arial"/>
-              <a:buNone/>
-            </a:pPr>
-            <a:endParaRPr sz="1400" b="0" i="0" u="none" strike="noStrike" cap="none">
-              <a:solidFill>
-                <a:srgbClr val="000000"/>
-              </a:solidFill>
-              <a:latin typeface="Arial"/>
-              <a:ea typeface="Arial"/>
-              <a:cs typeface="Arial"/>
-              <a:sym typeface="Arial"/>
-            </a:endParaRPr>
-          </a:p>
-        </p:txBody>
-      </p:sp>
-      <p:sp>
-        <p:nvSpPr>
-          <p:cNvPr id="143" name="Google Shape;143;g38b39bbdc2a_0_51"/>
-          <p:cNvSpPr/>
-          <p:nvPr/>
-        </p:nvSpPr>
-        <p:spPr>
-          <a:xfrm>
-            <a:off x="0" y="4869180"/>
-            <a:ext cx="9144000" cy="274200"/>
-          </a:xfrm>
-          <a:prstGeom prst="rect">
-            <a:avLst/>
-          </a:prstGeom>
-          <a:solidFill>
-            <a:srgbClr val="F4F6FA"/>
-          </a:solidFill>
-          <a:ln w="12700" cap="flat" cmpd="sng">
-            <a:solidFill>
-              <a:srgbClr val="F4F6FA"/>
-            </a:solidFill>
-            <a:prstDash val="solid"/>
-            <a:round/>
-            <a:headEnd type="none" w="sm" len="sm"/>
-            <a:tailEnd type="none" w="sm" len="sm"/>
-          </a:ln>
-        </p:spPr>
-        <p:txBody>
-          <a:bodyPr spcFirstLastPara="1" wrap="square" lIns="91425" tIns="91425" rIns="91425" bIns="91425" anchor="ctr" anchorCtr="0">
-            <a:noAutofit/>
-          </a:bodyPr>
-          <a:lstStyle/>
-          <a:p>
-            <a:pPr marL="0" marR="0" lvl="0" indent="0" algn="l" rtl="0">
-              <a:lnSpc>
-                <a:spcPct val="100000"/>
-              </a:lnSpc>
-              <a:spcBef>
-                <a:spcPts val="0"/>
-              </a:spcBef>
-              <a:spcAft>
-                <a:spcPts val="0"/>
-              </a:spcAft>
-              <a:buClr>
-                <a:srgbClr val="000000"/>
-              </a:buClr>
-              <a:buSzPts val="1400"/>
-              <a:buFont typeface="Arial"/>
-              <a:buNone/>
-            </a:pPr>
-            <a:endParaRPr sz="1400" b="0" i="0" u="none" strike="noStrike" cap="none">
-              <a:solidFill>
-                <a:srgbClr val="000000"/>
-              </a:solidFill>
-              <a:latin typeface="Arial"/>
-              <a:ea typeface="Arial"/>
-              <a:cs typeface="Arial"/>
-              <a:sym typeface="Arial"/>
-            </a:endParaRPr>
-          </a:p>
-        </p:txBody>
-      </p:sp>
-      <p:sp>
-        <p:nvSpPr>
-          <p:cNvPr id="144" name="Google Shape;144;g38b39bbdc2a_0_51"/>
-          <p:cNvSpPr/>
-          <p:nvPr/>
-        </p:nvSpPr>
-        <p:spPr>
-          <a:xfrm>
-            <a:off x="274320" y="4887468"/>
-            <a:ext cx="7772400" cy="201300"/>
-          </a:xfrm>
-          <a:prstGeom prst="rect">
-            <a:avLst/>
-          </a:prstGeom>
-          <a:noFill/>
-          <a:ln>
-            <a:noFill/>
-          </a:ln>
-        </p:spPr>
-        <p:txBody>
-          <a:bodyPr spcFirstLastPara="1" wrap="square" lIns="91425" tIns="45700" rIns="91425" bIns="45700" anchor="ctr" anchorCtr="0">
-            <a:noAutofit/>
-          </a:bodyPr>
-          <a:lstStyle/>
-          <a:p>
-            <a:pPr marL="0" marR="0" lvl="0" indent="0" algn="ctr" rtl="0">
-              <a:lnSpc>
-                <a:spcPct val="100000"/>
-              </a:lnSpc>
-              <a:spcBef>
-                <a:spcPts val="0"/>
-              </a:spcBef>
-              <a:spcAft>
-                <a:spcPts val="0"/>
-              </a:spcAft>
-              <a:buClr>
-                <a:srgbClr val="888888"/>
-              </a:buClr>
-              <a:buSzPts val="700"/>
-              <a:buFont typeface="Calibri"/>
-              <a:buNone/>
-            </a:pPr>
-            <a:r>
-              <a:rPr lang="en-US" sz="700" b="0" i="0" u="none" strike="noStrike" cap="none">
-                <a:solidFill>
-                  <a:srgbClr val="888888"/>
-                </a:solidFill>
-                <a:latin typeface="Calibri"/>
-                <a:ea typeface="Calibri"/>
-                <a:cs typeface="Calibri"/>
-                <a:sym typeface="Calibri"/>
-              </a:rPr>
-              <a:t>© 2026 Upscale AI – Proprietary and Confidential – Do Not Reproduce or Duplicate</a:t>
-            </a:r>
-            <a:endParaRPr sz="700" b="0" i="0" u="none" strike="noStrike" cap="none">
-              <a:solidFill>
-                <a:schemeClr val="dk1"/>
-              </a:solidFill>
-              <a:latin typeface="Calibri"/>
-              <a:ea typeface="Calibri"/>
-              <a:cs typeface="Calibri"/>
-              <a:sym typeface="Calibri"/>
-            </a:endParaRPr>
-          </a:p>
-        </p:txBody>
-      </p:sp>
-      <p:sp>
-        <p:nvSpPr>
-          <p:cNvPr id="145" name="Google Shape;145;g38b39bbdc2a_0_51"/>
-          <p:cNvSpPr/>
-          <p:nvPr/>
-        </p:nvSpPr>
-        <p:spPr>
-          <a:xfrm>
-            <a:off x="7863840" y="4887468"/>
-            <a:ext cx="1097400" cy="201300"/>
-          </a:xfrm>
-          <a:prstGeom prst="rect">
-            <a:avLst/>
-          </a:prstGeom>
-          <a:noFill/>
-          <a:ln>
-            <a:noFill/>
-          </a:ln>
-        </p:spPr>
-        <p:txBody>
-          <a:bodyPr spcFirstLastPara="1" wrap="square" lIns="91425" tIns="45700" rIns="91425" bIns="45700" anchor="ctr" anchorCtr="0">
-            <a:noAutofit/>
-          </a:bodyPr>
-          <a:lstStyle/>
-          <a:p>
-            <a:pPr marL="0" marR="0" lvl="0" indent="0" algn="r" rtl="0">
-              <a:lnSpc>
-                <a:spcPct val="100000"/>
-              </a:lnSpc>
-              <a:spcBef>
-                <a:spcPts val="0"/>
-              </a:spcBef>
-              <a:spcAft>
-                <a:spcPts val="0"/>
-              </a:spcAft>
-              <a:buClr>
-                <a:srgbClr val="FFE19E"/>
-              </a:buClr>
-              <a:buSzPts val="800"/>
-              <a:buFont typeface="Calibri"/>
-              <a:buNone/>
-            </a:pPr>
-            <a:r>
-              <a:rPr lang="en-US" sz="800" b="1" i="0" u="none" strike="noStrike" cap="none">
-                <a:solidFill>
-                  <a:srgbClr val="FFE19E"/>
-                </a:solidFill>
-                <a:latin typeface="Calibri"/>
-                <a:ea typeface="Calibri"/>
-                <a:cs typeface="Calibri"/>
-                <a:sym typeface="Calibri"/>
-              </a:rPr>
-              <a:t>UP </a:t>
-            </a:r>
-            <a:r>
-              <a:rPr lang="en-US" sz="900" b="1" i="0" u="none" strike="noStrike" cap="none">
-                <a:solidFill>
-                  <a:srgbClr val="FFE19E"/>
-                </a:solidFill>
-                <a:latin typeface="Calibri"/>
-                <a:ea typeface="Calibri"/>
-                <a:cs typeface="Calibri"/>
-                <a:sym typeface="Calibri"/>
-              </a:rPr>
-              <a:t>upscale </a:t>
-            </a:r>
-            <a:r>
-              <a:rPr lang="en-US" sz="900" b="0" i="0" u="none" strike="noStrike" cap="none">
-                <a:solidFill>
-                  <a:srgbClr val="FFE19E"/>
-                </a:solidFill>
-                <a:latin typeface="Calibri"/>
-                <a:ea typeface="Calibri"/>
-                <a:cs typeface="Calibri"/>
-                <a:sym typeface="Calibri"/>
-              </a:rPr>
-              <a:t>ai</a:t>
-            </a:r>
-            <a:endParaRPr sz="800" b="0" i="0" u="none" strike="noStrike" cap="none">
-              <a:solidFill>
-                <a:schemeClr val="dk1"/>
-              </a:solidFill>
-              <a:latin typeface="Calibri"/>
-              <a:ea typeface="Calibri"/>
-              <a:cs typeface="Calibri"/>
-              <a:sym typeface="Calibri"/>
-            </a:endParaRPr>
-          </a:p>
-        </p:txBody>
-      </p:sp>
-      <p:sp>
-        <p:nvSpPr>
-          <p:cNvPr id="146" name="Google Shape;146;g38b39bbdc2a_0_51"/>
-          <p:cNvSpPr txBox="1"/>
-          <p:nvPr/>
-        </p:nvSpPr>
-        <p:spPr>
-          <a:xfrm>
-            <a:off x="411475" y="795525"/>
-            <a:ext cx="8321100" cy="1926000"/>
-          </a:xfrm>
-          <a:prstGeom prst="rect">
-            <a:avLst/>
-          </a:prstGeom>
-          <a:noFill/>
-          <a:ln>
-            <a:noFill/>
-          </a:ln>
-        </p:spPr>
-        <p:txBody>
-          <a:bodyPr spcFirstLastPara="1" wrap="square" lIns="91425" tIns="91425" rIns="91425" bIns="91425" anchor="t" anchorCtr="0">
-            <a:spAutoFit/>
-          </a:bodyPr>
-          <a:lstStyle/>
-          <a:p>
-            <a:pPr marL="457200" marR="0" indent="-307975" algn="l" rtl="0">
-              <a:lnSpc>
-                <a:spcPct val="115000"/>
-              </a:lnSpc>
-              <a:spcBef>
-                <a:spcPts val="1200"/>
-              </a:spcBef>
-              <a:spcAft>
-                <a:spcPts val="0"/>
-              </a:spcAft>
-              <a:buClr>
-                <a:schemeClr val="dk1"/>
-              </a:buClr>
-              <a:buSzPts val="1250"/>
-              <a:buFont typeface="Arial"/>
-              <a:buChar char="●"/>
-            </a:pPr>
-            <a:r>
-              <a:rPr sz="1300">
-                <a:solidFill>
-                  <a:srgbClr val="333333"/>
-                </a:solidFill>
-                <a:latin typeface="Arial"/>
-              </a:rPr>
-              <a:t>Beat 6 · after mandate</a:t>
-            </a:r>
-            <a:endParaRPr sz="1250" b="0" i="0" u="none" strike="noStrike" cap="none">
-              <a:solidFill>
-                <a:schemeClr val="dk1"/>
-              </a:solidFill>
-              <a:latin typeface="Arial"/>
-              <a:ea typeface="Arial"/>
-              <a:cs typeface="Arial"/>
-              <a:sym typeface="Arial"/>
-            </a:endParaRPr>
-          </a:p>
-          <a:p>
-            <a:pPr/>
-            <a:r>
-              <a:rPr sz="1300">
-                <a:solidFill>
-                  <a:srgbClr val="333333"/>
-                </a:solidFill>
-                <a:latin typeface="Arial"/>
-              </a:rPr>
-              <a:t>Offer only if asked — who must be in the room.</a:t>
-            </a:r>
-          </a:p>
-          <a:p>
-            <a:pPr/>
-          </a:p>
-          <a:p>
-            <a:pPr/>
-            <a:r>
-              <a:rPr sz="1300">
-                <a:solidFill>
-                  <a:srgbClr val="333333"/>
-                </a:solidFill>
-                <a:latin typeface="Arial"/>
-              </a:rPr>
-              <a:t>Expand QoS buffer carving arch: swimlanes, DRI depth, integrated AV / C-model / datapath / SDK / SAI validation</a:t>
-            </a:r>
-          </a:p>
-          <a:p>
-            <a:pPr/>
-            <a:r>
-              <a:rPr sz="1300">
-                <a:solidFill>
-                  <a:srgbClr val="333333"/>
-                </a:solidFill>
-                <a:latin typeface="Arial"/>
-              </a:rPr>
-              <a:t>QoS RM HWv1 scope with HW datapath DRI (Rupa lane) — gates as we agree</a:t>
-            </a:r>
-          </a:p>
-          <a:p>
-            <a:pPr/>
-            <a:r>
-              <a:rPr sz="1300">
-                <a:solidFill>
-                  <a:srgbClr val="333333"/>
-                </a:solidFill>
-                <a:latin typeface="Arial"/>
-              </a:rPr>
-              <a:t>Cadence: Shafi, Tippanna, Rupa, Prasun — if Gururaj redirects drive to me</a:t>
-            </a:r>
-          </a:p>
-          <a:p>
-            <a:pPr/>
-            <a:r>
-              <a:rPr sz="1300">
-                <a:solidFill>
-                  <a:srgbClr val="333333"/>
-                </a:solidFill>
-                <a:latin typeface="Arial"/>
-              </a:rPr>
-              <a:t>Room list — offer here if you ask (not on qos-architecture slides)</a:t>
-            </a:r>
-          </a:p>
-        </p:txBody>
-      </p:sp>
-    </p:spTree>
-  </p:cSld>
-  <p:clrMapOvr>
-    <a:masterClrMapping/>
-  </p:clrMapOvr>
-</p:sld>
-</file>
-
-<file path=ppt/slides/slide12.xml><?xml version="1.0" encoding="utf-8"?>
-<p:sld xmlns:a="http://schemas.openxmlformats.org/drawingml/2006/main" xmlns:r="http://schemas.openxmlformats.org/officeDocument/2006/relationships" xmlns:p="http://schemas.openxmlformats.org/presentationml/2006/main">
-  <p:cSld>
-    <p:bg>
-      <p:bgPr>
-        <a:solidFill>
-          <a:srgbClr val="FFFFFF"/>
-        </a:solidFill>
-        <a:effectLst/>
-      </p:bgPr>
-    </p:bg>
-    <p:spTree>
-      <p:nvGrpSpPr>
-        <p:cNvPr id="1" name="Shape 151"/>
-        <p:cNvGrpSpPr/>
-        <p:nvPr/>
-      </p:nvGrpSpPr>
-      <p:grpSpPr>
-        <a:xfrm>
-          <a:off x="0" y="0"/>
-          <a:ext cx="0" cy="0"/>
-          <a:chOff x="0" y="0"/>
-          <a:chExt cx="0" cy="0"/>
-        </a:xfrm>
-      </p:grpSpPr>
-      <p:sp>
-        <p:nvSpPr>
-          <p:cNvPr id="152" name="Google Shape;152;g38b39bbdc2a_0_61"/>
-          <p:cNvSpPr/>
-          <p:nvPr/>
-        </p:nvSpPr>
-        <p:spPr>
-          <a:xfrm>
-            <a:off x="411480" y="201168"/>
-            <a:ext cx="8321100" cy="594300"/>
-          </a:xfrm>
-          <a:prstGeom prst="rect">
-            <a:avLst/>
-          </a:prstGeom>
-          <a:noFill/>
-          <a:ln>
-            <a:noFill/>
-          </a:ln>
-        </p:spPr>
-        <p:txBody>
-          <a:bodyPr spcFirstLastPara="1" wrap="square" lIns="91425" tIns="45700" rIns="91425" bIns="45700" anchor="t" anchorCtr="0">
-            <a:noAutofit/>
-          </a:bodyPr>
-          <a:lstStyle/>
-          <a:p>
-            <a:pPr marL="0" marR="0" lvl="0" indent="0" algn="l" rtl="0">
-              <a:lnSpc>
-                <a:spcPct val="100000"/>
-              </a:lnSpc>
-              <a:spcBef>
-                <a:spcPts val="0"/>
-              </a:spcBef>
-              <a:spcAft>
-                <a:spcPts val="0"/>
-              </a:spcAft>
-              <a:buClr>
-                <a:srgbClr val="051830"/>
-              </a:buClr>
-              <a:buSzPts val="3000"/>
-              <a:buFont typeface="Calibri"/>
-              <a:buNone/>
-            </a:pPr>
-            <a:r>
-              <a:rPr lang="en-US" sz="2600" b="0" i="0" u="none" strike="noStrike" cap="none">
-                <a:solidFill>
-                  <a:srgbClr val="051830"/>
-                </a:solidFill>
-                <a:latin typeface="Calibri"/>
-                <a:ea typeface="Calibri"/>
-                <a:cs typeface="Calibri"/>
-                <a:sym typeface="Calibri"/>
-              </a:rPr>
-              <a:t>What this walk is not</a:t>
-            </a:r>
-            <a:endParaRPr sz="3000" b="0" i="0" u="none" strike="noStrike" cap="none">
-              <a:solidFill>
-                <a:schemeClr val="dk1"/>
-              </a:solidFill>
-              <a:latin typeface="Calibri"/>
-              <a:ea typeface="Calibri"/>
-              <a:cs typeface="Calibri"/>
-              <a:sym typeface="Calibri"/>
-            </a:endParaRPr>
-          </a:p>
-        </p:txBody>
-      </p:sp>
-      <p:sp>
-        <p:nvSpPr>
-          <p:cNvPr id="153" name="Google Shape;153;g38b39bbdc2a_0_61"/>
-          <p:cNvSpPr/>
-          <p:nvPr/>
-        </p:nvSpPr>
-        <p:spPr>
-          <a:xfrm>
-            <a:off x="0" y="4850892"/>
-            <a:ext cx="9144000" cy="18300"/>
-          </a:xfrm>
-          <a:prstGeom prst="rect">
-            <a:avLst/>
-          </a:prstGeom>
-          <a:solidFill>
-            <a:srgbClr val="C8A85A"/>
-          </a:solidFill>
-          <a:ln w="12700" cap="flat" cmpd="sng">
-            <a:solidFill>
-              <a:srgbClr val="C8A85A"/>
-            </a:solidFill>
-            <a:prstDash val="solid"/>
-            <a:round/>
-            <a:headEnd type="none" w="sm" len="sm"/>
-            <a:tailEnd type="none" w="sm" len="sm"/>
-          </a:ln>
-        </p:spPr>
-        <p:txBody>
-          <a:bodyPr spcFirstLastPara="1" wrap="square" lIns="91425" tIns="91425" rIns="91425" bIns="91425" anchor="ctr" anchorCtr="0">
-            <a:noAutofit/>
-          </a:bodyPr>
-          <a:lstStyle/>
-          <a:p>
-            <a:pPr marL="0" marR="0" lvl="0" indent="0" algn="l" rtl="0">
-              <a:lnSpc>
-                <a:spcPct val="100000"/>
-              </a:lnSpc>
-              <a:spcBef>
-                <a:spcPts val="0"/>
-              </a:spcBef>
-              <a:spcAft>
-                <a:spcPts val="0"/>
-              </a:spcAft>
-              <a:buClr>
-                <a:srgbClr val="000000"/>
-              </a:buClr>
-              <a:buSzPts val="1400"/>
-              <a:buFont typeface="Arial"/>
-              <a:buNone/>
-            </a:pPr>
-            <a:endParaRPr sz="1400" b="0" i="0" u="none" strike="noStrike" cap="none">
-              <a:solidFill>
-                <a:srgbClr val="000000"/>
-              </a:solidFill>
-              <a:latin typeface="Arial"/>
-              <a:ea typeface="Arial"/>
-              <a:cs typeface="Arial"/>
-              <a:sym typeface="Arial"/>
-            </a:endParaRPr>
-          </a:p>
-        </p:txBody>
-      </p:sp>
-      <p:sp>
-        <p:nvSpPr>
-          <p:cNvPr id="154" name="Google Shape;154;g38b39bbdc2a_0_61"/>
-          <p:cNvSpPr/>
-          <p:nvPr/>
-        </p:nvSpPr>
-        <p:spPr>
-          <a:xfrm>
-            <a:off x="0" y="4869180"/>
-            <a:ext cx="9144000" cy="274200"/>
-          </a:xfrm>
-          <a:prstGeom prst="rect">
-            <a:avLst/>
-          </a:prstGeom>
-          <a:solidFill>
-            <a:srgbClr val="F4F6FA"/>
-          </a:solidFill>
-          <a:ln w="12700" cap="flat" cmpd="sng">
-            <a:solidFill>
-              <a:srgbClr val="F4F6FA"/>
-            </a:solidFill>
-            <a:prstDash val="solid"/>
-            <a:round/>
-            <a:headEnd type="none" w="sm" len="sm"/>
-            <a:tailEnd type="none" w="sm" len="sm"/>
-          </a:ln>
-        </p:spPr>
-        <p:txBody>
-          <a:bodyPr spcFirstLastPara="1" wrap="square" lIns="91425" tIns="91425" rIns="91425" bIns="91425" anchor="ctr" anchorCtr="0">
-            <a:noAutofit/>
-          </a:bodyPr>
-          <a:lstStyle/>
-          <a:p>
-            <a:pPr marL="0" marR="0" lvl="0" indent="0" algn="l" rtl="0">
-              <a:lnSpc>
-                <a:spcPct val="100000"/>
-              </a:lnSpc>
-              <a:spcBef>
-                <a:spcPts val="0"/>
-              </a:spcBef>
-              <a:spcAft>
-                <a:spcPts val="0"/>
-              </a:spcAft>
-              <a:buClr>
-                <a:srgbClr val="000000"/>
-              </a:buClr>
-              <a:buSzPts val="1400"/>
-              <a:buFont typeface="Arial"/>
-              <a:buNone/>
-            </a:pPr>
-            <a:endParaRPr sz="1400" b="0" i="0" u="none" strike="noStrike" cap="none">
-              <a:solidFill>
-                <a:srgbClr val="000000"/>
-              </a:solidFill>
-              <a:latin typeface="Arial"/>
-              <a:ea typeface="Arial"/>
-              <a:cs typeface="Arial"/>
-              <a:sym typeface="Arial"/>
-            </a:endParaRPr>
-          </a:p>
-        </p:txBody>
-      </p:sp>
-      <p:sp>
-        <p:nvSpPr>
-          <p:cNvPr id="155" name="Google Shape;155;g38b39bbdc2a_0_61"/>
-          <p:cNvSpPr/>
-          <p:nvPr/>
-        </p:nvSpPr>
-        <p:spPr>
-          <a:xfrm>
-            <a:off x="274320" y="4887468"/>
-            <a:ext cx="7772400" cy="201300"/>
-          </a:xfrm>
-          <a:prstGeom prst="rect">
-            <a:avLst/>
-          </a:prstGeom>
-          <a:noFill/>
-          <a:ln>
-            <a:noFill/>
-          </a:ln>
-        </p:spPr>
-        <p:txBody>
-          <a:bodyPr spcFirstLastPara="1" wrap="square" lIns="91425" tIns="45700" rIns="91425" bIns="45700" anchor="ctr" anchorCtr="0">
-            <a:noAutofit/>
-          </a:bodyPr>
-          <a:lstStyle/>
-          <a:p>
-            <a:pPr marL="0" marR="0" lvl="0" indent="0" algn="ctr" rtl="0">
-              <a:lnSpc>
-                <a:spcPct val="100000"/>
-              </a:lnSpc>
-              <a:spcBef>
-                <a:spcPts val="0"/>
-              </a:spcBef>
-              <a:spcAft>
-                <a:spcPts val="0"/>
-              </a:spcAft>
-              <a:buClr>
-                <a:srgbClr val="888888"/>
-              </a:buClr>
-              <a:buSzPts val="700"/>
-              <a:buFont typeface="Calibri"/>
-              <a:buNone/>
-            </a:pPr>
-            <a:r>
-              <a:rPr lang="en-US" sz="700" b="0" i="0" u="none" strike="noStrike" cap="none">
-                <a:solidFill>
-                  <a:srgbClr val="888888"/>
-                </a:solidFill>
-                <a:latin typeface="Calibri"/>
-                <a:ea typeface="Calibri"/>
-                <a:cs typeface="Calibri"/>
-                <a:sym typeface="Calibri"/>
-              </a:rPr>
-              <a:t>© 2026 Upscale AI – Proprietary and Confidential – Do Not Reproduce or Duplicate</a:t>
-            </a:r>
-            <a:endParaRPr sz="700" b="0" i="0" u="none" strike="noStrike" cap="none">
-              <a:solidFill>
-                <a:schemeClr val="dk1"/>
-              </a:solidFill>
-              <a:latin typeface="Calibri"/>
-              <a:ea typeface="Calibri"/>
-              <a:cs typeface="Calibri"/>
-              <a:sym typeface="Calibri"/>
-            </a:endParaRPr>
-          </a:p>
-        </p:txBody>
-      </p:sp>
-      <p:sp>
-        <p:nvSpPr>
-          <p:cNvPr id="156" name="Google Shape;156;g38b39bbdc2a_0_61"/>
-          <p:cNvSpPr/>
-          <p:nvPr/>
-        </p:nvSpPr>
-        <p:spPr>
-          <a:xfrm>
-            <a:off x="7863840" y="4887468"/>
-            <a:ext cx="1097400" cy="201300"/>
-          </a:xfrm>
-          <a:prstGeom prst="rect">
-            <a:avLst/>
-          </a:prstGeom>
-          <a:noFill/>
-          <a:ln>
-            <a:noFill/>
-          </a:ln>
-        </p:spPr>
-        <p:txBody>
-          <a:bodyPr spcFirstLastPara="1" wrap="square" lIns="91425" tIns="45700" rIns="91425" bIns="45700" anchor="ctr" anchorCtr="0">
-            <a:noAutofit/>
-          </a:bodyPr>
-          <a:lstStyle/>
-          <a:p>
-            <a:pPr marL="0" marR="0" lvl="0" indent="0" algn="r" rtl="0">
-              <a:lnSpc>
-                <a:spcPct val="100000"/>
-              </a:lnSpc>
-              <a:spcBef>
-                <a:spcPts val="0"/>
-              </a:spcBef>
-              <a:spcAft>
-                <a:spcPts val="0"/>
-              </a:spcAft>
-              <a:buClr>
-                <a:srgbClr val="FFE19E"/>
-              </a:buClr>
-              <a:buSzPts val="800"/>
-              <a:buFont typeface="Calibri"/>
-              <a:buNone/>
-            </a:pPr>
-            <a:r>
-              <a:rPr lang="en-US" sz="800" b="1" i="0" u="none" strike="noStrike" cap="none">
-                <a:solidFill>
-                  <a:srgbClr val="FFE19E"/>
-                </a:solidFill>
-                <a:latin typeface="Calibri"/>
-                <a:ea typeface="Calibri"/>
-                <a:cs typeface="Calibri"/>
-                <a:sym typeface="Calibri"/>
-              </a:rPr>
-              <a:t>UP </a:t>
-            </a:r>
-            <a:r>
-              <a:rPr lang="en-US" sz="900" b="1" i="0" u="none" strike="noStrike" cap="none">
-                <a:solidFill>
-                  <a:srgbClr val="FFE19E"/>
-                </a:solidFill>
-                <a:latin typeface="Calibri"/>
-                <a:ea typeface="Calibri"/>
-                <a:cs typeface="Calibri"/>
-                <a:sym typeface="Calibri"/>
-              </a:rPr>
-              <a:t>upscale </a:t>
-            </a:r>
-            <a:r>
-              <a:rPr lang="en-US" sz="900" b="0" i="0" u="none" strike="noStrike" cap="none">
-                <a:solidFill>
-                  <a:srgbClr val="FFE19E"/>
-                </a:solidFill>
-                <a:latin typeface="Calibri"/>
-                <a:ea typeface="Calibri"/>
-                <a:cs typeface="Calibri"/>
-                <a:sym typeface="Calibri"/>
-              </a:rPr>
-              <a:t>ai</a:t>
-            </a:r>
-            <a:endParaRPr sz="800" b="0" i="0" u="none" strike="noStrike" cap="none">
-              <a:solidFill>
-                <a:schemeClr val="dk1"/>
-              </a:solidFill>
-              <a:latin typeface="Calibri"/>
-              <a:ea typeface="Calibri"/>
-              <a:cs typeface="Calibri"/>
-              <a:sym typeface="Calibri"/>
-            </a:endParaRPr>
-          </a:p>
-        </p:txBody>
-      </p:sp>
-      <p:sp>
-        <p:nvSpPr>
-          <p:cNvPr id="157" name="Google Shape;157;g38b39bbdc2a_0_61"/>
-          <p:cNvSpPr txBox="1"/>
-          <p:nvPr/>
-        </p:nvSpPr>
-        <p:spPr>
-          <a:xfrm>
-            <a:off x="411475" y="795525"/>
-            <a:ext cx="8321100" cy="2147100"/>
-          </a:xfrm>
-          <a:prstGeom prst="rect">
-            <a:avLst/>
-          </a:prstGeom>
-          <a:noFill/>
-          <a:ln>
-            <a:noFill/>
-          </a:ln>
-        </p:spPr>
-        <p:txBody>
-          <a:bodyPr spcFirstLastPara="1" wrap="square" lIns="91425" tIns="91425" rIns="91425" bIns="91425" anchor="t" anchorCtr="0">
-            <a:spAutoFit/>
-          </a:bodyPr>
-          <a:lstStyle/>
-          <a:p>
-            <a:pPr marL="457200" marR="0" indent="-307975" algn="l" rtl="0">
-              <a:lnSpc>
-                <a:spcPct val="115000"/>
-              </a:lnSpc>
-              <a:spcBef>
-                <a:spcPts val="1200"/>
-              </a:spcBef>
-              <a:spcAft>
-                <a:spcPts val="0"/>
-              </a:spcAft>
-              <a:buClr>
-                <a:schemeClr val="dk1"/>
-              </a:buClr>
-              <a:buSzPts val="1250"/>
-              <a:buFont typeface="Arial"/>
-              <a:buChar char="●"/>
-            </a:pPr>
-            <a:r>
-              <a:rPr sz="1300">
-                <a:solidFill>
-                  <a:srgbClr val="333333"/>
-                </a:solidFill>
-                <a:latin typeface="Arial"/>
-              </a:rPr>
-              <a:t>Beat 5–6</a:t>
-            </a:r>
-            <a:endParaRPr sz="1250" b="0" i="0" u="none" strike="noStrike" cap="none">
-              <a:solidFill>
-                <a:schemeClr val="dk1"/>
-              </a:solidFill>
-              <a:latin typeface="Arial"/>
-              <a:ea typeface="Arial"/>
-              <a:cs typeface="Arial"/>
-              <a:sym typeface="Arial"/>
-            </a:endParaRPr>
-          </a:p>
-          <a:p>
-            <a:pPr/>
-            <a:r>
-              <a:rPr sz="1300">
-                <a:solidFill>
-                  <a:srgbClr val="333333"/>
-                </a:solidFill>
-                <a:latin typeface="Arial"/>
-              </a:rPr>
-              <a:t>Boundaries — keeps Friday walkable.</a:t>
-            </a:r>
-          </a:p>
-          <a:p>
-            <a:pPr/>
-          </a:p>
-          <a:p>
-            <a:pPr/>
-            <a:r>
-              <a:rPr sz="1300">
-                <a:solidFill>
-                  <a:srgbClr val="333333"/>
-                </a:solidFill>
-                <a:latin typeface="Arial"/>
-              </a:rPr>
-              <a:t>Not C40 / full HW digest · Not SDK program ownership day one</a:t>
-            </a:r>
-          </a:p>
-          <a:p>
-            <a:pPr/>
-            <a:r>
-              <a:rPr sz="1300">
-                <a:solidFill>
-                  <a:srgbClr val="333333"/>
-                </a:solidFill>
-                <a:latin typeface="Arial"/>
-              </a:rPr>
-              <a:t>Not AI/token policy · Not sponsor homework-check — walkable backup only</a:t>
-            </a:r>
-          </a:p>
-          <a:p>
-            <a:pPr/>
-            <a:r>
-              <a:rPr sz="1300">
-                <a:solidFill>
-                  <a:srgbClr val="333333"/>
-                </a:solidFill>
-                <a:latin typeface="Arial"/>
-              </a:rPr>
-              <a:t>Whiteboard backup: assets/dt100-whiteboards.md (only if asked)</a:t>
-            </a:r>
-          </a:p>
-        </p:txBody>
-      </p:sp>
-    </p:spTree>
-  </p:cSld>
-  <p:clrMapOvr>
-    <a:masterClrMapping/>
-  </p:clrMapOvr>
-</p:sld>
-</file>
-
 <file path=ppt/slides/slide3.xml><?xml version="1.0" encoding="utf-8"?>
 <p:sld xmlns:a="http://schemas.openxmlformats.org/drawingml/2006/main" xmlns:r="http://schemas.openxmlformats.org/officeDocument/2006/relationships" xmlns:p="http://schemas.openxmlformats.org/presentationml/2006/main">
   <p:cSld>
@@ -7446,20 +5436,20 @@
           </a:ln>
         </p:spPr>
         <p:txBody>
-          <a:bodyPr spcFirstLastPara="1" wrap="square" lIns="91425" tIns="45700" rIns="91425" bIns="45700" anchor="t" anchorCtr="0">
+          <a:bodyPr spcFirstLastPara="1" wrap="none" lIns="91425" tIns="45700" rIns="91425" bIns="45700" anchor="t" anchorCtr="0">
             <a:noAutofit/>
           </a:bodyPr>
           <a:lstStyle/>
           <a:p>
-            <a:pPr marL="0" marR="0" lvl="0" indent="0" algn="l" rtl="0">
-              <a:lnSpc>
-                <a:spcPct val="100000"/>
-              </a:lnSpc>
-              <a:spcBef>
-                <a:spcPts val="0"/>
-              </a:spcBef>
-              <a:spcAft>
-                <a:spcPts val="0"/>
+            <a:pPr marL="0" marR="0" indent="0" algn="l" rtl="0">
+              <a:lnSpc>
+                <a:spcPct val="100000"/>
+              </a:lnSpc>
+              <a:spcBef>
+                <a:spcPts val="0"/>
+              </a:spcBef>
+              <a:spcAft>
+                <a:spcPts val="300"/>
               </a:spcAft>
               <a:buClr>
                 <a:srgbClr val="051830"/>
@@ -7469,16 +5459,13 @@
               <a:buNone/>
             </a:pPr>
             <a:r>
-              <a:rPr lang="en-US" sz="2600" b="0" i="0" u="none" strike="noStrike" cap="none">
+              <a:rPr sz="2600">
                 <a:solidFill>
                   <a:srgbClr val="051830"/>
                 </a:solidFill>
                 <a:latin typeface="Calibri"/>
-                <a:ea typeface="Calibri"/>
-                <a:cs typeface="Calibri"/>
-                <a:sym typeface="Calibri"/>
               </a:rPr>
-              <a:t>Define task — after qos-architecture slides 1–2</a:t>
+              <a:t>The walk — five beats (process)</a:t>
             </a:r>
             <a:endParaRPr sz="3000" b="0" i="0" u="none" strike="noStrike" cap="none">
               <a:solidFill>
@@ -7489,6 +5476,22 @@
               <a:cs typeface="Calibri"/>
               <a:sym typeface="Calibri"/>
             </a:endParaRPr>
+          </a:p>
+          <a:p>
+            <a:pPr>
+              <a:spcAft>
+                <a:spcPts val="300"/>
+              </a:spcAft>
+            </a:pPr>
+            <a:r>
+              <a:rPr sz="1300">
+                <a:solidFill>
+                  <a:srgbClr val="556677"/>
+                </a:solidFill>
+                <a:latin typeface="Arial"/>
+              </a:rPr>
+              <a:t>Act I · broad strokes</a:t>
+            </a:r>
           </a:p>
         </p:txBody>
       </p:sp>
@@ -7781,7 +5784,7 @@
         <p:spPr>
           <a:xfrm>
             <a:off x="411475" y="795525"/>
-            <a:ext cx="8321100" cy="3917400"/>
+            <a:ext cx="0" cy="0"/>
           </a:xfrm>
           <a:prstGeom prst="rect">
             <a:avLst/>
@@ -7797,7 +5800,7 @@
           </a:bodyPr>
           <a:lstStyle/>
           <a:p>
-            <a:pPr marL="457200" marR="0" indent="-307975" algn="l" rtl="0">
+            <a:pPr marL="457200" marR="0" lvl="0" indent="-307975" algn="l" rtl="0">
               <a:lnSpc>
                 <a:spcPct val="115000"/>
               </a:lnSpc>
@@ -7814,15 +5817,6 @@
               <a:buFont typeface="Arial"/>
               <a:buChar char="●"/>
             </a:pPr>
-            <a:r>
-              <a:rPr sz="1300">
-                <a:solidFill>
-                  <a:srgbClr val="333333"/>
-                </a:solidFill>
-                <a:latin typeface="Arial"/>
-              </a:rPr>
-              <a:t>Beat 1 · ~1 min</a:t>
-            </a:r>
             <a:endParaRPr sz="1250" b="0" i="0" u="none" strike="noStrike" cap="none">
               <a:solidFill>
                 <a:schemeClr val="dk1"/>
@@ -7833,59 +5827,32 @@
               <a:sym typeface="Arial"/>
             </a:endParaRPr>
           </a:p>
-          <a:p>
-            <a:pPr/>
-            <a:r>
-              <a:rPr sz="1300">
-                <a:solidFill>
-                  <a:srgbClr val="333333"/>
-                </a:solidFill>
-                <a:latin typeface="Arial"/>
-              </a:rPr>
-              <a:t>Transition — alignment deck framed situation + task; this walk defines how.</a:t>
-            </a:r>
-          </a:p>
-          <a:p>
-            <a:pPr/>
-          </a:p>
-          <a:p>
-            <a:pPr/>
-            <a:r>
-              <a:rPr sz="1300">
-                <a:solidFill>
-                  <a:srgbClr val="333333"/>
-                </a:solidFill>
-                <a:latin typeface="Arial"/>
-              </a:rPr>
-              <a:t>Assumption: **qos-architecture** aligned on tape-out program bar + QoS RM wedge at CSB.</a:t>
-            </a:r>
-          </a:p>
-          <a:p>
-            <a:pPr/>
-            <a:r>
-              <a:rPr sz="1300">
-                <a:solidFill>
-                  <a:srgbClr val="333333"/>
-                </a:solidFill>
-                <a:latin typeface="Arial"/>
-              </a:rPr>
-              <a:t>Show validation machine, owners, QoS on logical pipeline — co-evolve plan live.</a:t>
-            </a:r>
-          </a:p>
-          <a:p>
-            <a:pPr/>
-            <a:r>
-              <a:rPr sz="1300">
-                <a:solidFill>
-                  <a:srgbClr val="333333"/>
-                </a:solidFill>
-                <a:latin typeface="Arial"/>
-              </a:rPr>
-              <a:t>Close on qos-architecture slides 3–4 (near-term scope + Friday alignment) — not repeated here.</a:t>
-            </a:r>
-          </a:p>
         </p:txBody>
       </p:sp>
+      <p:pic>
+        <p:nvPicPr>
+          <p:cNvPr id="59" name="Picture 58" descr="b6-slide01-process-ribbon.png"/>
+          <p:cNvPicPr>
+            <a:picLocks noChangeAspect="1"/>
+          </p:cNvPicPr>
+          <p:nvPr/>
+        </p:nvPicPr>
+        <p:blipFill>
+          <a:blip r:embed="rId3"/>
+          <a:stretch>
+            <a:fillRect/>
+          </a:stretch>
+        </p:blipFill>
+        <p:spPr>
+          <a:xfrm>
+            <a:off x="365760" y="2777224"/>
+            <a:ext cx="8412480" cy="709191"/>
+          </a:xfrm>
+          <a:prstGeom prst="rect">
+            <a:avLst/>
+          </a:prstGeom>
+        </p:spPr>
+      </p:pic>
     </p:spTree>
   </p:cSld>
   <p:clrMapOvr>
@@ -7939,20 +5906,20 @@
           </a:ln>
         </p:spPr>
         <p:txBody>
-          <a:bodyPr spcFirstLastPara="1" wrap="square" lIns="91425" tIns="45700" rIns="91425" bIns="45700" anchor="t" anchorCtr="0">
+          <a:bodyPr spcFirstLastPara="1" wrap="none" lIns="91425" tIns="45700" rIns="91425" bIns="45700" anchor="t" anchorCtr="0">
             <a:noAutofit/>
           </a:bodyPr>
           <a:lstStyle/>
           <a:p>
-            <a:pPr marL="0" marR="0" lvl="0" indent="0" algn="l" rtl="0">
-              <a:lnSpc>
-                <a:spcPct val="100000"/>
-              </a:lnSpc>
-              <a:spcBef>
-                <a:spcPts val="0"/>
-              </a:spcBef>
-              <a:spcAft>
-                <a:spcPts val="0"/>
+            <a:pPr marL="0" marR="0" indent="0" algn="l" rtl="0">
+              <a:lnSpc>
+                <a:spcPct val="100000"/>
+              </a:lnSpc>
+              <a:spcBef>
+                <a:spcPts val="0"/>
+              </a:spcBef>
+              <a:spcAft>
+                <a:spcPts val="300"/>
               </a:spcAft>
               <a:buClr>
                 <a:srgbClr val="051830"/>
@@ -7962,16 +5929,13 @@
               <a:buNone/>
             </a:pPr>
             <a:r>
-              <a:rPr lang="en-US" sz="2600" b="0" i="0" u="none" strike="noStrike" cap="none">
+              <a:rPr sz="2600">
                 <a:solidFill>
                   <a:srgbClr val="051830"/>
                 </a:solidFill>
                 <a:latin typeface="Calibri"/>
-                <a:ea typeface="Calibri"/>
-                <a:cs typeface="Calibri"/>
-                <a:sym typeface="Calibri"/>
               </a:rPr>
-              <a:t>Document discipline</a:t>
+              <a:t>Validation machine — how we prove tape-out</a:t>
             </a:r>
             <a:endParaRPr sz="3000" b="0" i="0" u="none" strike="noStrike" cap="none">
               <a:solidFill>
@@ -7982,6 +5946,22 @@
               <a:cs typeface="Calibri"/>
               <a:sym typeface="Calibri"/>
             </a:endParaRPr>
+          </a:p>
+          <a:p>
+            <a:pPr>
+              <a:spcAft>
+                <a:spcPts val="300"/>
+              </a:spcAft>
+            </a:pPr>
+            <a:r>
+              <a:rPr sz="1300">
+                <a:solidFill>
+                  <a:srgbClr val="556677"/>
+                </a:solidFill>
+                <a:latin typeface="Arial"/>
+              </a:rPr>
+              <a:t>Act II · focus</a:t>
+            </a:r>
           </a:p>
         </p:txBody>
       </p:sp>
@@ -8274,7 +6254,7 @@
         <p:spPr>
           <a:xfrm>
             <a:off x="411475" y="795525"/>
-            <a:ext cx="8321100" cy="3253500"/>
+            <a:ext cx="0" cy="0"/>
           </a:xfrm>
           <a:prstGeom prst="rect">
             <a:avLst/>
@@ -8290,7 +6270,7 @@
           </a:bodyPr>
           <a:lstStyle/>
           <a:p>
-            <a:pPr marL="457200" marR="0" indent="-307975" algn="l" rtl="0">
+            <a:pPr marL="457200" marR="0" lvl="0" indent="-307975" algn="l" rtl="0">
               <a:lnSpc>
                 <a:spcPct val="115000"/>
               </a:lnSpc>
@@ -8307,15 +6287,6 @@
               <a:buFont typeface="Arial"/>
               <a:buChar char="●"/>
             </a:pPr>
-            <a:r>
-              <a:rPr sz="1300">
-                <a:solidFill>
-                  <a:srgbClr val="333333"/>
-                </a:solidFill>
-                <a:latin typeface="Arial"/>
-              </a:rPr>
-              <a:t>Beat 2 · thin</a:t>
-            </a:r>
             <a:endParaRPr sz="1250" b="0" i="0" u="none" strike="noStrike" cap="none">
               <a:solidFill>
                 <a:schemeClr val="dk1"/>
@@ -8326,59 +6297,32 @@
               <a:sym typeface="Arial"/>
             </a:endParaRPr>
           </a:p>
-          <a:p>
-            <a:pPr/>
-            <a:r>
-              <a:rPr sz="1300">
-                <a:solidFill>
-                  <a:srgbClr val="333333"/>
-                </a:solidFill>
-                <a:latin typeface="Arial"/>
-              </a:rPr>
-              <a:t>Thin walk today; depth only if Gururaj redirects.</a:t>
-            </a:r>
-          </a:p>
-          <a:p>
-            <a:pPr/>
-          </a:p>
-          <a:p>
-            <a:pPr/>
-            <a:r>
-              <a:rPr sz="1300">
-                <a:solidFill>
-                  <a:srgbClr val="333333"/>
-                </a:solidFill>
-                <a:latin typeface="Arial"/>
-              </a:rPr>
-              <a:t>Friday meeting: qos-architecture slides 1–2, then this walk (~6 beats).</a:t>
-            </a:r>
-          </a:p>
-          <a:p>
-            <a:pPr/>
-            <a:r>
-              <a:rPr sz="1300">
-                <a:solidFill>
-                  <a:srgbClr val="333333"/>
-                </a:solidFill>
-                <a:latin typeface="Arial"/>
-              </a:rPr>
-              <a:t>Next: expand swimlanes / integrated validation plans — format and depth per your steer.</a:t>
-            </a:r>
-          </a:p>
-          <a:p>
-            <a:pPr/>
-            <a:r>
-              <a:rPr sz="1300">
-                <a:solidFill>
-                  <a:srgbClr val="333333"/>
-                </a:solidFill>
-                <a:latin typeface="Arial"/>
-              </a:rPr>
-              <a:t>Not this walk: 50-page dump, full HW catalog.</a:t>
-            </a:r>
-          </a:p>
         </p:txBody>
       </p:sp>
+      <p:pic>
+        <p:nvPicPr>
+          <p:cNvPr id="70" name="Picture 69" descr="b6-slide02-validation-stack.png"/>
+          <p:cNvPicPr>
+            <a:picLocks noChangeAspect="1"/>
+          </p:cNvPicPr>
+          <p:nvPr/>
+        </p:nvPicPr>
+        <p:blipFill>
+          <a:blip r:embed="rId3"/>
+          <a:stretch>
+            <a:fillRect/>
+          </a:stretch>
+        </p:blipFill>
+        <p:spPr>
+          <a:xfrm>
+            <a:off x="2695036" y="1508760"/>
+            <a:ext cx="3753928" cy="3246120"/>
+          </a:xfrm>
+          <a:prstGeom prst="rect">
+            <a:avLst/>
+          </a:prstGeom>
+        </p:spPr>
+      </p:pic>
     </p:spTree>
   </p:cSld>
   <p:clrMapOvr>
@@ -8432,20 +6376,20 @@
           </a:ln>
         </p:spPr>
         <p:txBody>
-          <a:bodyPr spcFirstLastPara="1" wrap="square" lIns="91425" tIns="45700" rIns="91425" bIns="45700" anchor="t" anchorCtr="0">
+          <a:bodyPr spcFirstLastPara="1" wrap="none" lIns="91425" tIns="45700" rIns="91425" bIns="45700" anchor="t" anchorCtr="0">
             <a:noAutofit/>
           </a:bodyPr>
           <a:lstStyle/>
           <a:p>
-            <a:pPr marL="0" marR="0" lvl="0" indent="0" algn="l" rtl="0">
-              <a:lnSpc>
-                <a:spcPct val="100000"/>
-              </a:lnSpc>
-              <a:spcBef>
-                <a:spcPts val="0"/>
-              </a:spcBef>
-              <a:spcAft>
-                <a:spcPts val="0"/>
+            <a:pPr marL="0" marR="0" indent="0" algn="l" rtl="0">
+              <a:lnSpc>
+                <a:spcPct val="100000"/>
+              </a:lnSpc>
+              <a:spcBef>
+                <a:spcPts val="0"/>
+              </a:spcBef>
+              <a:spcAft>
+                <a:spcPts val="300"/>
               </a:spcAft>
               <a:buClr>
                 <a:srgbClr val="051830"/>
@@ -8455,16 +6399,13 @@
               <a:buNone/>
             </a:pPr>
             <a:r>
-              <a:rPr lang="en-US" sz="2600" b="0" i="0" u="none" strike="noStrike" cap="none">
+              <a:rPr sz="2600">
                 <a:solidFill>
                   <a:srgbClr val="051830"/>
                 </a:solidFill>
                 <a:latin typeface="Calibri"/>
-                <a:ea typeface="Calibri"/>
-                <a:cs typeface="Calibri"/>
-                <a:sym typeface="Calibri"/>
               </a:rPr>
-              <a:t>Validation framework (I draft v0; peers align)</a:t>
+              <a:t>Logical pipeline — my wedge on your slide</a:t>
             </a:r>
             <a:endParaRPr sz="3000" b="0" i="0" u="none" strike="noStrike" cap="none">
               <a:solidFill>
@@ -8475,6 +6416,22 @@
               <a:cs typeface="Calibri"/>
               <a:sym typeface="Calibri"/>
             </a:endParaRPr>
+          </a:p>
+          <a:p>
+            <a:pPr>
+              <a:spcAft>
+                <a:spcPts val="300"/>
+              </a:spcAft>
+            </a:pPr>
+            <a:r>
+              <a:rPr sz="1300">
+                <a:solidFill>
+                  <a:srgbClr val="556677"/>
+                </a:solidFill>
+                <a:latin typeface="Arial"/>
+              </a:rPr>
+              <a:t>Act II · center of walk</a:t>
+            </a:r>
           </a:p>
         </p:txBody>
       </p:sp>
@@ -8767,7 +6724,7 @@
         <p:spPr>
           <a:xfrm>
             <a:off x="411475" y="795525"/>
-            <a:ext cx="8321100" cy="3032400"/>
+            <a:ext cx="0" cy="0"/>
           </a:xfrm>
           <a:prstGeom prst="rect">
             <a:avLst/>
@@ -8783,7 +6740,7 @@
           </a:bodyPr>
           <a:lstStyle/>
           <a:p>
-            <a:pPr marL="457200" marR="0" indent="-307975" algn="l" rtl="0">
+            <a:pPr marL="457200" marR="0" lvl="0" indent="-307975" algn="l" rtl="0">
               <a:lnSpc>
                 <a:spcPct val="115000"/>
               </a:lnSpc>
@@ -8800,15 +6757,6 @@
               <a:buFont typeface="Arial"/>
               <a:buChar char="●"/>
             </a:pPr>
-            <a:r>
-              <a:rPr sz="1300">
-                <a:solidFill>
-                  <a:srgbClr val="333333"/>
-                </a:solidFill>
-                <a:latin typeface="Arial"/>
-              </a:rPr>
-              <a:t>Beat 2 · ~3 min</a:t>
-            </a:r>
             <a:endParaRPr sz="1250" b="0" i="0" u="none" strike="noStrike" cap="none">
               <a:solidFill>
                 <a:schemeClr val="dk1"/>
@@ -8819,95 +6767,32 @@
               <a:sym typeface="Arial"/>
             </a:endParaRPr>
           </a:p>
-          <a:p>
-            <a:pPr/>
-            <a:r>
-              <a:rPr sz="1300">
-                <a:solidFill>
-                  <a:srgbClr val="333333"/>
-                </a:solidFill>
-                <a:latin typeface="Arial"/>
-              </a:rPr>
-              <a:t>Gates are v0 for group review — not unilateral.</a:t>
-            </a:r>
-          </a:p>
-          <a:p>
-            <a:pPr/>
-          </a:p>
-          <a:p>
-            <a:pPr/>
-            <a:r>
-              <a:rPr sz="1300">
-                <a:solidFill>
-                  <a:srgbClr val="333333"/>
-                </a:solidFill>
-                <a:latin typeface="Arial"/>
-              </a:rPr>
-              <a:t>Product / program use cases</a:t>
-            </a:r>
-          </a:p>
-          <a:p>
-            <a:pPr/>
-            <a:r>
-              <a:rPr sz="1300">
-                <a:solidFill>
-                  <a:srgbClr val="333333"/>
-                </a:solidFill>
-                <a:latin typeface="Arial"/>
-              </a:rPr>
-              <a:t>Architecture validation ↔ datapath arch</a:t>
-            </a:r>
-          </a:p>
-          <a:p>
-            <a:pPr/>
-            <a:r>
-              <a:rPr sz="1300">
-                <a:solidFill>
-                  <a:srgbClr val="333333"/>
-                </a:solidFill>
-                <a:latin typeface="Arial"/>
-              </a:rPr>
-              <a:t>Management plane — SONiC / FBOSS → SAI</a:t>
-            </a:r>
-          </a:p>
-          <a:p>
-            <a:pPr/>
-            <a:r>
-              <a:rPr sz="1300">
-                <a:solidFill>
-                  <a:srgbClr val="333333"/>
-                </a:solidFill>
-                <a:latin typeface="Arial"/>
-              </a:rPr>
-              <a:t>Tape-out path: C-models → emulation / FPGA → silicon</a:t>
-            </a:r>
-          </a:p>
-          <a:p>
-            <a:pPr/>
-            <a:r>
-              <a:rPr sz="1300">
-                <a:solidFill>
-                  <a:srgbClr val="333333"/>
-                </a:solidFill>
-                <a:latin typeface="Arial"/>
-              </a:rPr>
-              <a:t>SDK + SAI gates before tape-out</a:t>
-            </a:r>
-          </a:p>
-          <a:p>
-            <a:pPr/>
-            <a:r>
-              <a:rPr sz="1300">
-                <a:solidFill>
-                  <a:srgbClr val="333333"/>
-                </a:solidFill>
-                <a:latin typeface="Arial"/>
-              </a:rPr>
-              <a:t>I socialize v0 gates for group review; peers own slice proof.</a:t>
-            </a:r>
-          </a:p>
         </p:txBody>
       </p:sp>
+      <p:pic>
+        <p:nvPicPr>
+          <p:cNvPr id="81" name="Picture 80" descr="b6-slide03-pipeline-annotated.png"/>
+          <p:cNvPicPr>
+            <a:picLocks noChangeAspect="1"/>
+          </p:cNvPicPr>
+          <p:nvPr/>
+        </p:nvPicPr>
+        <p:blipFill>
+          <a:blip r:embed="rId3"/>
+          <a:stretch>
+            <a:fillRect/>
+          </a:stretch>
+        </p:blipFill>
+        <p:spPr>
+          <a:xfrm>
+            <a:off x="1681542" y="1508760"/>
+            <a:ext cx="5780916" cy="3246120"/>
+          </a:xfrm>
+          <a:prstGeom prst="rect">
+            <a:avLst/>
+          </a:prstGeom>
+        </p:spPr>
+      </p:pic>
     </p:spTree>
   </p:cSld>
   <p:clrMapOvr>
@@ -8961,20 +6846,20 @@
           </a:ln>
         </p:spPr>
         <p:txBody>
-          <a:bodyPr spcFirstLastPara="1" wrap="square" lIns="91425" tIns="45700" rIns="91425" bIns="45700" anchor="t" anchorCtr="0">
+          <a:bodyPr spcFirstLastPara="1" wrap="none" lIns="91425" tIns="45700" rIns="91425" bIns="45700" anchor="t" anchorCtr="0">
             <a:noAutofit/>
           </a:bodyPr>
           <a:lstStyle/>
           <a:p>
-            <a:pPr marL="0" marR="0" lvl="0" indent="0" algn="l" rtl="0">
-              <a:lnSpc>
-                <a:spcPct val="100000"/>
-              </a:lnSpc>
-              <a:spcBef>
-                <a:spcPts val="0"/>
-              </a:spcBef>
-              <a:spcAft>
-                <a:spcPts val="0"/>
+            <a:pPr marL="0" marR="0" indent="0" algn="l" rtl="0">
+              <a:lnSpc>
+                <a:spcPct val="100000"/>
+              </a:lnSpc>
+              <a:spcBef>
+                <a:spcPts val="0"/>
+              </a:spcBef>
+              <a:spcAft>
+                <a:spcPts val="300"/>
               </a:spcAft>
               <a:buClr>
                 <a:srgbClr val="051830"/>
@@ -8984,16 +6869,13 @@
               <a:buNone/>
             </a:pPr>
             <a:r>
-              <a:rPr lang="en-US" sz="2600" b="0" i="0" u="none" strike="noStrike" cap="none">
+              <a:rPr sz="2600">
                 <a:solidFill>
                   <a:srgbClr val="051830"/>
                 </a:solidFill>
                 <a:latin typeface="Calibri"/>
-                <a:ea typeface="Calibri"/>
-                <a:cs typeface="Calibri"/>
-                <a:sym typeface="Calibri"/>
               </a:rPr>
-              <a:t>Who owns what (don't read every row)</a:t>
+              <a:t>Buffer carve @ CSB</a:t>
             </a:r>
             <a:endParaRPr sz="3000" b="0" i="0" u="none" strike="noStrike" cap="none">
               <a:solidFill>
@@ -9004,6 +6886,22 @@
               <a:cs typeface="Calibri"/>
               <a:sym typeface="Calibri"/>
             </a:endParaRPr>
+          </a:p>
+          <a:p>
+            <a:pPr>
+              <a:spcAft>
+                <a:spcPts val="300"/>
+              </a:spcAft>
+            </a:pPr>
+            <a:r>
+              <a:rPr sz="1300">
+                <a:solidFill>
+                  <a:srgbClr val="556677"/>
+                </a:solidFill>
+                <a:latin typeface="Arial"/>
+              </a:rPr>
+              <a:t>Act II · egress wedge</a:t>
+            </a:r>
           </a:p>
         </p:txBody>
       </p:sp>
@@ -9296,7 +7194,7 @@
         <p:spPr>
           <a:xfrm>
             <a:off x="411475" y="795525"/>
-            <a:ext cx="8622000" cy="2811000"/>
+            <a:ext cx="0" cy="0"/>
           </a:xfrm>
           <a:prstGeom prst="rect">
             <a:avLst/>
@@ -9312,7 +7210,7 @@
           </a:bodyPr>
           <a:lstStyle/>
           <a:p>
-            <a:pPr marL="457200" marR="0" indent="-307975" algn="l" rtl="0">
+            <a:pPr marL="457200" marR="0" lvl="0" indent="-307975" algn="l" rtl="0">
               <a:lnSpc>
                 <a:spcPct val="115000"/>
               </a:lnSpc>
@@ -9329,15 +7227,6 @@
               <a:buFont typeface="Arial"/>
               <a:buChar char="●"/>
             </a:pPr>
-            <a:r>
-              <a:rPr sz="1300">
-                <a:solidFill>
-                  <a:srgbClr val="333333"/>
-                </a:solidFill>
-                <a:latin typeface="Arial"/>
-              </a:rPr>
-              <a:t>Beat 3 · ~2 min</a:t>
-            </a:r>
             <a:endParaRPr sz="1250" b="0" i="0" u="none" strike="noStrike" cap="none">
               <a:solidFill>
                 <a:schemeClr val="dk1"/>
@@ -9348,71 +7237,32 @@
               <a:sym typeface="Arial"/>
             </a:endParaRPr>
           </a:p>
-          <a:p>
-            <a:pPr/>
-            <a:r>
-              <a:rPr sz="1300">
-                <a:solidFill>
-                  <a:srgbClr val="333333"/>
-                </a:solidFill>
-                <a:latin typeface="Arial"/>
-              </a:rPr>
-              <a:t>My lane first; peer DRIs in W order — then point at pipeline slide.</a:t>
-            </a:r>
-          </a:p>
-          <a:p>
-            <a:pPr/>
-          </a:p>
-          <a:p>
-            <a:pPr/>
-            <a:r>
-              <a:rPr sz="1300">
-                <a:solidFill>
-                  <a:srgbClr val="333333"/>
-                </a:solidFill>
-                <a:latin typeface="Arial"/>
-              </a:rPr>
-              <a:t>Validation program + QoS RM: Diwakar Tundlam · QoSMAP · Queue · buffer carve at CSB</a:t>
-            </a:r>
-          </a:p>
-          <a:p>
-            <a:pPr/>
-            <a:r>
-              <a:rPr sz="1300">
-                <a:solidFill>
-                  <a:srgbClr val="333333"/>
-                </a:solidFill>
-                <a:latin typeface="Arial"/>
-              </a:rPr>
-              <a:t>Peer DRIs: Shafi Mohammad · L2/L3/Mirroring · Tippanna Hongal · ECMP/LAG/Counters · Tilak · L2 · Girish Kale · L3</a:t>
-            </a:r>
-          </a:p>
-          <a:p>
-            <a:pPr/>
-            <a:r>
-              <a:rPr sz="1300">
-                <a:solidFill>
-                  <a:srgbClr val="333333"/>
-                </a:solidFill>
-                <a:latin typeface="Arial"/>
-              </a:rPr>
-              <a:t>HW datapath / OCP ESUN: Rupa Budhia · SDK / SAI: SDK leads — consult, not my R</a:t>
-            </a:r>
-          </a:p>
-          <a:p>
-            <a:pPr/>
-            <a:r>
-              <a:rPr sz="1300">
-                <a:solidFill>
-                  <a:srgbClr val="333333"/>
-                </a:solidFill>
-                <a:latin typeface="Arial"/>
-              </a:rPr>
-              <a:t>Program mesh: Prasun Sinha · Scope / company external: Gururaj</a:t>
-            </a:r>
-          </a:p>
         </p:txBody>
       </p:sp>
+      <p:pic>
+        <p:nvPicPr>
+          <p:cNvPr id="92" name="Picture 91" descr="b6-slide04-csb-inset.png"/>
+          <p:cNvPicPr>
+            <a:picLocks noChangeAspect="1"/>
+          </p:cNvPicPr>
+          <p:nvPr/>
+        </p:nvPicPr>
+        <p:blipFill>
+          <a:blip r:embed="rId3"/>
+          <a:stretch>
+            <a:fillRect/>
+          </a:stretch>
+        </p:blipFill>
+        <p:spPr>
+          <a:xfrm>
+            <a:off x="3364558" y="1508760"/>
+            <a:ext cx="2414883" cy="3246120"/>
+          </a:xfrm>
+          <a:prstGeom prst="rect">
+            <a:avLst/>
+          </a:prstGeom>
+        </p:spPr>
+      </p:pic>
     </p:spTree>
   </p:cSld>
   <p:clrMapOvr>
@@ -9466,20 +7316,20 @@
           </a:ln>
         </p:spPr>
         <p:txBody>
-          <a:bodyPr spcFirstLastPara="1" wrap="square" lIns="91425" tIns="45700" rIns="91425" bIns="45700" anchor="t" anchorCtr="0">
+          <a:bodyPr spcFirstLastPara="1" wrap="none" lIns="91425" tIns="45700" rIns="91425" bIns="45700" anchor="t" anchorCtr="0">
             <a:noAutofit/>
           </a:bodyPr>
           <a:lstStyle/>
           <a:p>
-            <a:pPr marL="0" marR="0" lvl="0" indent="0" algn="l" rtl="0">
-              <a:lnSpc>
-                <a:spcPct val="100000"/>
-              </a:lnSpc>
-              <a:spcBef>
-                <a:spcPts val="0"/>
-              </a:spcBef>
-              <a:spcAft>
-                <a:spcPts val="0"/>
+            <a:pPr marL="0" marR="0" indent="0" algn="l" rtl="0">
+              <a:lnSpc>
+                <a:spcPct val="100000"/>
+              </a:lnSpc>
+              <a:spcBef>
+                <a:spcPts val="0"/>
+              </a:spcBef>
+              <a:spcAft>
+                <a:spcPts val="300"/>
               </a:spcAft>
               <a:buClr>
                 <a:srgbClr val="051830"/>
@@ -9489,16 +7339,13 @@
               <a:buNone/>
             </a:pPr>
             <a:r>
-              <a:rPr lang="en-US" sz="2600" b="0" i="0" u="none" strike="noStrike" cap="none">
+              <a:rPr sz="2600">
                 <a:solidFill>
                   <a:srgbClr val="051830"/>
                 </a:solidFill>
                 <a:latin typeface="Calibri"/>
-                <a:ea typeface="Calibri"/>
-                <a:cs typeface="Calibri"/>
-                <a:sym typeface="Calibri"/>
               </a:rPr>
-              <a:t>My wedge — QoS / RM (HWv1)</a:t>
+              <a:t>Who aligns on which gate</a:t>
             </a:r>
             <a:endParaRPr sz="3000" b="0" i="0" u="none" strike="noStrike" cap="none">
               <a:solidFill>
@@ -9509,6 +7356,22 @@
               <a:cs typeface="Calibri"/>
               <a:sym typeface="Calibri"/>
             </a:endParaRPr>
+          </a:p>
+          <a:p>
+            <a:pPr>
+              <a:spcAft>
+                <a:spcPts val="300"/>
+              </a:spcAft>
+            </a:pPr>
+            <a:r>
+              <a:rPr sz="1300">
+                <a:solidFill>
+                  <a:srgbClr val="556677"/>
+                </a:solidFill>
+                <a:latin typeface="Arial"/>
+              </a:rPr>
+              <a:t>Act III · review</a:t>
+            </a:r>
           </a:p>
         </p:txBody>
       </p:sp>
@@ -9801,7 +7664,7 @@
         <p:spPr>
           <a:xfrm>
             <a:off x="411475" y="795525"/>
-            <a:ext cx="8622000" cy="1704600"/>
+            <a:ext cx="0" cy="0"/>
           </a:xfrm>
           <a:prstGeom prst="rect">
             <a:avLst/>
@@ -9817,7 +7680,7 @@
           </a:bodyPr>
           <a:lstStyle/>
           <a:p>
-            <a:pPr marL="457200" marR="0" indent="-307975" algn="l" rtl="0">
+            <a:pPr marL="457200" marR="0" lvl="0" indent="-307975" algn="l" rtl="0">
               <a:lnSpc>
                 <a:spcPct val="115000"/>
               </a:lnSpc>
@@ -9834,15 +7697,6 @@
               <a:buFont typeface="Arial"/>
               <a:buChar char="●"/>
             </a:pPr>
-            <a:r>
-              <a:rPr sz="1300">
-                <a:solidFill>
-                  <a:srgbClr val="333333"/>
-                </a:solidFill>
-                <a:latin typeface="Arial"/>
-              </a:rPr>
-              <a:t>Beat 4 · reference only (historical)</a:t>
-            </a:r>
             <a:endParaRPr sz="1250" b="0" i="0" u="none" strike="noStrike" cap="none">
               <a:solidFill>
                 <a:schemeClr val="dk1"/>
@@ -9853,83 +7707,32 @@
               <a:sym typeface="Arial"/>
             </a:endParaRPr>
           </a:p>
-          <a:p>
-            <a:pPr/>
-            <a:r>
-              <a:rPr sz="1300">
-                <a:solidFill>
-                  <a:srgbClr val="333333"/>
-                </a:solidFill>
-                <a:latin typeface="Arial"/>
-              </a:rPr>
-              <a:t>Kept for reference — validation scope lives on slide 3 framework.</a:t>
-            </a:r>
-          </a:p>
-          <a:p>
-            <a:pPr/>
-          </a:p>
-          <a:p>
-            <a:pPr/>
-            <a:r>
-              <a:rPr sz="1300">
-                <a:solidFill>
-                  <a:srgbClr val="333333"/>
-                </a:solidFill>
-                <a:latin typeface="Arial"/>
-              </a:rPr>
-              <a:t>VLAN-PRI, TOS/DSCP → queues → schedulers</a:t>
-            </a:r>
-          </a:p>
-          <a:p>
-            <a:pPr/>
-            <a:r>
-              <a:rPr sz="1300">
-                <a:solidFill>
-                  <a:srgbClr val="333333"/>
-                </a:solidFill>
-                <a:latin typeface="Arial"/>
-              </a:rPr>
-              <a:t>Buffer management and carving (resource manager)</a:t>
-            </a:r>
-          </a:p>
-          <a:p>
-            <a:pPr/>
-            <a:r>
-              <a:rPr sz="1300">
-                <a:solidFill>
-                  <a:srgbClr val="333333"/>
-                </a:solidFill>
-                <a:latin typeface="Arial"/>
-              </a:rPr>
-              <a:t>Port speed + queue/port policy coherence</a:t>
-            </a:r>
-          </a:p>
-          <a:p>
-            <a:pPr/>
-            <a:r>
-              <a:rPr sz="1300">
-                <a:solidFill>
-                  <a:srgbClr val="333333"/>
-                </a:solidFill>
-                <a:latin typeface="Arial"/>
-              </a:rPr>
-              <a:t>ESUN — align buffer/TM with standardization (OCP)</a:t>
-            </a:r>
-          </a:p>
-          <a:p>
-            <a:pPr/>
-            <a:r>
-              <a:rPr sz="1300">
-                <a:solidFill>
-                  <a:srgbClr val="333333"/>
-                </a:solidFill>
-                <a:latin typeface="Arial"/>
-              </a:rPr>
-              <a:t>HWv1: no MPLS EXP, no IPv6 priority mapping · HWv2: EXP + IPv6 pri</a:t>
-            </a:r>
-          </a:p>
         </p:txBody>
       </p:sp>
+      <p:pic>
+        <p:nvPicPr>
+          <p:cNvPr id="103" name="Picture 102" descr="b6-slide05-gate-alignment.png"/>
+          <p:cNvPicPr>
+            <a:picLocks noChangeAspect="1"/>
+          </p:cNvPicPr>
+          <p:nvPr/>
+        </p:nvPicPr>
+        <p:blipFill>
+          <a:blip r:embed="rId3"/>
+          <a:stretch>
+            <a:fillRect/>
+          </a:stretch>
+        </p:blipFill>
+        <p:spPr>
+          <a:xfrm>
+            <a:off x="2547274" y="1508760"/>
+            <a:ext cx="4049452" cy="3246120"/>
+          </a:xfrm>
+          <a:prstGeom prst="rect">
+            <a:avLst/>
+          </a:prstGeom>
+        </p:spPr>
+      </p:pic>
     </p:spTree>
   </p:cSld>
   <p:clrMapOvr>
@@ -10012,7 +7815,7 @@
                 </a:solidFill>
                 <a:latin typeface="Calibri"/>
               </a:rPr>
-              <a:t>Your pipeline slide — my wedge (center of walk)</a:t>
+              <a:t>Boundaries — in this walk vs not merged</a:t>
             </a:r>
             <a:endParaRPr sz="3000" b="0" i="0" u="none" strike="noStrike" cap="none">
               <a:solidFill>
@@ -10023,6 +7826,22 @@
               <a:cs typeface="Calibri"/>
               <a:sym typeface="Calibri"/>
             </a:endParaRPr>
+          </a:p>
+          <a:p>
+            <a:pPr>
+              <a:spcAft>
+                <a:spcPts val="300"/>
+              </a:spcAft>
+            </a:pPr>
+            <a:r>
+              <a:rPr sz="1300">
+                <a:solidFill>
+                  <a:srgbClr val="556677"/>
+                </a:solidFill>
+                <a:latin typeface="Arial"/>
+              </a:rPr>
+              <a:t>Act III · defer</a:t>
+            </a:r>
           </a:p>
         </p:txBody>
       </p:sp>
@@ -10362,7 +8181,7 @@
       </p:sp>
       <p:pic>
         <p:nvPicPr>
-          <p:cNvPr id="114" name="Picture 113" descr="logical-pipeline-boss-slide.png"/>
+          <p:cNvPr id="114" name="Picture 113" descr="b6-slide06-boundaries.png"/>
           <p:cNvPicPr>
             <a:picLocks noChangeAspect="1"/>
           </p:cNvPicPr>
@@ -10376,8 +8195,8 @@
         </p:blipFill>
         <p:spPr>
           <a:xfrm>
-            <a:off x="1681542" y="1508760"/>
-            <a:ext cx="5780916" cy="3246120"/>
+            <a:off x="586190" y="1508760"/>
+            <a:ext cx="7971619" cy="3246120"/>
           </a:xfrm>
           <a:prstGeom prst="rect">
             <a:avLst/>
@@ -10437,20 +8256,20 @@
           </a:ln>
         </p:spPr>
         <p:txBody>
-          <a:bodyPr spcFirstLastPara="1" wrap="square" lIns="91425" tIns="45700" rIns="91425" bIns="45700" anchor="t" anchorCtr="0">
+          <a:bodyPr spcFirstLastPara="1" wrap="none" lIns="91425" tIns="45700" rIns="91425" bIns="45700" anchor="t" anchorCtr="0">
             <a:noAutofit/>
           </a:bodyPr>
           <a:lstStyle/>
           <a:p>
-            <a:pPr marL="0" marR="0" lvl="0" indent="0" algn="l" rtl="0">
-              <a:lnSpc>
-                <a:spcPct val="100000"/>
-              </a:lnSpc>
-              <a:spcBef>
-                <a:spcPts val="0"/>
-              </a:spcBef>
-              <a:spcAft>
-                <a:spcPts val="0"/>
+            <a:pPr marL="0" marR="0" indent="0" algn="l" rtl="0">
+              <a:lnSpc>
+                <a:spcPct val="100000"/>
+              </a:lnSpc>
+              <a:spcBef>
+                <a:spcPts val="0"/>
+              </a:spcBef>
+              <a:spcAft>
+                <a:spcPts val="300"/>
               </a:spcAft>
               <a:buClr>
                 <a:srgbClr val="051830"/>
@@ -10460,16 +8279,13 @@
               <a:buNone/>
             </a:pPr>
             <a:r>
-              <a:rPr lang="en-US" sz="2600" b="0" i="0" u="none" strike="noStrike" cap="none">
+              <a:rPr sz="2600">
                 <a:solidFill>
                   <a:srgbClr val="051830"/>
                 </a:solidFill>
                 <a:latin typeface="Calibri"/>
-                <a:ea typeface="Calibri"/>
-                <a:cs typeface="Calibri"/>
-                <a:sym typeface="Calibri"/>
               </a:rPr>
-              <a:t>On the picture — blocks and validation tie-in</a:t>
+              <a:t>Next steps — if you want me to drive</a:t>
             </a:r>
             <a:endParaRPr sz="3000" b="0" i="0" u="none" strike="noStrike" cap="none">
               <a:solidFill>
@@ -10480,6 +8296,22 @@
               <a:cs typeface="Calibri"/>
               <a:sym typeface="Calibri"/>
             </a:endParaRPr>
+          </a:p>
+          <a:p>
+            <a:pPr>
+              <a:spcAft>
+                <a:spcPts val="300"/>
+              </a:spcAft>
+            </a:pPr>
+            <a:r>
+              <a:rPr sz="1300">
+                <a:solidFill>
+                  <a:srgbClr val="556677"/>
+                </a:solidFill>
+                <a:latin typeface="Arial"/>
+              </a:rPr>
+              <a:t>Act III · forward</a:t>
+            </a:r>
           </a:p>
         </p:txBody>
       </p:sp>
@@ -10772,7 +8604,7 @@
         <p:spPr>
           <a:xfrm>
             <a:off x="411475" y="795525"/>
-            <a:ext cx="8321100" cy="2811000"/>
+            <a:ext cx="0" cy="0"/>
           </a:xfrm>
           <a:prstGeom prst="rect">
             <a:avLst/>
@@ -10788,7 +8620,7 @@
           </a:bodyPr>
           <a:lstStyle/>
           <a:p>
-            <a:pPr marL="457200" marR="0" indent="-307975" algn="l" rtl="0">
+            <a:pPr marL="457200" marR="0" lvl="0" indent="-307975" algn="l" rtl="0">
               <a:lnSpc>
                 <a:spcPct val="115000"/>
               </a:lnSpc>
@@ -10805,15 +8637,6 @@
               <a:buFont typeface="Arial"/>
               <a:buChar char="●"/>
             </a:pPr>
-            <a:r>
-              <a:rPr sz="1300">
-                <a:solidFill>
-                  <a:srgbClr val="556677"/>
-                </a:solidFill>
-                <a:latin typeface="Arial"/>
-              </a:rPr>
-              <a:t>Beat 4 · optional detail</a:t>
-            </a:r>
             <a:endParaRPr sz="1250" b="0" i="0" u="none" strike="noStrike" cap="none">
               <a:solidFill>
                 <a:schemeClr val="dk1"/>
@@ -10824,59 +8647,32 @@
               <a:sym typeface="Arial"/>
             </a:endParaRPr>
           </a:p>
-          <a:p>
-            <a:pPr/>
-            <a:r>
-              <a:rPr sz="1300">
-                <a:solidFill>
-                  <a:srgbClr val="333333"/>
-                </a:solidFill>
-                <a:latin typeface="Arial"/>
-              </a:rPr>
-              <a:t>Only if Gururaj asks — each block needs AV + software proof before silicon.</a:t>
-            </a:r>
-          </a:p>
-          <a:p>
-            <a:pPr/>
-          </a:p>
-          <a:p>
-            <a:pPr/>
-            <a:r>
-              <a:rPr sz="1300">
-                <a:solidFill>
-                  <a:srgbClr val="333333"/>
-                </a:solidFill>
-                <a:latin typeface="Arial"/>
-              </a:rPr>
-              <a:t>Ingress / Parser — parse correctness with Rupa before OCP/BCM calls</a:t>
-            </a:r>
-          </a:p>
-          <a:p>
-            <a:pPr/>
-            <a:r>
-              <a:rPr sz="1300">
-                <a:solidFill>
-                  <a:srgbClr val="333333"/>
-                </a:solidFill>
-                <a:latin typeface="Arial"/>
-              </a:rPr>
-              <a:t>L2 — Shafi · Tilak · L3 — Girish · Forward: ECMP/LAG/Counters (Tippanna), QoSMAP (me) · Egress Queue/carve (me)</a:t>
-            </a:r>
-          </a:p>
-          <a:p>
-            <a:pPr/>
-            <a:r>
-              <a:rPr sz="1300">
-                <a:solidFill>
-                  <a:srgbClr val="333333"/>
-                </a:solidFill>
-                <a:latin typeface="Arial"/>
-              </a:rPr>
-              <a:t>I draft cross-block tape-out gates; block DRIs own slice proof (C-model → emulation)</a:t>
-            </a:r>
-          </a:p>
         </p:txBody>
       </p:sp>
+      <p:pic>
+        <p:nvPicPr>
+          <p:cNvPr id="125" name="Picture 124" descr="b6-slide07-next-steps.png"/>
+          <p:cNvPicPr>
+            <a:picLocks noChangeAspect="1"/>
+          </p:cNvPicPr>
+          <p:nvPr/>
+        </p:nvPicPr>
+        <p:blipFill>
+          <a:blip r:embed="rId3"/>
+          <a:stretch>
+            <a:fillRect/>
+          </a:stretch>
+        </p:blipFill>
+        <p:spPr>
+          <a:xfrm>
+            <a:off x="3118672" y="1508760"/>
+            <a:ext cx="2906656" cy="3246120"/>
+          </a:xfrm>
+          <a:prstGeom prst="rect">
+            <a:avLst/>
+          </a:prstGeom>
+        </p:spPr>
+      </p:pic>
     </p:spTree>
   </p:cSld>
   <p:clrMapOvr>

</xml_diff>

<commit_message>
P0 DT122: B6 pipeline — subtitle, lead, caption on diagram slides
pptx_util/build-dt100-decks: separate act subtitle, lead, and caption on diagram slides.

render_b6_diagrams: W-order peer labels, Queue label, cross-platform fonts; regen b6 pngs + bugatti-qos-ccc.pptx.
</commit_message>
<xml_diff>
--- a/dt122/bugatti-qos-ccc.pptx
+++ b/dt122/bugatti-qos-ccc.pptx
@@ -5486,11 +5486,27 @@
             <a:r>
               <a:rPr sz="1300">
                 <a:solidFill>
-                  <a:srgbClr val="556677"/>
+                  <a:srgbClr val="FFE19E"/>
                 </a:solidFill>
                 <a:latin typeface="Arial"/>
               </a:rPr>
               <a:t>Act I · broad strokes</a:t>
+            </a:r>
+          </a:p>
+          <a:p>
+            <a:pPr>
+              <a:spcAft>
+                <a:spcPts val="300"/>
+              </a:spcAft>
+            </a:pPr>
+            <a:r>
+              <a:rPr sz="1300">
+                <a:solidFill>
+                  <a:srgbClr val="556677"/>
+                </a:solidFill>
+                <a:latin typeface="Arial"/>
+              </a:rPr>
+              <a:t>A3 framed situation + task — this deck shows how we execute.</a:t>
             </a:r>
           </a:p>
         </p:txBody>
@@ -5956,11 +5972,27 @@
             <a:r>
               <a:rPr sz="1300">
                 <a:solidFill>
-                  <a:srgbClr val="556677"/>
+                  <a:srgbClr val="FFE19E"/>
                 </a:solidFill>
                 <a:latin typeface="Arial"/>
               </a:rPr>
               <a:t>Act II · focus</a:t>
+            </a:r>
+          </a:p>
+          <a:p>
+            <a:pPr>
+              <a:spcAft>
+                <a:spcPts val="300"/>
+              </a:spcAft>
+            </a:pPr>
+            <a:r>
+              <a:rPr sz="1300">
+                <a:solidFill>
+                  <a:srgbClr val="556677"/>
+                </a:solidFill>
+                <a:latin typeface="Arial"/>
+              </a:rPr>
+              <a:t>v0 gates for group review — not unilateral.</a:t>
             </a:r>
           </a:p>
         </p:txBody>
@@ -6426,11 +6458,43 @@
             <a:r>
               <a:rPr sz="1300">
                 <a:solidFill>
-                  <a:srgbClr val="556677"/>
+                  <a:srgbClr val="FFE19E"/>
                 </a:solidFill>
                 <a:latin typeface="Arial"/>
               </a:rPr>
               <a:t>Act II · center of walk</a:t>
+            </a:r>
+          </a:p>
+          <a:p>
+            <a:pPr>
+              <a:spcAft>
+                <a:spcPts val="300"/>
+              </a:spcAft>
+            </a:pPr>
+            <a:r>
+              <a:rPr sz="1300">
+                <a:solidFill>
+                  <a:srgbClr val="556677"/>
+                </a:solidFill>
+                <a:latin typeface="Arial"/>
+              </a:rPr>
+              <a:t>QoSMAP + Queue = my lane; peers on their blocks.</a:t>
+            </a:r>
+          </a:p>
+          <a:p>
+            <a:pPr>
+              <a:spcAft>
+                <a:spcPts val="300"/>
+              </a:spcAft>
+            </a:pPr>
+            <a:r>
+              <a:rPr sz="1100">
+                <a:solidFill>
+                  <a:srgbClr val="333333"/>
+                </a:solidFill>
+                <a:latin typeface="Arial"/>
+              </a:rPr>
+              <a:t>Shafi · Tippanna · Tilak · Girish · Rupa — W order on the picture.</a:t>
             </a:r>
           </a:p>
         </p:txBody>
@@ -6896,11 +6960,27 @@
             <a:r>
               <a:rPr sz="1300">
                 <a:solidFill>
-                  <a:srgbClr val="556677"/>
+                  <a:srgbClr val="FFE19E"/>
                 </a:solidFill>
                 <a:latin typeface="Arial"/>
               </a:rPr>
               <a:t>Act II · egress wedge</a:t>
+            </a:r>
+          </a:p>
+          <a:p>
+            <a:pPr>
+              <a:spcAft>
+                <a:spcPts val="300"/>
+              </a:spcAft>
+            </a:pPr>
+            <a:r>
+              <a:rPr sz="1300">
+                <a:solidFill>
+                  <a:srgbClr val="556677"/>
+                </a:solidFill>
+                <a:latin typeface="Arial"/>
+              </a:rPr>
+              <a:t>Process outcome — carve plan + gate v0 in the next few days.</a:t>
             </a:r>
           </a:p>
         </p:txBody>
@@ -7366,11 +7446,27 @@
             <a:r>
               <a:rPr sz="1300">
                 <a:solidFill>
-                  <a:srgbClr val="556677"/>
+                  <a:srgbClr val="FFE19E"/>
                 </a:solidFill>
                 <a:latin typeface="Arial"/>
               </a:rPr>
               <a:t>Act III · review</a:t>
+            </a:r>
+          </a:p>
+          <a:p>
+            <a:pPr>
+              <a:spcAft>
+                <a:spcPts val="300"/>
+              </a:spcAft>
+            </a:pPr>
+            <a:r>
+              <a:rPr sz="1300">
+                <a:solidFill>
+                  <a:srgbClr val="556677"/>
+                </a:solidFill>
+                <a:latin typeface="Arial"/>
+              </a:rPr>
+              <a:t>Don’t read every row — point at the matrix.</a:t>
             </a:r>
           </a:p>
         </p:txBody>
@@ -7836,11 +7932,27 @@
             <a:r>
               <a:rPr sz="1300">
                 <a:solidFill>
-                  <a:srgbClr val="556677"/>
+                  <a:srgbClr val="FFE19E"/>
                 </a:solidFill>
                 <a:latin typeface="Arial"/>
               </a:rPr>
               <a:t>Act III · defer</a:t>
+            </a:r>
+          </a:p>
+          <a:p>
+            <a:pPr>
+              <a:spcAft>
+                <a:spcPts val="300"/>
+              </a:spcAft>
+            </a:pPr>
+            <a:r>
+              <a:rPr sz="1300">
+                <a:solidFill>
+                  <a:srgbClr val="556677"/>
+                </a:solidFill>
+                <a:latin typeface="Arial"/>
+              </a:rPr>
+              <a:t>Weekly sync on adjacent threads — no scope merge this walk.</a:t>
             </a:r>
           </a:p>
         </p:txBody>
@@ -8195,8 +8307,8 @@
         </p:blipFill>
         <p:spPr>
           <a:xfrm>
-            <a:off x="586190" y="1508760"/>
-            <a:ext cx="7971619" cy="3246120"/>
+            <a:off x="724550" y="1508760"/>
+            <a:ext cx="7694900" cy="3246120"/>
           </a:xfrm>
           <a:prstGeom prst="rect">
             <a:avLst/>
@@ -8306,11 +8418,27 @@
             <a:r>
               <a:rPr sz="1300">
                 <a:solidFill>
-                  <a:srgbClr val="556677"/>
+                  <a:srgbClr val="FFE19E"/>
                 </a:solidFill>
                 <a:latin typeface="Arial"/>
               </a:rPr>
               <a:t>Act III · forward</a:t>
+            </a:r>
+          </a:p>
+          <a:p>
+            <a:pPr>
+              <a:spcAft>
+                <a:spcPts val="300"/>
+              </a:spcAft>
+            </a:pPr>
+            <a:r>
+              <a:rPr sz="1300">
+                <a:solidFill>
+                  <a:srgbClr val="556677"/>
+                </a:solidFill>
+                <a:latin typeface="Arial"/>
+              </a:rPr>
+              <a:t>Offer only if asked — peer huddle follows homework.</a:t>
             </a:r>
           </a:p>
         </p:txBody>

</xml_diff>

<commit_message>
P0 DT122: rubber-band B6 — CCC frame, W log hooks, qos wedge Rev 0.1
Six content slides: CCC vocabulary, pipeline hooks, classify interface, CSB carve, HW TODO, next steps.

Regen from W CCC log (local vault); peer decks not in git.

Co-authored-by: Cursor <cursoragent@cursor.com>
</commit_message>
<xml_diff>
--- a/dt122/bugatti-qos-ccc.pptx
+++ b/dt122/bugatti-qos-ccc.pptx
@@ -15,7 +15,6 @@
     <p:sldId id="261" r:id="rId10"/>
     <p:sldId id="262" r:id="rId11"/>
     <p:sldId id="263" r:id="rId12"/>
-    <p:sldId id="264" r:id="rId13"/>
   </p:sldIdLst>
   <p:sldSz cx="9144000" cy="5143500" type="screen16x9"/>
   <p:notesSz cx="5143500" cy="9144000"/>
@@ -2900,178 +2899,6 @@
             <a:fld id="{00000000-1234-1234-1234-123412341234}" type="slidenum">
               <a:rPr lang="en-US"/>
               <a:t>8</a:t>
-            </a:fld>
-            <a:endParaRPr/>
-          </a:p>
-        </p:txBody>
-      </p:sp>
-    </p:spTree>
-  </p:cSld>
-  <p:clrMapOvr>
-    <a:masterClrMapping/>
-  </p:clrMapOvr>
-</p:notes>
-</file>
-
-<file path=ppt/notesSlides/notesSlide9.xml><?xml version="1.0" encoding="utf-8"?>
-<p:notes xmlns:a="http://schemas.openxmlformats.org/drawingml/2006/main" xmlns:r="http://schemas.openxmlformats.org/officeDocument/2006/relationships" xmlns:p="http://schemas.openxmlformats.org/presentationml/2006/main" showMasterSp="0" showMasterPhAnim="0">
-  <p:cSld>
-    <p:spTree>
-      <p:nvGrpSpPr>
-        <p:cNvPr id="1" name="Shape 114"/>
-        <p:cNvGrpSpPr/>
-        <p:nvPr/>
-      </p:nvGrpSpPr>
-      <p:grpSpPr>
-        <a:xfrm>
-          <a:off x="0" y="0"/>
-          <a:ext cx="0" cy="0"/>
-          <a:chOff x="0" y="0"/>
-          <a:chExt cx="0" cy="0"/>
-        </a:xfrm>
-      </p:grpSpPr>
-      <p:sp>
-        <p:nvSpPr>
-          <p:cNvPr id="115" name="Google Shape;115;g3d542e4bd64_0_20:notes"/>
-          <p:cNvSpPr>
-            <a:spLocks noGrp="1" noRot="1" noChangeAspect="1"/>
-          </p:cNvSpPr>
-          <p:nvPr>
-            <p:ph type="sldImg" idx="2"/>
-          </p:nvPr>
-        </p:nvSpPr>
-        <p:spPr>
-          <a:xfrm>
-            <a:off x="685800" y="1143000"/>
-            <a:ext cx="5486400" cy="3086100"/>
-          </a:xfrm>
-          <a:custGeom>
-            <a:avLst/>
-            <a:gdLst/>
-            <a:ahLst/>
-            <a:cxnLst/>
-            <a:rect l="l" t="t" r="r" b="b"/>
-            <a:pathLst>
-              <a:path w="120000" h="120000" extrusionOk="0">
-                <a:moveTo>
-                  <a:pt x="0" y="0"/>
-                </a:moveTo>
-                <a:lnTo>
-                  <a:pt x="120000" y="0"/>
-                </a:lnTo>
-                <a:lnTo>
-                  <a:pt x="120000" y="120000"/>
-                </a:lnTo>
-                <a:lnTo>
-                  <a:pt x="0" y="120000"/>
-                </a:lnTo>
-                <a:close/>
-              </a:path>
-            </a:pathLst>
-          </a:custGeom>
-          <a:noFill/>
-          <a:ln w="12700" cap="flat" cmpd="sng">
-            <a:solidFill>
-              <a:srgbClr val="000000"/>
-            </a:solidFill>
-            <a:prstDash val="solid"/>
-            <a:round/>
-            <a:headEnd type="none" w="sm" len="sm"/>
-            <a:tailEnd type="none" w="sm" len="sm"/>
-          </a:ln>
-        </p:spPr>
-      </p:sp>
-      <p:sp>
-        <p:nvSpPr>
-          <p:cNvPr id="116" name="Google Shape;116;g3d542e4bd64_0_20:notes"/>
-          <p:cNvSpPr txBox="1">
-            <a:spLocks noGrp="1"/>
-          </p:cNvSpPr>
-          <p:nvPr>
-            <p:ph type="body" idx="1"/>
-          </p:nvPr>
-        </p:nvSpPr>
-        <p:spPr>
-          <a:xfrm>
-            <a:off x="685800" y="4400550"/>
-            <a:ext cx="5486400" cy="3600600"/>
-          </a:xfrm>
-          <a:prstGeom prst="rect">
-            <a:avLst/>
-          </a:prstGeom>
-          <a:noFill/>
-          <a:ln>
-            <a:noFill/>
-          </a:ln>
-        </p:spPr>
-        <p:txBody>
-          <a:bodyPr spcFirstLastPara="1" wrap="square" lIns="91425" tIns="45700" rIns="91425" bIns="45700" anchor="t" anchorCtr="0">
-            <a:noAutofit/>
-          </a:bodyPr>
-          <a:lstStyle/>
-          <a:p>
-            <a:pPr marL="0" lvl="0" indent="0" algn="l" rtl="0">
-              <a:lnSpc>
-                <a:spcPct val="100000"/>
-              </a:lnSpc>
-              <a:spcBef>
-                <a:spcPts val="0"/>
-              </a:spcBef>
-              <a:spcAft>
-                <a:spcPts val="0"/>
-              </a:spcAft>
-              <a:buSzPts val="1400"/>
-              <a:buNone/>
-            </a:pPr>
-            <a:endParaRPr/>
-          </a:p>
-        </p:txBody>
-      </p:sp>
-      <p:sp>
-        <p:nvSpPr>
-          <p:cNvPr id="117" name="Google Shape;117;g3d542e4bd64_0_20:notes"/>
-          <p:cNvSpPr txBox="1">
-            <a:spLocks noGrp="1"/>
-          </p:cNvSpPr>
-          <p:nvPr>
-            <p:ph type="sldNum" idx="12"/>
-          </p:nvPr>
-        </p:nvSpPr>
-        <p:spPr>
-          <a:xfrm>
-            <a:off x="3884613" y="8685213"/>
-            <a:ext cx="2971800" cy="458700"/>
-          </a:xfrm>
-          <a:prstGeom prst="rect">
-            <a:avLst/>
-          </a:prstGeom>
-          <a:noFill/>
-          <a:ln>
-            <a:noFill/>
-          </a:ln>
-        </p:spPr>
-        <p:txBody>
-          <a:bodyPr spcFirstLastPara="1" wrap="square" lIns="91425" tIns="45700" rIns="91425" bIns="45700" anchor="b" anchorCtr="0">
-            <a:noAutofit/>
-          </a:bodyPr>
-          <a:lstStyle/>
-          <a:p>
-            <a:pPr marL="0" lvl="0" indent="0" algn="r" rtl="0">
-              <a:lnSpc>
-                <a:spcPct val="100000"/>
-              </a:lnSpc>
-              <a:spcBef>
-                <a:spcPts val="0"/>
-              </a:spcBef>
-              <a:spcAft>
-                <a:spcPts val="0"/>
-              </a:spcAft>
-              <a:buSzPts val="1400"/>
-              <a:buNone/>
-            </a:pPr>
-            <a:fld id="{00000000-1234-1234-1234-123412341234}" type="slidenum">
-              <a:rPr lang="en-US"/>
-              <a:t>9</a:t>
             </a:fld>
             <a:endParaRPr/>
           </a:p>
@@ -4174,7 +4001,7 @@
                 <a:cs typeface="Calibri"/>
                 <a:sym typeface="Calibri"/>
               </a:rPr>
-              <a:t>Open after qos-architecture slides 1–2 — role-play, not a handoff</a:t>
+              <a:t>Open after qos-architecture slides 1–2 · Rev 0.1 draft</a:t>
             </a:r>
             <a:endParaRPr sz="1100" b="0" i="0" u="none" strike="noStrike" cap="none">
               <a:solidFill>
@@ -5089,7 +4916,7 @@
                 </a:solidFill>
                 <a:latin typeface="Calibri"/>
               </a:rPr>
-              <a:t>Walk: process → pipeline → alignment</a:t>
+              <a:t>CCC walk — Capabilities · Capacities · Constraints</a:t>
             </a:r>
             <a:endParaRPr sz="2200" b="0" i="0" u="none" strike="noStrike" cap="none">
               <a:solidFill>
@@ -5465,7 +5292,7 @@
                 </a:solidFill>
                 <a:latin typeface="Calibri"/>
               </a:rPr>
-              <a:t>The walk — five beats (process)</a:t>
+              <a:t>CCC — datapath vocabulary</a:t>
             </a:r>
             <a:endParaRPr sz="3000" b="0" i="0" u="none" strike="noStrike" cap="none">
               <a:solidFill>
@@ -5490,7 +5317,7 @@
                 </a:solidFill>
                 <a:latin typeface="Arial"/>
               </a:rPr>
-              <a:t>Act I · broad strokes</a:t>
+              <a:t>Act I · one framework</a:t>
             </a:r>
           </a:p>
           <a:p>
@@ -5506,7 +5333,7 @@
                 </a:solidFill>
                 <a:latin typeface="Arial"/>
               </a:rPr>
-              <a:t>A3 framed situation + task — this deck shows how we execute.</a:t>
+              <a:t>**Capability** = what · **Capacity** = how many · **Constraint** = how used — maps to header fields → TC → resources.</a:t>
             </a:r>
           </a:p>
         </p:txBody>
@@ -5847,7 +5674,7 @@
       </p:sp>
       <p:pic>
         <p:nvPicPr>
-          <p:cNvPr id="59" name="Picture 58" descr="b6-slide01-process-ribbon.png"/>
+          <p:cNvPr id="59" name="Picture 58" descr="b6-slide01-ccc-framework.png"/>
           <p:cNvPicPr>
             <a:picLocks noChangeAspect="1"/>
           </p:cNvPicPr>
@@ -5861,8 +5688,8 @@
         </p:blipFill>
         <p:spPr>
           <a:xfrm>
-            <a:off x="365760" y="2777224"/>
-            <a:ext cx="8412480" cy="709191"/>
+            <a:off x="3913213" y="1508760"/>
+            <a:ext cx="1317574" cy="3246120"/>
           </a:xfrm>
           <a:prstGeom prst="rect">
             <a:avLst/>
@@ -5951,7 +5778,7 @@
                 </a:solidFill>
                 <a:latin typeface="Calibri"/>
               </a:rPr>
-              <a:t>Validation machine — how we prove tape-out</a:t>
+              <a:t>Logical pipeline — W hooks on the log</a:t>
             </a:r>
             <a:endParaRPr sz="3000" b="0" i="0" u="none" strike="noStrike" cap="none">
               <a:solidFill>
@@ -5976,7 +5803,7 @@
                 </a:solidFill>
                 <a:latin typeface="Arial"/>
               </a:rPr>
-              <a:t>Act II · focus</a:t>
+              <a:t>Act I · stitch story</a:t>
             </a:r>
           </a:p>
           <a:p>
@@ -5992,7 +5819,23 @@
                 </a:solidFill>
                 <a:latin typeface="Arial"/>
               </a:rPr>
-              <a:t>v0 gates for group review — not unilateral.</a:t>
+              <a:t>Packet path picks which CCC applies — peer DRIs on their blocks; I own QoSMAP · Queue · CSB carve.</a:t>
+            </a:r>
+          </a:p>
+          <a:p>
+            <a:pPr>
+              <a:spcAft>
+                <a:spcPts val="300"/>
+              </a:spcAft>
+            </a:pPr>
+            <a:r>
+              <a:rPr sz="1100">
+                <a:solidFill>
+                  <a:srgbClr val="333333"/>
+                </a:solidFill>
+                <a:latin typeface="Arial"/>
+              </a:rPr>
+              <a:t>L2 Tilak · L3/ESUN Girish · ACL Shrawan · ECMP Hongal · QoS classify Shrawan · carve Diwakar · Mirror Shafi.</a:t>
             </a:r>
           </a:p>
         </p:txBody>
@@ -6333,7 +6176,7 @@
       </p:sp>
       <p:pic>
         <p:nvPicPr>
-          <p:cNvPr id="70" name="Picture 69" descr="b6-slide02-validation-stack.png"/>
+          <p:cNvPr id="70" name="Picture 69" descr="b6-slide03-pipeline-annotated.png"/>
           <p:cNvPicPr>
             <a:picLocks noChangeAspect="1"/>
           </p:cNvPicPr>
@@ -6347,8 +6190,8 @@
         </p:blipFill>
         <p:spPr>
           <a:xfrm>
-            <a:off x="2695036" y="1508760"/>
-            <a:ext cx="3753928" cy="3246120"/>
+            <a:off x="1681542" y="1508760"/>
+            <a:ext cx="5780916" cy="3246120"/>
           </a:xfrm>
           <a:prstGeom prst="rect">
             <a:avLst/>
@@ -6437,7 +6280,7 @@
                 </a:solidFill>
                 <a:latin typeface="Calibri"/>
               </a:rPr>
-              <a:t>Logical pipeline — my wedge on your slide</a:t>
+              <a:t>QoS classify &amp; remark — W lane (interface)</a:t>
             </a:r>
             <a:endParaRPr sz="3000" b="0" i="0" u="none" strike="noStrike" cap="none">
               <a:solidFill>
@@ -6462,7 +6305,7 @@
                 </a:solidFill>
                 <a:latin typeface="Arial"/>
               </a:rPr>
-              <a:t>Act II · center of walk</a:t>
+              <a:t>Act II · upstream of carve</a:t>
             </a:r>
           </a:p>
           <a:p>
@@ -6478,23 +6321,7 @@
                 </a:solidFill>
                 <a:latin typeface="Arial"/>
               </a:rPr>
-              <a:t>QoSMAP + Queue = my lane; peers on their blocks.</a:t>
-            </a:r>
-          </a:p>
-          <a:p>
-            <a:pPr>
-              <a:spcAft>
-                <a:spcPts val="300"/>
-              </a:spcAft>
-            </a:pPr>
-            <a:r>
-              <a:rPr sz="1100">
-                <a:solidFill>
-                  <a:srgbClr val="333333"/>
-                </a:solidFill>
-                <a:latin typeface="Arial"/>
-              </a:rPr>
-              <a:t>Shafi · Tippanna · Tilak · Girish · Rupa — W order on the picture.</a:t>
+              <a:t>TC from VLAN .1p · DSCP · ESUN CoS · UFH DSCP — remark on egress; ACL can override. Detail in peer QoS Classification CCC.</a:t>
             </a:r>
           </a:p>
         </p:txBody>
@@ -6835,7 +6662,7 @@
       </p:sp>
       <p:pic>
         <p:nvPicPr>
-          <p:cNvPr id="81" name="Picture 80" descr="b6-slide03-pipeline-annotated.png"/>
+          <p:cNvPr id="81" name="Picture 80" descr="b6-slide04-qos-stitch.png"/>
           <p:cNvPicPr>
             <a:picLocks noChangeAspect="1"/>
           </p:cNvPicPr>
@@ -6849,8 +6676,8 @@
         </p:blipFill>
         <p:spPr>
           <a:xfrm>
-            <a:off x="1681542" y="1508760"/>
-            <a:ext cx="5780916" cy="3246120"/>
+            <a:off x="365760" y="2814161"/>
+            <a:ext cx="8412480" cy="635317"/>
           </a:xfrm>
           <a:prstGeom prst="rect">
             <a:avLst/>
@@ -6939,7 +6766,7 @@
                 </a:solidFill>
                 <a:latin typeface="Calibri"/>
               </a:rPr>
-              <a:t>Buffer carve @ CSB</a:t>
+              <a:t>Buffer carve @ CSB — my wedge</a:t>
             </a:r>
             <a:endParaRPr sz="3000" b="0" i="0" u="none" strike="noStrike" cap="none">
               <a:solidFill>
@@ -6964,7 +6791,7 @@
                 </a:solidFill>
                 <a:latin typeface="Arial"/>
               </a:rPr>
-              <a:t>Act II · egress wedge</a:t>
+              <a:t>Act II · qos-arch focus</a:t>
             </a:r>
           </a:p>
           <a:p>
@@ -6980,7 +6807,7 @@
                 </a:solidFill>
                 <a:latin typeface="Arial"/>
               </a:rPr>
-              <a:t>Process outcome — carve plan + gate v0 in the next few days.</a:t>
+              <a:t>**Capability:** pool modes · sharing · lossy/lossless · **Capacity:** carve sizes · port tiers · **Constraint:** admission · PFC · speed coherence — v0 draft.</a:t>
             </a:r>
           </a:p>
         </p:txBody>
@@ -7425,7 +7252,7 @@
                 </a:solidFill>
                 <a:latin typeface="Calibri"/>
               </a:rPr>
-              <a:t>Who aligns on which gate</a:t>
+              <a:t>Scope · HW TODO · peer CCC refs</a:t>
             </a:r>
             <a:endParaRPr sz="3000" b="0" i="0" u="none" strike="noStrike" cap="none">
               <a:solidFill>
@@ -7450,7 +7277,7 @@
                 </a:solidFill>
                 <a:latin typeface="Arial"/>
               </a:rPr>
-              <a:t>Act III · review</a:t>
+              <a:t>Act III · boundaries</a:t>
             </a:r>
           </a:p>
           <a:p>
@@ -7466,7 +7293,7 @@
                 </a:solidFill>
                 <a:latin typeface="Arial"/>
               </a:rPr>
-              <a:t>Don’t read every row — point at the matrix.</a:t>
+              <a:t>In this walk vs deferred; cross-decks by reference (ECMP capacity in ECMP CCC, etc.).</a:t>
             </a:r>
           </a:p>
         </p:txBody>
@@ -7807,7 +7634,7 @@
       </p:sp>
       <p:pic>
         <p:nvPicPr>
-          <p:cNvPr id="103" name="Picture 102" descr="b6-slide05-gate-alignment.png"/>
+          <p:cNvPr id="103" name="Picture 102" descr="b6-slide06-boundaries.png"/>
           <p:cNvPicPr>
             <a:picLocks noChangeAspect="1"/>
           </p:cNvPicPr>
@@ -7821,8 +7648,8 @@
         </p:blipFill>
         <p:spPr>
           <a:xfrm>
-            <a:off x="2547274" y="1508760"/>
-            <a:ext cx="4049452" cy="3246120"/>
+            <a:off x="365760" y="1594106"/>
+            <a:ext cx="8412480" cy="3075428"/>
           </a:xfrm>
           <a:prstGeom prst="rect">
             <a:avLst/>
@@ -7911,7 +7738,7 @@
                 </a:solidFill>
                 <a:latin typeface="Calibri"/>
               </a:rPr>
-              <a:t>Boundaries — in this walk vs not merged</a:t>
+              <a:t>Rev 0.1 · next steps</a:t>
             </a:r>
             <a:endParaRPr sz="3000" b="0" i="0" u="none" strike="noStrike" cap="none">
               <a:solidFill>
@@ -7936,7 +7763,7 @@
                 </a:solidFill>
                 <a:latin typeface="Arial"/>
               </a:rPr>
-              <a:t>Act III · defer</a:t>
+              <a:t>Act III · forward</a:t>
             </a:r>
           </a:p>
           <a:p>
@@ -7952,7 +7779,7 @@
                 </a:solidFill>
                 <a:latin typeface="Arial"/>
               </a:rPr>
-              <a:t>Weekly sync on adjacent threads — no scope merge this walk.</a:t>
+              <a:t>Draft for steer — peer lane edits welcome; Friday walk if aligned.</a:t>
             </a:r>
           </a:p>
         </p:txBody>
@@ -8293,493 +8120,7 @@
       </p:sp>
       <p:pic>
         <p:nvPicPr>
-          <p:cNvPr id="114" name="Picture 113" descr="b6-slide06-boundaries.png"/>
-          <p:cNvPicPr>
-            <a:picLocks noChangeAspect="1"/>
-          </p:cNvPicPr>
-          <p:nvPr/>
-        </p:nvPicPr>
-        <p:blipFill>
-          <a:blip r:embed="rId3"/>
-          <a:stretch>
-            <a:fillRect/>
-          </a:stretch>
-        </p:blipFill>
-        <p:spPr>
-          <a:xfrm>
-            <a:off x="724550" y="1508760"/>
-            <a:ext cx="7694900" cy="3246120"/>
-          </a:xfrm>
-          <a:prstGeom prst="rect">
-            <a:avLst/>
-          </a:prstGeom>
-        </p:spPr>
-      </p:pic>
-    </p:spTree>
-  </p:cSld>
-  <p:clrMapOvr>
-    <a:masterClrMapping/>
-  </p:clrMapOvr>
-</p:sld>
-</file>
-
-<file path=ppt/slides/slide9.xml><?xml version="1.0" encoding="utf-8"?>
-<p:sld xmlns:a="http://schemas.openxmlformats.org/drawingml/2006/main" xmlns:r="http://schemas.openxmlformats.org/officeDocument/2006/relationships" xmlns:p="http://schemas.openxmlformats.org/presentationml/2006/main">
-  <p:cSld>
-    <p:bg>
-      <p:bgPr>
-        <a:solidFill>
-          <a:srgbClr val="FFFFFF"/>
-        </a:solidFill>
-        <a:effectLst/>
-      </p:bgPr>
-    </p:bg>
-    <p:spTree>
-      <p:nvGrpSpPr>
-        <p:cNvPr id="1" name="Shape 118"/>
-        <p:cNvGrpSpPr/>
-        <p:nvPr/>
-      </p:nvGrpSpPr>
-      <p:grpSpPr>
-        <a:xfrm>
-          <a:off x="0" y="0"/>
-          <a:ext cx="0" cy="0"/>
-          <a:chOff x="0" y="0"/>
-          <a:chExt cx="0" cy="0"/>
-        </a:xfrm>
-      </p:grpSpPr>
-      <p:sp>
-        <p:nvSpPr>
-          <p:cNvPr id="119" name="Google Shape;119;g3d542e4bd64_0_20"/>
-          <p:cNvSpPr/>
-          <p:nvPr/>
-        </p:nvSpPr>
-        <p:spPr>
-          <a:xfrm>
-            <a:off x="411480" y="201168"/>
-            <a:ext cx="8321100" cy="594300"/>
-          </a:xfrm>
-          <a:prstGeom prst="rect">
-            <a:avLst/>
-          </a:prstGeom>
-          <a:noFill/>
-          <a:ln>
-            <a:noFill/>
-          </a:ln>
-        </p:spPr>
-        <p:txBody>
-          <a:bodyPr spcFirstLastPara="1" wrap="none" lIns="91425" tIns="45700" rIns="91425" bIns="45700" anchor="t" anchorCtr="0">
-            <a:noAutofit/>
-          </a:bodyPr>
-          <a:lstStyle/>
-          <a:p>
-            <a:pPr marL="0" marR="0" indent="0" algn="l" rtl="0">
-              <a:lnSpc>
-                <a:spcPct val="100000"/>
-              </a:lnSpc>
-              <a:spcBef>
-                <a:spcPts val="0"/>
-              </a:spcBef>
-              <a:spcAft>
-                <a:spcPts val="300"/>
-              </a:spcAft>
-              <a:buClr>
-                <a:srgbClr val="051830"/>
-              </a:buClr>
-              <a:buSzPts val="3000"/>
-              <a:buFont typeface="Calibri"/>
-              <a:buNone/>
-            </a:pPr>
-            <a:r>
-              <a:rPr sz="2600">
-                <a:solidFill>
-                  <a:srgbClr val="051830"/>
-                </a:solidFill>
-                <a:latin typeface="Calibri"/>
-              </a:rPr>
-              <a:t>Next steps — if you want me to drive</a:t>
-            </a:r>
-            <a:endParaRPr sz="3000" b="0" i="0" u="none" strike="noStrike" cap="none">
-              <a:solidFill>
-                <a:schemeClr val="dk1"/>
-              </a:solidFill>
-              <a:latin typeface="Calibri"/>
-              <a:ea typeface="Calibri"/>
-              <a:cs typeface="Calibri"/>
-              <a:sym typeface="Calibri"/>
-            </a:endParaRPr>
-          </a:p>
-          <a:p>
-            <a:pPr>
-              <a:spcAft>
-                <a:spcPts val="300"/>
-              </a:spcAft>
-            </a:pPr>
-            <a:r>
-              <a:rPr sz="1300">
-                <a:solidFill>
-                  <a:srgbClr val="FFE19E"/>
-                </a:solidFill>
-                <a:latin typeface="Arial"/>
-              </a:rPr>
-              <a:t>Act III · forward</a:t>
-            </a:r>
-          </a:p>
-          <a:p>
-            <a:pPr>
-              <a:spcAft>
-                <a:spcPts val="300"/>
-              </a:spcAft>
-            </a:pPr>
-            <a:r>
-              <a:rPr sz="1300">
-                <a:solidFill>
-                  <a:srgbClr val="556677"/>
-                </a:solidFill>
-                <a:latin typeface="Arial"/>
-              </a:rPr>
-              <a:t>Offer only if asked — peer huddle follows homework.</a:t>
-            </a:r>
-          </a:p>
-        </p:txBody>
-      </p:sp>
-      <p:sp>
-        <p:nvSpPr>
-          <p:cNvPr id="120" name="Google Shape;120;g3d542e4bd64_0_20"/>
-          <p:cNvSpPr/>
-          <p:nvPr/>
-        </p:nvSpPr>
-        <p:spPr>
-          <a:xfrm>
-            <a:off x="0" y="4850892"/>
-            <a:ext cx="9144000" cy="18300"/>
-          </a:xfrm>
-          <a:prstGeom prst="rect">
-            <a:avLst/>
-          </a:prstGeom>
-          <a:solidFill>
-            <a:srgbClr val="C8A85A"/>
-          </a:solidFill>
-          <a:ln w="12700" cap="flat" cmpd="sng">
-            <a:solidFill>
-              <a:srgbClr val="C8A85A"/>
-            </a:solidFill>
-            <a:prstDash val="solid"/>
-            <a:round/>
-            <a:headEnd type="none" w="sm" len="sm"/>
-            <a:tailEnd type="none" w="sm" len="sm"/>
-          </a:ln>
-        </p:spPr>
-        <p:txBody>
-          <a:bodyPr spcFirstLastPara="1" wrap="square" lIns="91425" tIns="91425" rIns="91425" bIns="91425" anchor="ctr" anchorCtr="0">
-            <a:noAutofit/>
-          </a:bodyPr>
-          <a:lstStyle/>
-          <a:p>
-            <a:pPr marL="0" marR="0" lvl="0" indent="0" algn="l" rtl="0">
-              <a:lnSpc>
-                <a:spcPct val="100000"/>
-              </a:lnSpc>
-              <a:spcBef>
-                <a:spcPts val="0"/>
-              </a:spcBef>
-              <a:spcAft>
-                <a:spcPts val="0"/>
-              </a:spcAft>
-              <a:buClr>
-                <a:srgbClr val="000000"/>
-              </a:buClr>
-              <a:buSzPts val="1400"/>
-              <a:buFont typeface="Arial"/>
-              <a:buNone/>
-            </a:pPr>
-            <a:endParaRPr sz="1400" b="0" i="0" u="none" strike="noStrike" cap="none">
-              <a:solidFill>
-                <a:srgbClr val="000000"/>
-              </a:solidFill>
-              <a:latin typeface="Arial"/>
-              <a:ea typeface="Arial"/>
-              <a:cs typeface="Arial"/>
-              <a:sym typeface="Arial"/>
-            </a:endParaRPr>
-          </a:p>
-        </p:txBody>
-      </p:sp>
-      <p:sp>
-        <p:nvSpPr>
-          <p:cNvPr id="121" name="Google Shape;121;g3d542e4bd64_0_20"/>
-          <p:cNvSpPr/>
-          <p:nvPr/>
-        </p:nvSpPr>
-        <p:spPr>
-          <a:xfrm>
-            <a:off x="0" y="4869180"/>
-            <a:ext cx="9144000" cy="274200"/>
-          </a:xfrm>
-          <a:prstGeom prst="rect">
-            <a:avLst/>
-          </a:prstGeom>
-          <a:solidFill>
-            <a:srgbClr val="F4F6FA"/>
-          </a:solidFill>
-          <a:ln w="12700" cap="flat" cmpd="sng">
-            <a:solidFill>
-              <a:srgbClr val="F4F6FA"/>
-            </a:solidFill>
-            <a:prstDash val="solid"/>
-            <a:round/>
-            <a:headEnd type="none" w="sm" len="sm"/>
-            <a:tailEnd type="none" w="sm" len="sm"/>
-          </a:ln>
-        </p:spPr>
-        <p:txBody>
-          <a:bodyPr spcFirstLastPara="1" wrap="square" lIns="91425" tIns="91425" rIns="91425" bIns="91425" anchor="ctr" anchorCtr="0">
-            <a:noAutofit/>
-          </a:bodyPr>
-          <a:lstStyle/>
-          <a:p>
-            <a:pPr marL="0" marR="0" lvl="0" indent="0" algn="l" rtl="0">
-              <a:lnSpc>
-                <a:spcPct val="100000"/>
-              </a:lnSpc>
-              <a:spcBef>
-                <a:spcPts val="0"/>
-              </a:spcBef>
-              <a:spcAft>
-                <a:spcPts val="0"/>
-              </a:spcAft>
-              <a:buClr>
-                <a:srgbClr val="000000"/>
-              </a:buClr>
-              <a:buSzPts val="1400"/>
-              <a:buFont typeface="Arial"/>
-              <a:buNone/>
-            </a:pPr>
-            <a:endParaRPr sz="1400" b="0" i="0" u="none" strike="noStrike" cap="none">
-              <a:solidFill>
-                <a:srgbClr val="000000"/>
-              </a:solidFill>
-              <a:latin typeface="Arial"/>
-              <a:ea typeface="Arial"/>
-              <a:cs typeface="Arial"/>
-              <a:sym typeface="Arial"/>
-            </a:endParaRPr>
-          </a:p>
-        </p:txBody>
-      </p:sp>
-      <p:sp>
-        <p:nvSpPr>
-          <p:cNvPr id="122" name="Google Shape;122;g3d542e4bd64_0_20"/>
-          <p:cNvSpPr/>
-          <p:nvPr/>
-        </p:nvSpPr>
-        <p:spPr>
-          <a:xfrm>
-            <a:off x="274320" y="4887468"/>
-            <a:ext cx="7772400" cy="201300"/>
-          </a:xfrm>
-          <a:prstGeom prst="rect">
-            <a:avLst/>
-          </a:prstGeom>
-          <a:noFill/>
-          <a:ln>
-            <a:noFill/>
-          </a:ln>
-        </p:spPr>
-        <p:txBody>
-          <a:bodyPr spcFirstLastPara="1" wrap="square" lIns="91425" tIns="45700" rIns="91425" bIns="45700" anchor="ctr" anchorCtr="0">
-            <a:noAutofit/>
-          </a:bodyPr>
-          <a:lstStyle/>
-          <a:p>
-            <a:pPr marL="0" marR="0" lvl="0" indent="0" algn="ctr" rtl="0">
-              <a:lnSpc>
-                <a:spcPct val="100000"/>
-              </a:lnSpc>
-              <a:spcBef>
-                <a:spcPts val="0"/>
-              </a:spcBef>
-              <a:spcAft>
-                <a:spcPts val="0"/>
-              </a:spcAft>
-              <a:buClr>
-                <a:srgbClr val="888888"/>
-              </a:buClr>
-              <a:buSzPts val="700"/>
-              <a:buFont typeface="Calibri"/>
-              <a:buNone/>
-            </a:pPr>
-            <a:r>
-              <a:rPr lang="en-US" sz="700" b="0" i="0" u="none" strike="noStrike" cap="none">
-                <a:solidFill>
-                  <a:srgbClr val="888888"/>
-                </a:solidFill>
-                <a:latin typeface="Calibri"/>
-                <a:ea typeface="Calibri"/>
-                <a:cs typeface="Calibri"/>
-                <a:sym typeface="Calibri"/>
-              </a:rPr>
-              <a:t>© 2026 Upscale AI – Proprietary and Confidential – Do Not Reproduce or Duplicate</a:t>
-            </a:r>
-            <a:endParaRPr sz="700" b="0" i="0" u="none" strike="noStrike" cap="none">
-              <a:solidFill>
-                <a:schemeClr val="dk1"/>
-              </a:solidFill>
-              <a:latin typeface="Calibri"/>
-              <a:ea typeface="Calibri"/>
-              <a:cs typeface="Calibri"/>
-              <a:sym typeface="Calibri"/>
-            </a:endParaRPr>
-          </a:p>
-        </p:txBody>
-      </p:sp>
-      <p:sp>
-        <p:nvSpPr>
-          <p:cNvPr id="123" name="Google Shape;123;g3d542e4bd64_0_20"/>
-          <p:cNvSpPr/>
-          <p:nvPr/>
-        </p:nvSpPr>
-        <p:spPr>
-          <a:xfrm>
-            <a:off x="7863840" y="4887468"/>
-            <a:ext cx="1097400" cy="201300"/>
-          </a:xfrm>
-          <a:prstGeom prst="rect">
-            <a:avLst/>
-          </a:prstGeom>
-          <a:noFill/>
-          <a:ln>
-            <a:noFill/>
-          </a:ln>
-        </p:spPr>
-        <p:txBody>
-          <a:bodyPr spcFirstLastPara="1" wrap="square" lIns="91425" tIns="45700" rIns="91425" bIns="45700" anchor="ctr" anchorCtr="0">
-            <a:noAutofit/>
-          </a:bodyPr>
-          <a:lstStyle/>
-          <a:p>
-            <a:pPr marL="0" marR="0" lvl="0" indent="0" algn="r" rtl="0">
-              <a:lnSpc>
-                <a:spcPct val="100000"/>
-              </a:lnSpc>
-              <a:spcBef>
-                <a:spcPts val="0"/>
-              </a:spcBef>
-              <a:spcAft>
-                <a:spcPts val="0"/>
-              </a:spcAft>
-              <a:buClr>
-                <a:srgbClr val="FFE19E"/>
-              </a:buClr>
-              <a:buSzPts val="800"/>
-              <a:buFont typeface="Calibri"/>
-              <a:buNone/>
-            </a:pPr>
-            <a:r>
-              <a:rPr lang="en-US" sz="800" b="1" i="0" u="none" strike="noStrike" cap="none">
-                <a:solidFill>
-                  <a:srgbClr val="FFE19E"/>
-                </a:solidFill>
-                <a:latin typeface="Calibri"/>
-                <a:ea typeface="Calibri"/>
-                <a:cs typeface="Calibri"/>
-                <a:sym typeface="Calibri"/>
-              </a:rPr>
-              <a:t>UP </a:t>
-            </a:r>
-            <a:r>
-              <a:rPr lang="en-US" sz="900" b="1" i="0" u="none" strike="noStrike" cap="none">
-                <a:solidFill>
-                  <a:srgbClr val="FFE19E"/>
-                </a:solidFill>
-                <a:latin typeface="Calibri"/>
-                <a:ea typeface="Calibri"/>
-                <a:cs typeface="Calibri"/>
-                <a:sym typeface="Calibri"/>
-              </a:rPr>
-              <a:t>upscale </a:t>
-            </a:r>
-            <a:r>
-              <a:rPr lang="en-US" sz="900" b="0" i="0" u="none" strike="noStrike" cap="none">
-                <a:solidFill>
-                  <a:srgbClr val="FFE19E"/>
-                </a:solidFill>
-                <a:latin typeface="Calibri"/>
-                <a:ea typeface="Calibri"/>
-                <a:cs typeface="Calibri"/>
-                <a:sym typeface="Calibri"/>
-              </a:rPr>
-              <a:t>ai</a:t>
-            </a:r>
-            <a:endParaRPr sz="800" b="0" i="0" u="none" strike="noStrike" cap="none">
-              <a:solidFill>
-                <a:schemeClr val="dk1"/>
-              </a:solidFill>
-              <a:latin typeface="Calibri"/>
-              <a:ea typeface="Calibri"/>
-              <a:cs typeface="Calibri"/>
-              <a:sym typeface="Calibri"/>
-            </a:endParaRPr>
-          </a:p>
-        </p:txBody>
-      </p:sp>
-      <p:sp>
-        <p:nvSpPr>
-          <p:cNvPr id="124" name="Google Shape;124;g3d542e4bd64_0_20"/>
-          <p:cNvSpPr txBox="1"/>
-          <p:nvPr/>
-        </p:nvSpPr>
-        <p:spPr>
-          <a:xfrm>
-            <a:off x="411475" y="795525"/>
-            <a:ext cx="0" cy="0"/>
-          </a:xfrm>
-          <a:prstGeom prst="rect">
-            <a:avLst/>
-          </a:prstGeom>
-          <a:noFill/>
-          <a:ln>
-            <a:noFill/>
-          </a:ln>
-        </p:spPr>
-        <p:txBody>
-          <a:bodyPr spcFirstLastPara="1" wrap="square" lIns="91425" tIns="91425" rIns="91425" bIns="91425" anchor="t" anchorCtr="0">
-            <a:spAutoFit/>
-          </a:bodyPr>
-          <a:lstStyle/>
-          <a:p>
-            <a:pPr marL="457200" marR="0" lvl="0" indent="-307975" algn="l" rtl="0">
-              <a:lnSpc>
-                <a:spcPct val="115000"/>
-              </a:lnSpc>
-              <a:spcBef>
-                <a:spcPts val="1200"/>
-              </a:spcBef>
-              <a:spcAft>
-                <a:spcPts val="0"/>
-              </a:spcAft>
-              <a:buClr>
-                <a:schemeClr val="dk1"/>
-              </a:buClr>
-              <a:buSzPts val="1250"/>
-              <a:buFont typeface="Arial"/>
-              <a:buChar char="●"/>
-            </a:pPr>
-            <a:endParaRPr sz="1250" b="0" i="0" u="none" strike="noStrike" cap="none">
-              <a:solidFill>
-                <a:schemeClr val="dk1"/>
-              </a:solidFill>
-              <a:latin typeface="Arial"/>
-              <a:ea typeface="Arial"/>
-              <a:cs typeface="Arial"/>
-              <a:sym typeface="Arial"/>
-            </a:endParaRPr>
-          </a:p>
-        </p:txBody>
-      </p:sp>
-      <p:pic>
-        <p:nvPicPr>
-          <p:cNvPr id="125" name="Picture 124" descr="b6-slide07-next-steps.png"/>
+          <p:cNvPr id="114" name="Picture 113" descr="b6-slide07-next-steps.png"/>
           <p:cNvPicPr>
             <a:picLocks noChangeAspect="1"/>
           </p:cNvPicPr>

</xml_diff>

<commit_message>
P0 DT122: B6 shareable walk — buffer-carving, A3 bridges, on-slide story.
Polish bugatti-qos-ccc for Guru peer share: self-contained bullets on diagram slides, pipeline scope pie, Central Scheduler Block terminology, and subtle qos architecture flow without repeating A3 visuals.

Co-authored-by: Cursor <cursoragent@cursor.com>
</commit_message>
<xml_diff>
--- a/dt122/bugatti-qos-ccc.pptx
+++ b/dt122/bugatti-qos-ccc.pptx
@@ -3895,7 +3895,7 @@
                 <a:cs typeface="Arial"/>
                 <a:sym typeface="Arial"/>
               </a:rPr>
-              <a:t>QoS buffer carving arch</a:t>
+              <a:t>Quality of Service (QoS) buffer-carving architecture</a:t>
             </a:r>
             <a:endParaRPr sz="1950" b="0" i="1" u="none" strike="noStrike" cap="none">
               <a:solidFill>
@@ -4001,7 +4001,7 @@
                 <a:cs typeface="Calibri"/>
                 <a:sym typeface="Calibri"/>
               </a:rPr>
-              <a:t>Open after qos-architecture slides 1–2 · Rev 0.1 draft</a:t>
+              <a:t>Follows qos architecture · Revision 0.1</a:t>
             </a:r>
             <a:endParaRPr sz="1100" b="0" i="0" u="none" strike="noStrike" cap="none">
               <a:solidFill>
@@ -4916,7 +4916,7 @@
                 </a:solidFill>
                 <a:latin typeface="Calibri"/>
               </a:rPr>
-              <a:t>CCC walk — Capabilities · Capacities · Constraints</a:t>
+              <a:t>Dynamic Switch-Buffer Management · logical pipeline</a:t>
             </a:r>
             <a:endParaRPr sz="2200" b="0" i="0" u="none" strike="noStrike" cap="none">
               <a:solidFill>
@@ -5263,7 +5263,7 @@
           </a:ln>
         </p:spPr>
         <p:txBody>
-          <a:bodyPr spcFirstLastPara="1" wrap="none" lIns="91425" tIns="45700" rIns="91425" bIns="45700" anchor="t" anchorCtr="0">
+          <a:bodyPr spcFirstLastPara="1" wrap="square" lIns="91425" tIns="45700" rIns="91425" bIns="45700" anchor="t" anchorCtr="0">
             <a:noAutofit/>
           </a:bodyPr>
           <a:lstStyle/>
@@ -5276,7 +5276,7 @@
                 <a:spcPts val="0"/>
               </a:spcBef>
               <a:spcAft>
-                <a:spcPts val="300"/>
+                <a:spcPts val="200"/>
               </a:spcAft>
               <a:buClr>
                 <a:srgbClr val="051830"/>
@@ -5292,7 +5292,7 @@
                 </a:solidFill>
                 <a:latin typeface="Calibri"/>
               </a:rPr>
-              <a:t>CCC — datapath vocabulary</a:t>
+              <a:t>Logical pipeline</a:t>
             </a:r>
             <a:endParaRPr sz="3000" b="0" i="0" u="none" strike="noStrike" cap="none">
               <a:solidFill>
@@ -5307,7 +5307,7 @@
           <a:p>
             <a:pPr>
               <a:spcAft>
-                <a:spcPts val="300"/>
+                <a:spcPts val="200"/>
               </a:spcAft>
             </a:pPr>
             <a:r>
@@ -5317,13 +5317,13 @@
                 </a:solidFill>
                 <a:latin typeface="Arial"/>
               </a:rPr>
-              <a:t>Act I · one framework</a:t>
+              <a:t>Validated to tape-out · datapath context</a:t>
             </a:r>
           </a:p>
           <a:p>
             <a:pPr>
               <a:spcAft>
-                <a:spcPts val="300"/>
+                <a:spcPts val="200"/>
               </a:spcAft>
             </a:pPr>
             <a:r>
@@ -5333,7 +5333,7 @@
                 </a:solidFill>
                 <a:latin typeface="Arial"/>
               </a:rPr>
-              <a:t>**Capability** = what · **Capacity** = how many · **Constraint** = how used — maps to header fields → TC → resources.</a:t>
+              <a:t>QoSMAP, Queue, and buffer-carving at Central Scheduler Block (CSB) — same wedge as qos architecture.</a:t>
             </a:r>
           </a:p>
         </p:txBody>
@@ -5674,7 +5674,7 @@
       </p:sp>
       <p:pic>
         <p:nvPicPr>
-          <p:cNvPr id="59" name="Picture 58" descr="b6-slide01-ccc-framework.png"/>
+          <p:cNvPr id="59" name="Picture 58" descr="logical-pipeline-boss-slide.png"/>
           <p:cNvPicPr>
             <a:picLocks noChangeAspect="1"/>
           </p:cNvPicPr>
@@ -5688,8 +5688,8 @@
         </p:blipFill>
         <p:spPr>
           <a:xfrm>
-            <a:off x="3913213" y="1508760"/>
-            <a:ext cx="1317574" cy="3246120"/>
+            <a:off x="1681542" y="1508760"/>
+            <a:ext cx="5780916" cy="3246120"/>
           </a:xfrm>
           <a:prstGeom prst="rect">
             <a:avLst/>
@@ -5749,7 +5749,7 @@
           </a:ln>
         </p:spPr>
         <p:txBody>
-          <a:bodyPr spcFirstLastPara="1" wrap="none" lIns="91425" tIns="45700" rIns="91425" bIns="45700" anchor="t" anchorCtr="0">
+          <a:bodyPr spcFirstLastPara="1" wrap="square" lIns="91425" tIns="45700" rIns="91425" bIns="45700" anchor="t" anchorCtr="0">
             <a:noAutofit/>
           </a:bodyPr>
           <a:lstStyle/>
@@ -5762,7 +5762,7 @@
                 <a:spcPts val="0"/>
               </a:spcBef>
               <a:spcAft>
-                <a:spcPts val="300"/>
+                <a:spcPts val="200"/>
               </a:spcAft>
               <a:buClr>
                 <a:srgbClr val="051830"/>
@@ -5778,7 +5778,7 @@
                 </a:solidFill>
                 <a:latin typeface="Calibri"/>
               </a:rPr>
-              <a:t>Logical pipeline — W hooks on the log</a:t>
+              <a:t>Pipeline scope</a:t>
             </a:r>
             <a:endParaRPr sz="3000" b="0" i="0" u="none" strike="noStrike" cap="none">
               <a:solidFill>
@@ -5793,7 +5793,7 @@
           <a:p>
             <a:pPr>
               <a:spcAft>
-                <a:spcPts val="300"/>
+                <a:spcPts val="200"/>
               </a:spcAft>
             </a:pPr>
             <a:r>
@@ -5803,13 +5803,13 @@
                 </a:solidFill>
                 <a:latin typeface="Arial"/>
               </a:rPr>
-              <a:t>Act I · stitch story</a:t>
+              <a:t>Orange slice = Dynamic Switch-Buffer Management scope</a:t>
             </a:r>
           </a:p>
           <a:p>
             <a:pPr>
               <a:spcAft>
-                <a:spcPts val="300"/>
+                <a:spcPts val="200"/>
               </a:spcAft>
             </a:pPr>
             <a:r>
@@ -5819,13 +5819,13 @@
                 </a:solidFill>
                 <a:latin typeface="Arial"/>
               </a:rPr>
-              <a:t>Packet path picks which CCC applies — peer DRIs on their blocks; I own QoSMAP · Queue · CSB carve.</a:t>
+              <a:t>QoSMAP · Queue · buffer-carving at Central Scheduler Block (CSB).</a:t>
             </a:r>
           </a:p>
           <a:p>
             <a:pPr>
               <a:spcAft>
-                <a:spcPts val="300"/>
+                <a:spcPts val="200"/>
               </a:spcAft>
             </a:pPr>
             <a:r>
@@ -5835,7 +5835,23 @@
                 </a:solidFill>
                 <a:latin typeface="Arial"/>
               </a:rPr>
-              <a:t>L2 Tilak · L3/ESUN Girish · ACL Shrawan · ECMP Hongal · QoS classify Shrawan · carve Diwakar · Mirror Shafi.</a:t>
+              <a:t>• Schematic only — equal slices, not sizing metrics.</a:t>
+            </a:r>
+          </a:p>
+          <a:p>
+            <a:pPr>
+              <a:spcAft>
+                <a:spcPts val="200"/>
+              </a:spcAft>
+            </a:pPr>
+            <a:r>
+              <a:rPr sz="1100">
+                <a:solidFill>
+                  <a:srgbClr val="333333"/>
+                </a:solidFill>
+                <a:latin typeface="Arial"/>
+              </a:rPr>
+              <a:t>• Other pipeline blocks covered on peer architecture decks (SharePoint).</a:t>
             </a:r>
           </a:p>
         </p:txBody>
@@ -6176,7 +6192,7 @@
       </p:sp>
       <p:pic>
         <p:nvPicPr>
-          <p:cNvPr id="70" name="Picture 69" descr="b6-slide03-pipeline-annotated.png"/>
+          <p:cNvPr id="70" name="Picture 69" descr="b6-slide02-pipeline-scope-pie.png"/>
           <p:cNvPicPr>
             <a:picLocks noChangeAspect="1"/>
           </p:cNvPicPr>
@@ -6190,8 +6206,8 @@
         </p:blipFill>
         <p:spPr>
           <a:xfrm>
-            <a:off x="1681542" y="1508760"/>
-            <a:ext cx="5780916" cy="3246120"/>
+            <a:off x="1325880" y="1508760"/>
+            <a:ext cx="6492239" cy="3246119"/>
           </a:xfrm>
           <a:prstGeom prst="rect">
             <a:avLst/>
@@ -6251,7 +6267,7 @@
           </a:ln>
         </p:spPr>
         <p:txBody>
-          <a:bodyPr spcFirstLastPara="1" wrap="none" lIns="91425" tIns="45700" rIns="91425" bIns="45700" anchor="t" anchorCtr="0">
+          <a:bodyPr spcFirstLastPara="1" wrap="square" lIns="91425" tIns="45700" rIns="91425" bIns="45700" anchor="t" anchorCtr="0">
             <a:noAutofit/>
           </a:bodyPr>
           <a:lstStyle/>
@@ -6264,7 +6280,7 @@
                 <a:spcPts val="0"/>
               </a:spcBef>
               <a:spcAft>
-                <a:spcPts val="300"/>
+                <a:spcPts val="200"/>
               </a:spcAft>
               <a:buClr>
                 <a:srgbClr val="051830"/>
@@ -6280,7 +6296,7 @@
                 </a:solidFill>
                 <a:latin typeface="Calibri"/>
               </a:rPr>
-              <a:t>QoS classify &amp; remark — W lane (interface)</a:t>
+              <a:t>QoS classify and remark</a:t>
             </a:r>
             <a:endParaRPr sz="3000" b="0" i="0" u="none" strike="noStrike" cap="none">
               <a:solidFill>
@@ -6295,7 +6311,7 @@
           <a:p>
             <a:pPr>
               <a:spcAft>
-                <a:spcPts val="300"/>
+                <a:spcPts val="200"/>
               </a:spcAft>
             </a:pPr>
             <a:r>
@@ -6305,13 +6321,13 @@
                 </a:solidFill>
                 <a:latin typeface="Arial"/>
               </a:rPr>
-              <a:t>Act II · upstream of carve</a:t>
+              <a:t>Upstream of buffer-carving</a:t>
             </a:r>
           </a:p>
           <a:p>
             <a:pPr>
               <a:spcAft>
-                <a:spcPts val="300"/>
+                <a:spcPts val="200"/>
               </a:spcAft>
             </a:pPr>
             <a:r>
@@ -6321,7 +6337,39 @@
                 </a:solidFill>
                 <a:latin typeface="Arial"/>
               </a:rPr>
-              <a:t>TC from VLAN .1p · DSCP · ESUN CoS · UFH DSCP — remark on egress; ACL can override. Detail in peer QoS Classification CCC.</a:t>
+              <a:t>VLAN priority, Differentiated Services Code Point (DSCP), ESUN class of service, and Unified Forwarding Header (UFH) → Traffic Class (TC) on egress.</a:t>
+            </a:r>
+          </a:p>
+          <a:p>
+            <a:pPr>
+              <a:spcAft>
+                <a:spcPts val="200"/>
+              </a:spcAft>
+            </a:pPr>
+            <a:r>
+              <a:rPr sz="1100">
+                <a:solidFill>
+                  <a:srgbClr val="333333"/>
+                </a:solidFill>
+                <a:latin typeface="Arial"/>
+              </a:rPr>
+              <a:t>• Access Control List (ACL) can override remark policy.</a:t>
+            </a:r>
+          </a:p>
+          <a:p>
+            <a:pPr>
+              <a:spcAft>
+                <a:spcPts val="200"/>
+              </a:spcAft>
+            </a:pPr>
+            <a:r>
+              <a:rPr sz="1100">
+                <a:solidFill>
+                  <a:srgbClr val="333333"/>
+                </a:solidFill>
+                <a:latin typeface="Arial"/>
+              </a:rPr>
+              <a:t>• Handoff: classify → remark → Queue → buffer-carving at CSB.</a:t>
             </a:r>
           </a:p>
         </p:txBody>
@@ -6676,8 +6724,8 @@
         </p:blipFill>
         <p:spPr>
           <a:xfrm>
-            <a:off x="365760" y="2814161"/>
-            <a:ext cx="8412480" cy="635317"/>
+            <a:off x="365760" y="2816895"/>
+            <a:ext cx="8412480" cy="629850"/>
           </a:xfrm>
           <a:prstGeom prst="rect">
             <a:avLst/>
@@ -6737,7 +6785,7 @@
           </a:ln>
         </p:spPr>
         <p:txBody>
-          <a:bodyPr spcFirstLastPara="1" wrap="none" lIns="91425" tIns="45700" rIns="91425" bIns="45700" anchor="t" anchorCtr="0">
+          <a:bodyPr spcFirstLastPara="1" wrap="square" lIns="91425" tIns="45700" rIns="91425" bIns="45700" anchor="t" anchorCtr="0">
             <a:noAutofit/>
           </a:bodyPr>
           <a:lstStyle/>
@@ -6750,7 +6798,7 @@
                 <a:spcPts val="0"/>
               </a:spcBef>
               <a:spcAft>
-                <a:spcPts val="300"/>
+                <a:spcPts val="200"/>
               </a:spcAft>
               <a:buClr>
                 <a:srgbClr val="051830"/>
@@ -6766,7 +6814,7 @@
                 </a:solidFill>
                 <a:latin typeface="Calibri"/>
               </a:rPr>
-              <a:t>Buffer carve @ CSB — my wedge</a:t>
+              <a:t>Buffer-carving at Central Scheduler Block (CSB)</a:t>
             </a:r>
             <a:endParaRPr sz="3000" b="0" i="0" u="none" strike="noStrike" cap="none">
               <a:solidFill>
@@ -6781,7 +6829,7 @@
           <a:p>
             <a:pPr>
               <a:spcAft>
-                <a:spcPts val="300"/>
+                <a:spcPts val="200"/>
               </a:spcAft>
             </a:pPr>
             <a:r>
@@ -6791,13 +6839,13 @@
                 </a:solidFill>
                 <a:latin typeface="Arial"/>
               </a:rPr>
-              <a:t>Act II · qos-arch focus</a:t>
+              <a:t>Egress buffer policy · version 0</a:t>
             </a:r>
           </a:p>
           <a:p>
             <a:pPr>
               <a:spcAft>
-                <a:spcPts val="300"/>
+                <a:spcPts val="200"/>
               </a:spcAft>
             </a:pPr>
             <a:r>
@@ -6807,7 +6855,39 @@
                 </a:solidFill>
                 <a:latin typeface="Arial"/>
               </a:rPr>
-              <a:t>**Capability:** pool modes · sharing · lossy/lossless · **Capacity:** carve sizes · port tiers · **Constraint:** admission · PFC · speed coherence — v0 draft.</a:t>
+              <a:t>Pool modes, buffer-carving sizes, admission, Priority Flow Control (PFC), port-speed coherence.</a:t>
+            </a:r>
+          </a:p>
+          <a:p>
+            <a:pPr>
+              <a:spcAft>
+                <a:spcPts val="200"/>
+              </a:spcAft>
+            </a:pPr>
+            <a:r>
+              <a:rPr sz="1100">
+                <a:solidFill>
+                  <a:srgbClr val="333333"/>
+                </a:solidFill>
+                <a:latin typeface="Arial"/>
+              </a:rPr>
+              <a:t>• Near-term deliverable: buffer-carving plan and gate version 0 · next few days.</a:t>
+            </a:r>
+          </a:p>
+          <a:p>
+            <a:pPr>
+              <a:spcAft>
+                <a:spcPts val="200"/>
+              </a:spcAft>
+            </a:pPr>
+            <a:r>
+              <a:rPr sz="1100">
+                <a:solidFill>
+                  <a:srgbClr val="333333"/>
+                </a:solidFill>
+                <a:latin typeface="Arial"/>
+              </a:rPr>
+              <a:t>• Hardware pool and register-transfer-level (RTL) sizing — in progress with architecture.</a:t>
             </a:r>
           </a:p>
         </p:txBody>
@@ -7162,8 +7242,8 @@
         </p:blipFill>
         <p:spPr>
           <a:xfrm>
-            <a:off x="3364558" y="1508760"/>
-            <a:ext cx="2414883" cy="3246120"/>
+            <a:off x="3414719" y="1508760"/>
+            <a:ext cx="2314562" cy="3246120"/>
           </a:xfrm>
           <a:prstGeom prst="rect">
             <a:avLst/>
@@ -7223,7 +7303,7 @@
           </a:ln>
         </p:spPr>
         <p:txBody>
-          <a:bodyPr spcFirstLastPara="1" wrap="none" lIns="91425" tIns="45700" rIns="91425" bIns="45700" anchor="t" anchorCtr="0">
+          <a:bodyPr spcFirstLastPara="1" wrap="square" lIns="91425" tIns="45700" rIns="91425" bIns="45700" anchor="t" anchorCtr="0">
             <a:noAutofit/>
           </a:bodyPr>
           <a:lstStyle/>
@@ -7236,7 +7316,7 @@
                 <a:spcPts val="0"/>
               </a:spcBef>
               <a:spcAft>
-                <a:spcPts val="300"/>
+                <a:spcPts val="200"/>
               </a:spcAft>
               <a:buClr>
                 <a:srgbClr val="051830"/>
@@ -7252,7 +7332,7 @@
                 </a:solidFill>
                 <a:latin typeface="Calibri"/>
               </a:rPr>
-              <a:t>Scope · HW TODO · peer CCC refs</a:t>
+              <a:t>Scope and open items</a:t>
             </a:r>
             <a:endParaRPr sz="3000" b="0" i="0" u="none" strike="noStrike" cap="none">
               <a:solidFill>
@@ -7267,7 +7347,7 @@
           <a:p>
             <a:pPr>
               <a:spcAft>
-                <a:spcPts val="300"/>
+                <a:spcPts val="200"/>
               </a:spcAft>
             </a:pPr>
             <a:r>
@@ -7277,13 +7357,13 @@
                 </a:solidFill>
                 <a:latin typeface="Arial"/>
               </a:rPr>
-              <a:t>Act III · boundaries</a:t>
+              <a:t>In this walk versus deferred</a:t>
             </a:r>
           </a:p>
           <a:p>
             <a:pPr>
               <a:spcAft>
-                <a:spcPts val="300"/>
+                <a:spcPts val="200"/>
               </a:spcAft>
             </a:pPr>
             <a:r>
@@ -7293,7 +7373,39 @@
                 </a:solidFill>
                 <a:latin typeface="Arial"/>
               </a:rPr>
-              <a:t>In this walk vs deferred; cross-decks by reference (ECMP capacity in ECMP CCC, etc.).</a:t>
+              <a:t>What we cover today versus what stays on peer decks.</a:t>
+            </a:r>
+          </a:p>
+          <a:p>
+            <a:pPr>
+              <a:spcAft>
+                <a:spcPts val="200"/>
+              </a:spcAft>
+            </a:pPr>
+            <a:r>
+              <a:rPr sz="1100">
+                <a:solidFill>
+                  <a:srgbClr val="333333"/>
+                </a:solidFill>
+                <a:latin typeface="Arial"/>
+              </a:rPr>
+              <a:t>• Open: Ingress Fabric Port (IFP), Ingress Switch Buffer (ISB), CSB, and Egress Fabric Port (EFP) pool sizing.</a:t>
+            </a:r>
+          </a:p>
+          <a:p>
+            <a:pPr>
+              <a:spcAft>
+                <a:spcPts val="200"/>
+              </a:spcAft>
+            </a:pPr>
+            <a:r>
+              <a:rPr sz="1100">
+                <a:solidFill>
+                  <a:srgbClr val="333333"/>
+                </a:solidFill>
+                <a:latin typeface="Arial"/>
+              </a:rPr>
+              <a:t>• Deferred: software development kit (SDK) swimlanes and duplicating full peer deck bodies.</a:t>
             </a:r>
           </a:p>
         </p:txBody>
@@ -7648,8 +7760,8 @@
         </p:blipFill>
         <p:spPr>
           <a:xfrm>
-            <a:off x="365760" y="1594106"/>
-            <a:ext cx="8412480" cy="3075428"/>
+            <a:off x="365760" y="1632886"/>
+            <a:ext cx="8412480" cy="2997868"/>
           </a:xfrm>
           <a:prstGeom prst="rect">
             <a:avLst/>
@@ -7709,7 +7821,7 @@
           </a:ln>
         </p:spPr>
         <p:txBody>
-          <a:bodyPr spcFirstLastPara="1" wrap="none" lIns="91425" tIns="45700" rIns="91425" bIns="45700" anchor="t" anchorCtr="0">
+          <a:bodyPr spcFirstLastPara="1" wrap="square" lIns="91425" tIns="45700" rIns="91425" bIns="45700" anchor="t" anchorCtr="0">
             <a:noAutofit/>
           </a:bodyPr>
           <a:lstStyle/>
@@ -7722,7 +7834,7 @@
                 <a:spcPts val="0"/>
               </a:spcBef>
               <a:spcAft>
-                <a:spcPts val="300"/>
+                <a:spcPts val="200"/>
               </a:spcAft>
               <a:buClr>
                 <a:srgbClr val="051830"/>
@@ -7738,7 +7850,7 @@
                 </a:solidFill>
                 <a:latin typeface="Calibri"/>
               </a:rPr>
-              <a:t>Rev 0.1 · next steps</a:t>
+              <a:t>Next steps</a:t>
             </a:r>
             <a:endParaRPr sz="3000" b="0" i="0" u="none" strike="noStrike" cap="none">
               <a:solidFill>
@@ -7753,7 +7865,7 @@
           <a:p>
             <a:pPr>
               <a:spcAft>
-                <a:spcPts val="300"/>
+                <a:spcPts val="200"/>
               </a:spcAft>
             </a:pPr>
             <a:r>
@@ -7763,13 +7875,13 @@
                 </a:solidFill>
                 <a:latin typeface="Arial"/>
               </a:rPr>
-              <a:t>Act III · forward</a:t>
+              <a:t>Back to alignment · mandate checkpoints</a:t>
             </a:r>
           </a:p>
           <a:p>
             <a:pPr>
               <a:spcAft>
-                <a:spcPts val="300"/>
+                <a:spcPts val="200"/>
               </a:spcAft>
             </a:pPr>
             <a:r>
@@ -7779,7 +7891,39 @@
                 </a:solidFill>
                 <a:latin typeface="Arial"/>
               </a:rPr>
-              <a:t>Draft for steer — peer lane edits welcome; Friday walk if aligned.</a:t>
+              <a:t>Lock version 0 gates — resume qos architecture close.</a:t>
+            </a:r>
+          </a:p>
+          <a:p>
+            <a:pPr>
+              <a:spcAft>
+                <a:spcPts val="200"/>
+              </a:spcAft>
+            </a:pPr>
+            <a:r>
+              <a:rPr sz="1100">
+                <a:solidFill>
+                  <a:srgbClr val="333333"/>
+                </a:solidFill>
+                <a:latin typeface="Arial"/>
+              </a:rPr>
+              <a:t>• Revision 0.1 · Diwakar Tundlam.</a:t>
+            </a:r>
+          </a:p>
+          <a:p>
+            <a:pPr>
+              <a:spcAft>
+                <a:spcPts val="200"/>
+              </a:spcAft>
+            </a:pPr>
+            <a:r>
+              <a:rPr sz="1100">
+                <a:solidFill>
+                  <a:srgbClr val="333333"/>
+                </a:solidFill>
+                <a:latin typeface="Arial"/>
+              </a:rPr>
+              <a:t>• Publish to SharePoint after group review.</a:t>
             </a:r>
           </a:p>
         </p:txBody>
@@ -8134,8 +8278,8 @@
         </p:blipFill>
         <p:spPr>
           <a:xfrm>
-            <a:off x="3118672" y="1508760"/>
-            <a:ext cx="2906656" cy="3246120"/>
+            <a:off x="3173671" y="1508760"/>
+            <a:ext cx="2796657" cy="3246120"/>
           </a:xfrm>
           <a:prstGeom prst="rect">
             <a:avLst/>

</xml_diff>

<commit_message>
P0 DT122: B6 A-review — peer ack wedges, CCC tables, org hub.
Add pipeline scope peer lines (Diwakar on QoS wedge only), Bugatti center hub for Rupa·N·E, and CSB Cap/Cap/Con placeholder slide for informal A review.

Co-authored-by: Cursor <cursoragent@cursor.com>
</commit_message>
<xml_diff>
--- a/dt122/bugatti-qos-ccc.pptx
+++ b/dt122/bugatti-qos-ccc.pptx
@@ -15,6 +15,7 @@
     <p:sldId id="261" r:id="rId10"/>
     <p:sldId id="262" r:id="rId11"/>
     <p:sldId id="263" r:id="rId12"/>
+    <p:sldId id="264" r:id="rId13"/>
   </p:sldIdLst>
   <p:sldSz cx="9144000" cy="5143500" type="screen16x9"/>
   <p:notesSz cx="5143500" cy="9144000"/>
@@ -2899,6 +2900,178 @@
             <a:fld id="{00000000-1234-1234-1234-123412341234}" type="slidenum">
               <a:rPr lang="en-US"/>
               <a:t>8</a:t>
+            </a:fld>
+            <a:endParaRPr/>
+          </a:p>
+        </p:txBody>
+      </p:sp>
+    </p:spTree>
+  </p:cSld>
+  <p:clrMapOvr>
+    <a:masterClrMapping/>
+  </p:clrMapOvr>
+</p:notes>
+</file>
+
+<file path=ppt/notesSlides/notesSlide9.xml><?xml version="1.0" encoding="utf-8"?>
+<p:notes xmlns:a="http://schemas.openxmlformats.org/drawingml/2006/main" xmlns:r="http://schemas.openxmlformats.org/officeDocument/2006/relationships" xmlns:p="http://schemas.openxmlformats.org/presentationml/2006/main" showMasterSp="0" showMasterPhAnim="0">
+  <p:cSld>
+    <p:spTree>
+      <p:nvGrpSpPr>
+        <p:cNvPr id="1" name="Shape 114"/>
+        <p:cNvGrpSpPr/>
+        <p:nvPr/>
+      </p:nvGrpSpPr>
+      <p:grpSpPr>
+        <a:xfrm>
+          <a:off x="0" y="0"/>
+          <a:ext cx="0" cy="0"/>
+          <a:chOff x="0" y="0"/>
+          <a:chExt cx="0" cy="0"/>
+        </a:xfrm>
+      </p:grpSpPr>
+      <p:sp>
+        <p:nvSpPr>
+          <p:cNvPr id="115" name="Google Shape;115;g3d542e4bd64_0_20:notes"/>
+          <p:cNvSpPr>
+            <a:spLocks noGrp="1" noRot="1" noChangeAspect="1"/>
+          </p:cNvSpPr>
+          <p:nvPr>
+            <p:ph type="sldImg" idx="2"/>
+          </p:nvPr>
+        </p:nvSpPr>
+        <p:spPr>
+          <a:xfrm>
+            <a:off x="685800" y="1143000"/>
+            <a:ext cx="5486400" cy="3086100"/>
+          </a:xfrm>
+          <a:custGeom>
+            <a:avLst/>
+            <a:gdLst/>
+            <a:ahLst/>
+            <a:cxnLst/>
+            <a:rect l="l" t="t" r="r" b="b"/>
+            <a:pathLst>
+              <a:path w="120000" h="120000" extrusionOk="0">
+                <a:moveTo>
+                  <a:pt x="0" y="0"/>
+                </a:moveTo>
+                <a:lnTo>
+                  <a:pt x="120000" y="0"/>
+                </a:lnTo>
+                <a:lnTo>
+                  <a:pt x="120000" y="120000"/>
+                </a:lnTo>
+                <a:lnTo>
+                  <a:pt x="0" y="120000"/>
+                </a:lnTo>
+                <a:close/>
+              </a:path>
+            </a:pathLst>
+          </a:custGeom>
+          <a:noFill/>
+          <a:ln w="12700" cap="flat" cmpd="sng">
+            <a:solidFill>
+              <a:srgbClr val="000000"/>
+            </a:solidFill>
+            <a:prstDash val="solid"/>
+            <a:round/>
+            <a:headEnd type="none" w="sm" len="sm"/>
+            <a:tailEnd type="none" w="sm" len="sm"/>
+          </a:ln>
+        </p:spPr>
+      </p:sp>
+      <p:sp>
+        <p:nvSpPr>
+          <p:cNvPr id="116" name="Google Shape;116;g3d542e4bd64_0_20:notes"/>
+          <p:cNvSpPr txBox="1">
+            <a:spLocks noGrp="1"/>
+          </p:cNvSpPr>
+          <p:nvPr>
+            <p:ph type="body" idx="1"/>
+          </p:nvPr>
+        </p:nvSpPr>
+        <p:spPr>
+          <a:xfrm>
+            <a:off x="685800" y="4400550"/>
+            <a:ext cx="5486400" cy="3600600"/>
+          </a:xfrm>
+          <a:prstGeom prst="rect">
+            <a:avLst/>
+          </a:prstGeom>
+          <a:noFill/>
+          <a:ln>
+            <a:noFill/>
+          </a:ln>
+        </p:spPr>
+        <p:txBody>
+          <a:bodyPr spcFirstLastPara="1" wrap="square" lIns="91425" tIns="45700" rIns="91425" bIns="45700" anchor="t" anchorCtr="0">
+            <a:noAutofit/>
+          </a:bodyPr>
+          <a:lstStyle/>
+          <a:p>
+            <a:pPr marL="0" lvl="0" indent="0" algn="l" rtl="0">
+              <a:lnSpc>
+                <a:spcPct val="100000"/>
+              </a:lnSpc>
+              <a:spcBef>
+                <a:spcPts val="0"/>
+              </a:spcBef>
+              <a:spcAft>
+                <a:spcPts val="0"/>
+              </a:spcAft>
+              <a:buSzPts val="1400"/>
+              <a:buNone/>
+            </a:pPr>
+            <a:endParaRPr/>
+          </a:p>
+        </p:txBody>
+      </p:sp>
+      <p:sp>
+        <p:nvSpPr>
+          <p:cNvPr id="117" name="Google Shape;117;g3d542e4bd64_0_20:notes"/>
+          <p:cNvSpPr txBox="1">
+            <a:spLocks noGrp="1"/>
+          </p:cNvSpPr>
+          <p:nvPr>
+            <p:ph type="sldNum" idx="12"/>
+          </p:nvPr>
+        </p:nvSpPr>
+        <p:spPr>
+          <a:xfrm>
+            <a:off x="3884613" y="8685213"/>
+            <a:ext cx="2971800" cy="458700"/>
+          </a:xfrm>
+          <a:prstGeom prst="rect">
+            <a:avLst/>
+          </a:prstGeom>
+          <a:noFill/>
+          <a:ln>
+            <a:noFill/>
+          </a:ln>
+        </p:spPr>
+        <p:txBody>
+          <a:bodyPr spcFirstLastPara="1" wrap="square" lIns="91425" tIns="45700" rIns="91425" bIns="45700" anchor="b" anchorCtr="0">
+            <a:noAutofit/>
+          </a:bodyPr>
+          <a:lstStyle/>
+          <a:p>
+            <a:pPr marL="0" lvl="0" indent="0" algn="r" rtl="0">
+              <a:lnSpc>
+                <a:spcPct val="100000"/>
+              </a:lnSpc>
+              <a:spcBef>
+                <a:spcPts val="0"/>
+              </a:spcBef>
+              <a:spcAft>
+                <a:spcPts val="0"/>
+              </a:spcAft>
+              <a:buSzPts val="1400"/>
+              <a:buNone/>
+            </a:pPr>
+            <a:fld id="{00000000-1234-1234-1234-123412341234}" type="slidenum">
+              <a:rPr lang="en-US"/>
+              <a:t>9</a:t>
             </a:fld>
             <a:endParaRPr/>
           </a:p>
@@ -5819,7 +5992,7 @@
                 </a:solidFill>
                 <a:latin typeface="Arial"/>
               </a:rPr>
-              <a:t>QoSMAP · Queue · buffer-carving at Central Scheduler Block (CSB).</a:t>
+              <a:t>QoSMAP · CSB buffer-carving · QoS-CCC — same wedge as qos architecture.</a:t>
             </a:r>
           </a:p>
           <a:p>
@@ -5835,7 +6008,23 @@
                 </a:solidFill>
                 <a:latin typeface="Arial"/>
               </a:rPr>
-              <a:t>• Schematic only — equal slices, not sizing metrics.</a:t>
+              <a:t>• Center hub: Bugatti — Rupa · N · E org alignment (not wedge owners).</a:t>
+            </a:r>
+          </a:p>
+          <a:p>
+            <a:pPr>
+              <a:spcAft>
+                <a:spcPts val="200"/>
+              </a:spcAft>
+            </a:pPr>
+            <a:r>
+              <a:rPr sz="1100">
+                <a:solidFill>
+                  <a:srgbClr val="333333"/>
+                </a:solidFill>
+                <a:latin typeface="Arial"/>
+              </a:rPr>
+              <a:t>• Wedge peers acknowledged in parentheses — schematic, not RACI.</a:t>
             </a:r>
           </a:p>
           <a:p>
@@ -7332,7 +7521,7 @@
                 </a:solidFill>
                 <a:latin typeface="Calibri"/>
               </a:rPr>
-              <a:t>Scope and open items</a:t>
+              <a:t>CSB buffer-carving · CCC</a:t>
             </a:r>
             <a:endParaRPr sz="3000" b="0" i="0" u="none" strike="noStrike" cap="none">
               <a:solidFill>
@@ -7357,7 +7546,7 @@
                 </a:solidFill>
                 <a:latin typeface="Arial"/>
               </a:rPr>
-              <a:t>In this walk versus deferred</a:t>
+              <a:t>Capabilities · Capacities · Constraints</a:t>
             </a:r>
           </a:p>
           <a:p>
@@ -7373,7 +7562,7 @@
                 </a:solidFill>
                 <a:latin typeface="Arial"/>
               </a:rPr>
-              <a:t>What we cover today versus what stays on peer decks.</a:t>
+              <a:t>Version 0 placeholders — refine from HW architecture, RTL, and c-models.</a:t>
             </a:r>
           </a:p>
           <a:p>
@@ -7389,7 +7578,7 @@
                 </a:solidFill>
                 <a:latin typeface="Arial"/>
               </a:rPr>
-              <a:t>• Open: Ingress Fabric Port (IFP), Ingress Switch Buffer (ISB), CSB, and Egress Fabric Port (EFP) pool sizing.</a:t>
+              <a:t>• Orange rows: CSB wedge and fabric pool context — values TBD.</a:t>
             </a:r>
           </a:p>
           <a:p>
@@ -7405,7 +7594,7 @@
                 </a:solidFill>
                 <a:latin typeface="Arial"/>
               </a:rPr>
-              <a:t>• Deferred: software development kit (SDK) swimlanes and duplicating full peer deck bodies.</a:t>
+              <a:t>• Use-case-driven datapath may revise rows after qos-aware walk.</a:t>
             </a:r>
           </a:p>
         </p:txBody>
@@ -7746,7 +7935,7 @@
       </p:sp>
       <p:pic>
         <p:nvPicPr>
-          <p:cNvPr id="103" name="Picture 102" descr="b6-slide06-boundaries.png"/>
+          <p:cNvPr id="103" name="Picture 102" descr="b6-slide05-csb-ccc-tables.png"/>
           <p:cNvPicPr>
             <a:picLocks noChangeAspect="1"/>
           </p:cNvPicPr>
@@ -7760,8 +7949,8 @@
         </p:blipFill>
         <p:spPr>
           <a:xfrm>
-            <a:off x="365760" y="1632886"/>
-            <a:ext cx="8412480" cy="2997868"/>
+            <a:off x="1325880" y="1508760"/>
+            <a:ext cx="6492239" cy="3246119"/>
           </a:xfrm>
           <a:prstGeom prst="rect">
             <a:avLst/>
@@ -7850,7 +8039,7 @@
                 </a:solidFill>
                 <a:latin typeface="Calibri"/>
               </a:rPr>
-              <a:t>Next steps</a:t>
+              <a:t>Scope and open items</a:t>
             </a:r>
             <a:endParaRPr sz="3000" b="0" i="0" u="none" strike="noStrike" cap="none">
               <a:solidFill>
@@ -7875,7 +8064,7 @@
                 </a:solidFill>
                 <a:latin typeface="Arial"/>
               </a:rPr>
-              <a:t>Back to alignment · mandate checkpoints</a:t>
+              <a:t>In this walk versus deferred</a:t>
             </a:r>
           </a:p>
           <a:p>
@@ -7891,7 +8080,7 @@
                 </a:solidFill>
                 <a:latin typeface="Arial"/>
               </a:rPr>
-              <a:t>Lock version 0 gates — resume qos architecture close.</a:t>
+              <a:t>What we cover today versus what stays on peer decks.</a:t>
             </a:r>
           </a:p>
           <a:p>
@@ -7907,7 +8096,7 @@
                 </a:solidFill>
                 <a:latin typeface="Arial"/>
               </a:rPr>
-              <a:t>• Revision 0.1 · Diwakar Tundlam.</a:t>
+              <a:t>• Open: Ingress Fabric Port (IFP), Ingress Switch Buffer (ISB), CSB, and Egress Fabric Port (EFP) pool sizing.</a:t>
             </a:r>
           </a:p>
           <a:p>
@@ -7923,7 +8112,7 @@
                 </a:solidFill>
                 <a:latin typeface="Arial"/>
               </a:rPr>
-              <a:t>• Publish to SharePoint after group review.</a:t>
+              <a:t>• Deferred: software development kit (SDK) swimlanes and duplicating full peer deck bodies.</a:t>
             </a:r>
           </a:p>
         </p:txBody>
@@ -8264,7 +8453,525 @@
       </p:sp>
       <p:pic>
         <p:nvPicPr>
-          <p:cNvPr id="114" name="Picture 113" descr="b6-slide07-next-steps.png"/>
+          <p:cNvPr id="114" name="Picture 113" descr="b6-slide06-boundaries.png"/>
+          <p:cNvPicPr>
+            <a:picLocks noChangeAspect="1"/>
+          </p:cNvPicPr>
+          <p:nvPr/>
+        </p:nvPicPr>
+        <p:blipFill>
+          <a:blip r:embed="rId3"/>
+          <a:stretch>
+            <a:fillRect/>
+          </a:stretch>
+        </p:blipFill>
+        <p:spPr>
+          <a:xfrm>
+            <a:off x="365760" y="1632886"/>
+            <a:ext cx="8412480" cy="2997868"/>
+          </a:xfrm>
+          <a:prstGeom prst="rect">
+            <a:avLst/>
+          </a:prstGeom>
+        </p:spPr>
+      </p:pic>
+    </p:spTree>
+  </p:cSld>
+  <p:clrMapOvr>
+    <a:masterClrMapping/>
+  </p:clrMapOvr>
+</p:sld>
+</file>
+
+<file path=ppt/slides/slide9.xml><?xml version="1.0" encoding="utf-8"?>
+<p:sld xmlns:a="http://schemas.openxmlformats.org/drawingml/2006/main" xmlns:r="http://schemas.openxmlformats.org/officeDocument/2006/relationships" xmlns:p="http://schemas.openxmlformats.org/presentationml/2006/main">
+  <p:cSld>
+    <p:bg>
+      <p:bgPr>
+        <a:solidFill>
+          <a:srgbClr val="FFFFFF"/>
+        </a:solidFill>
+        <a:effectLst/>
+      </p:bgPr>
+    </p:bg>
+    <p:spTree>
+      <p:nvGrpSpPr>
+        <p:cNvPr id="1" name="Shape 118"/>
+        <p:cNvGrpSpPr/>
+        <p:nvPr/>
+      </p:nvGrpSpPr>
+      <p:grpSpPr>
+        <a:xfrm>
+          <a:off x="0" y="0"/>
+          <a:ext cx="0" cy="0"/>
+          <a:chOff x="0" y="0"/>
+          <a:chExt cx="0" cy="0"/>
+        </a:xfrm>
+      </p:grpSpPr>
+      <p:sp>
+        <p:nvSpPr>
+          <p:cNvPr id="119" name="Google Shape;119;g3d542e4bd64_0_20"/>
+          <p:cNvSpPr/>
+          <p:nvPr/>
+        </p:nvSpPr>
+        <p:spPr>
+          <a:xfrm>
+            <a:off x="411480" y="201168"/>
+            <a:ext cx="8321100" cy="594300"/>
+          </a:xfrm>
+          <a:prstGeom prst="rect">
+            <a:avLst/>
+          </a:prstGeom>
+          <a:noFill/>
+          <a:ln>
+            <a:noFill/>
+          </a:ln>
+        </p:spPr>
+        <p:txBody>
+          <a:bodyPr spcFirstLastPara="1" wrap="square" lIns="91425" tIns="45700" rIns="91425" bIns="45700" anchor="t" anchorCtr="0">
+            <a:noAutofit/>
+          </a:bodyPr>
+          <a:lstStyle/>
+          <a:p>
+            <a:pPr marL="0" marR="0" indent="0" algn="l" rtl="0">
+              <a:lnSpc>
+                <a:spcPct val="100000"/>
+              </a:lnSpc>
+              <a:spcBef>
+                <a:spcPts val="0"/>
+              </a:spcBef>
+              <a:spcAft>
+                <a:spcPts val="200"/>
+              </a:spcAft>
+              <a:buClr>
+                <a:srgbClr val="051830"/>
+              </a:buClr>
+              <a:buSzPts val="3000"/>
+              <a:buFont typeface="Calibri"/>
+              <a:buNone/>
+            </a:pPr>
+            <a:r>
+              <a:rPr sz="2600">
+                <a:solidFill>
+                  <a:srgbClr val="051830"/>
+                </a:solidFill>
+                <a:latin typeface="Calibri"/>
+              </a:rPr>
+              <a:t>Next steps</a:t>
+            </a:r>
+            <a:endParaRPr sz="3000" b="0" i="0" u="none" strike="noStrike" cap="none">
+              <a:solidFill>
+                <a:schemeClr val="dk1"/>
+              </a:solidFill>
+              <a:latin typeface="Calibri"/>
+              <a:ea typeface="Calibri"/>
+              <a:cs typeface="Calibri"/>
+              <a:sym typeface="Calibri"/>
+            </a:endParaRPr>
+          </a:p>
+          <a:p>
+            <a:pPr>
+              <a:spcAft>
+                <a:spcPts val="200"/>
+              </a:spcAft>
+            </a:pPr>
+            <a:r>
+              <a:rPr sz="1300">
+                <a:solidFill>
+                  <a:srgbClr val="FFE19E"/>
+                </a:solidFill>
+                <a:latin typeface="Arial"/>
+              </a:rPr>
+              <a:t>Back to alignment · mandate checkpoints</a:t>
+            </a:r>
+          </a:p>
+          <a:p>
+            <a:pPr>
+              <a:spcAft>
+                <a:spcPts val="200"/>
+              </a:spcAft>
+            </a:pPr>
+            <a:r>
+              <a:rPr sz="1300">
+                <a:solidFill>
+                  <a:srgbClr val="556677"/>
+                </a:solidFill>
+                <a:latin typeface="Arial"/>
+              </a:rPr>
+              <a:t>Lock version 0 gates — resume qos architecture close.</a:t>
+            </a:r>
+          </a:p>
+          <a:p>
+            <a:pPr>
+              <a:spcAft>
+                <a:spcPts val="200"/>
+              </a:spcAft>
+            </a:pPr>
+            <a:r>
+              <a:rPr sz="1100">
+                <a:solidFill>
+                  <a:srgbClr val="333333"/>
+                </a:solidFill>
+                <a:latin typeface="Arial"/>
+              </a:rPr>
+              <a:t>• Revision 0.1.</a:t>
+            </a:r>
+          </a:p>
+          <a:p>
+            <a:pPr>
+              <a:spcAft>
+                <a:spcPts val="200"/>
+              </a:spcAft>
+            </a:pPr>
+            <a:r>
+              <a:rPr sz="1100">
+                <a:solidFill>
+                  <a:srgbClr val="333333"/>
+                </a:solidFill>
+                <a:latin typeface="Arial"/>
+              </a:rPr>
+              <a:t>• Publish to SharePoint after group review.</a:t>
+            </a:r>
+          </a:p>
+        </p:txBody>
+      </p:sp>
+      <p:sp>
+        <p:nvSpPr>
+          <p:cNvPr id="120" name="Google Shape;120;g3d542e4bd64_0_20"/>
+          <p:cNvSpPr/>
+          <p:nvPr/>
+        </p:nvSpPr>
+        <p:spPr>
+          <a:xfrm>
+            <a:off x="0" y="4850892"/>
+            <a:ext cx="9144000" cy="18300"/>
+          </a:xfrm>
+          <a:prstGeom prst="rect">
+            <a:avLst/>
+          </a:prstGeom>
+          <a:solidFill>
+            <a:srgbClr val="C8A85A"/>
+          </a:solidFill>
+          <a:ln w="12700" cap="flat" cmpd="sng">
+            <a:solidFill>
+              <a:srgbClr val="C8A85A"/>
+            </a:solidFill>
+            <a:prstDash val="solid"/>
+            <a:round/>
+            <a:headEnd type="none" w="sm" len="sm"/>
+            <a:tailEnd type="none" w="sm" len="sm"/>
+          </a:ln>
+        </p:spPr>
+        <p:txBody>
+          <a:bodyPr spcFirstLastPara="1" wrap="square" lIns="91425" tIns="91425" rIns="91425" bIns="91425" anchor="ctr" anchorCtr="0">
+            <a:noAutofit/>
+          </a:bodyPr>
+          <a:lstStyle/>
+          <a:p>
+            <a:pPr marL="0" marR="0" lvl="0" indent="0" algn="l" rtl="0">
+              <a:lnSpc>
+                <a:spcPct val="100000"/>
+              </a:lnSpc>
+              <a:spcBef>
+                <a:spcPts val="0"/>
+              </a:spcBef>
+              <a:spcAft>
+                <a:spcPts val="0"/>
+              </a:spcAft>
+              <a:buClr>
+                <a:srgbClr val="000000"/>
+              </a:buClr>
+              <a:buSzPts val="1400"/>
+              <a:buFont typeface="Arial"/>
+              <a:buNone/>
+            </a:pPr>
+            <a:endParaRPr sz="1400" b="0" i="0" u="none" strike="noStrike" cap="none">
+              <a:solidFill>
+                <a:srgbClr val="000000"/>
+              </a:solidFill>
+              <a:latin typeface="Arial"/>
+              <a:ea typeface="Arial"/>
+              <a:cs typeface="Arial"/>
+              <a:sym typeface="Arial"/>
+            </a:endParaRPr>
+          </a:p>
+        </p:txBody>
+      </p:sp>
+      <p:sp>
+        <p:nvSpPr>
+          <p:cNvPr id="121" name="Google Shape;121;g3d542e4bd64_0_20"/>
+          <p:cNvSpPr/>
+          <p:nvPr/>
+        </p:nvSpPr>
+        <p:spPr>
+          <a:xfrm>
+            <a:off x="0" y="4869180"/>
+            <a:ext cx="9144000" cy="274200"/>
+          </a:xfrm>
+          <a:prstGeom prst="rect">
+            <a:avLst/>
+          </a:prstGeom>
+          <a:solidFill>
+            <a:srgbClr val="F4F6FA"/>
+          </a:solidFill>
+          <a:ln w="12700" cap="flat" cmpd="sng">
+            <a:solidFill>
+              <a:srgbClr val="F4F6FA"/>
+            </a:solidFill>
+            <a:prstDash val="solid"/>
+            <a:round/>
+            <a:headEnd type="none" w="sm" len="sm"/>
+            <a:tailEnd type="none" w="sm" len="sm"/>
+          </a:ln>
+        </p:spPr>
+        <p:txBody>
+          <a:bodyPr spcFirstLastPara="1" wrap="square" lIns="91425" tIns="91425" rIns="91425" bIns="91425" anchor="ctr" anchorCtr="0">
+            <a:noAutofit/>
+          </a:bodyPr>
+          <a:lstStyle/>
+          <a:p>
+            <a:pPr marL="0" marR="0" lvl="0" indent="0" algn="l" rtl="0">
+              <a:lnSpc>
+                <a:spcPct val="100000"/>
+              </a:lnSpc>
+              <a:spcBef>
+                <a:spcPts val="0"/>
+              </a:spcBef>
+              <a:spcAft>
+                <a:spcPts val="0"/>
+              </a:spcAft>
+              <a:buClr>
+                <a:srgbClr val="000000"/>
+              </a:buClr>
+              <a:buSzPts val="1400"/>
+              <a:buFont typeface="Arial"/>
+              <a:buNone/>
+            </a:pPr>
+            <a:endParaRPr sz="1400" b="0" i="0" u="none" strike="noStrike" cap="none">
+              <a:solidFill>
+                <a:srgbClr val="000000"/>
+              </a:solidFill>
+              <a:latin typeface="Arial"/>
+              <a:ea typeface="Arial"/>
+              <a:cs typeface="Arial"/>
+              <a:sym typeface="Arial"/>
+            </a:endParaRPr>
+          </a:p>
+        </p:txBody>
+      </p:sp>
+      <p:sp>
+        <p:nvSpPr>
+          <p:cNvPr id="122" name="Google Shape;122;g3d542e4bd64_0_20"/>
+          <p:cNvSpPr/>
+          <p:nvPr/>
+        </p:nvSpPr>
+        <p:spPr>
+          <a:xfrm>
+            <a:off x="274320" y="4887468"/>
+            <a:ext cx="7772400" cy="201300"/>
+          </a:xfrm>
+          <a:prstGeom prst="rect">
+            <a:avLst/>
+          </a:prstGeom>
+          <a:noFill/>
+          <a:ln>
+            <a:noFill/>
+          </a:ln>
+        </p:spPr>
+        <p:txBody>
+          <a:bodyPr spcFirstLastPara="1" wrap="square" lIns="91425" tIns="45700" rIns="91425" bIns="45700" anchor="ctr" anchorCtr="0">
+            <a:noAutofit/>
+          </a:bodyPr>
+          <a:lstStyle/>
+          <a:p>
+            <a:pPr marL="0" marR="0" lvl="0" indent="0" algn="ctr" rtl="0">
+              <a:lnSpc>
+                <a:spcPct val="100000"/>
+              </a:lnSpc>
+              <a:spcBef>
+                <a:spcPts val="0"/>
+              </a:spcBef>
+              <a:spcAft>
+                <a:spcPts val="0"/>
+              </a:spcAft>
+              <a:buClr>
+                <a:srgbClr val="888888"/>
+              </a:buClr>
+              <a:buSzPts val="700"/>
+              <a:buFont typeface="Calibri"/>
+              <a:buNone/>
+            </a:pPr>
+            <a:r>
+              <a:rPr lang="en-US" sz="700" b="0" i="0" u="none" strike="noStrike" cap="none">
+                <a:solidFill>
+                  <a:srgbClr val="888888"/>
+                </a:solidFill>
+                <a:latin typeface="Calibri"/>
+                <a:ea typeface="Calibri"/>
+                <a:cs typeface="Calibri"/>
+                <a:sym typeface="Calibri"/>
+              </a:rPr>
+              <a:t>© 2026 Upscale AI – Proprietary and Confidential – Do Not Reproduce or Duplicate</a:t>
+            </a:r>
+            <a:endParaRPr sz="700" b="0" i="0" u="none" strike="noStrike" cap="none">
+              <a:solidFill>
+                <a:schemeClr val="dk1"/>
+              </a:solidFill>
+              <a:latin typeface="Calibri"/>
+              <a:ea typeface="Calibri"/>
+              <a:cs typeface="Calibri"/>
+              <a:sym typeface="Calibri"/>
+            </a:endParaRPr>
+          </a:p>
+        </p:txBody>
+      </p:sp>
+      <p:sp>
+        <p:nvSpPr>
+          <p:cNvPr id="123" name="Google Shape;123;g3d542e4bd64_0_20"/>
+          <p:cNvSpPr/>
+          <p:nvPr/>
+        </p:nvSpPr>
+        <p:spPr>
+          <a:xfrm>
+            <a:off x="7863840" y="4887468"/>
+            <a:ext cx="1097400" cy="201300"/>
+          </a:xfrm>
+          <a:prstGeom prst="rect">
+            <a:avLst/>
+          </a:prstGeom>
+          <a:noFill/>
+          <a:ln>
+            <a:noFill/>
+          </a:ln>
+        </p:spPr>
+        <p:txBody>
+          <a:bodyPr spcFirstLastPara="1" wrap="square" lIns="91425" tIns="45700" rIns="91425" bIns="45700" anchor="ctr" anchorCtr="0">
+            <a:noAutofit/>
+          </a:bodyPr>
+          <a:lstStyle/>
+          <a:p>
+            <a:pPr marL="0" marR="0" lvl="0" indent="0" algn="r" rtl="0">
+              <a:lnSpc>
+                <a:spcPct val="100000"/>
+              </a:lnSpc>
+              <a:spcBef>
+                <a:spcPts val="0"/>
+              </a:spcBef>
+              <a:spcAft>
+                <a:spcPts val="0"/>
+              </a:spcAft>
+              <a:buClr>
+                <a:srgbClr val="FFE19E"/>
+              </a:buClr>
+              <a:buSzPts val="800"/>
+              <a:buFont typeface="Calibri"/>
+              <a:buNone/>
+            </a:pPr>
+            <a:r>
+              <a:rPr lang="en-US" sz="800" b="1" i="0" u="none" strike="noStrike" cap="none">
+                <a:solidFill>
+                  <a:srgbClr val="FFE19E"/>
+                </a:solidFill>
+                <a:latin typeface="Calibri"/>
+                <a:ea typeface="Calibri"/>
+                <a:cs typeface="Calibri"/>
+                <a:sym typeface="Calibri"/>
+              </a:rPr>
+              <a:t>UP </a:t>
+            </a:r>
+            <a:r>
+              <a:rPr lang="en-US" sz="900" b="1" i="0" u="none" strike="noStrike" cap="none">
+                <a:solidFill>
+                  <a:srgbClr val="FFE19E"/>
+                </a:solidFill>
+                <a:latin typeface="Calibri"/>
+                <a:ea typeface="Calibri"/>
+                <a:cs typeface="Calibri"/>
+                <a:sym typeface="Calibri"/>
+              </a:rPr>
+              <a:t>upscale </a:t>
+            </a:r>
+            <a:r>
+              <a:rPr lang="en-US" sz="900" b="0" i="0" u="none" strike="noStrike" cap="none">
+                <a:solidFill>
+                  <a:srgbClr val="FFE19E"/>
+                </a:solidFill>
+                <a:latin typeface="Calibri"/>
+                <a:ea typeface="Calibri"/>
+                <a:cs typeface="Calibri"/>
+                <a:sym typeface="Calibri"/>
+              </a:rPr>
+              <a:t>ai</a:t>
+            </a:r>
+            <a:endParaRPr sz="800" b="0" i="0" u="none" strike="noStrike" cap="none">
+              <a:solidFill>
+                <a:schemeClr val="dk1"/>
+              </a:solidFill>
+              <a:latin typeface="Calibri"/>
+              <a:ea typeface="Calibri"/>
+              <a:cs typeface="Calibri"/>
+              <a:sym typeface="Calibri"/>
+            </a:endParaRPr>
+          </a:p>
+        </p:txBody>
+      </p:sp>
+      <p:sp>
+        <p:nvSpPr>
+          <p:cNvPr id="124" name="Google Shape;124;g3d542e4bd64_0_20"/>
+          <p:cNvSpPr txBox="1"/>
+          <p:nvPr/>
+        </p:nvSpPr>
+        <p:spPr>
+          <a:xfrm>
+            <a:off x="411475" y="795525"/>
+            <a:ext cx="0" cy="0"/>
+          </a:xfrm>
+          <a:prstGeom prst="rect">
+            <a:avLst/>
+          </a:prstGeom>
+          <a:noFill/>
+          <a:ln>
+            <a:noFill/>
+          </a:ln>
+        </p:spPr>
+        <p:txBody>
+          <a:bodyPr spcFirstLastPara="1" wrap="square" lIns="91425" tIns="91425" rIns="91425" bIns="91425" anchor="t" anchorCtr="0">
+            <a:spAutoFit/>
+          </a:bodyPr>
+          <a:lstStyle/>
+          <a:p>
+            <a:pPr marL="457200" marR="0" lvl="0" indent="-307975" algn="l" rtl="0">
+              <a:lnSpc>
+                <a:spcPct val="115000"/>
+              </a:lnSpc>
+              <a:spcBef>
+                <a:spcPts val="1200"/>
+              </a:spcBef>
+              <a:spcAft>
+                <a:spcPts val="0"/>
+              </a:spcAft>
+              <a:buClr>
+                <a:schemeClr val="dk1"/>
+              </a:buClr>
+              <a:buSzPts val="1250"/>
+              <a:buFont typeface="Arial"/>
+              <a:buChar char="●"/>
+            </a:pPr>
+            <a:endParaRPr sz="1250" b="0" i="0" u="none" strike="noStrike" cap="none">
+              <a:solidFill>
+                <a:schemeClr val="dk1"/>
+              </a:solidFill>
+              <a:latin typeface="Arial"/>
+              <a:ea typeface="Arial"/>
+              <a:cs typeface="Arial"/>
+              <a:sym typeface="Arial"/>
+            </a:endParaRPr>
+          </a:p>
+        </p:txBody>
+      </p:sp>
+      <p:pic>
+        <p:nvPicPr>
+          <p:cNvPr id="125" name="Picture 124" descr="b6-slide07-next-steps.png"/>
           <p:cNvPicPr>
             <a:picLocks noChangeAspect="1"/>
           </p:cNvPicPr>

</xml_diff>

<commit_message>
P0 DT122: B6 screen-ready — remove wedge and internal jargon from slides.
Replace on-slide wedge, RACI, and mandate wording with shareable scope language for DT122 delivery.

Co-authored-by: Cursor <cursoragent@cursor.com>
</commit_message>
<xml_diff>
--- a/dt122/bugatti-qos-ccc.pptx
+++ b/dt122/bugatti-qos-ccc.pptx
@@ -5506,7 +5506,7 @@
                 </a:solidFill>
                 <a:latin typeface="Arial"/>
               </a:rPr>
-              <a:t>QoSMAP, Queue, and buffer-carving at Central Scheduler Block (CSB) — same wedge as qos architecture.</a:t>
+              <a:t>QoSMAP, Queue, and buffer-carving at Central Scheduler Block (CSB) — aligned with qos architecture.</a:t>
             </a:r>
           </a:p>
         </p:txBody>
@@ -5992,7 +5992,7 @@
                 </a:solidFill>
                 <a:latin typeface="Arial"/>
               </a:rPr>
-              <a:t>QoSMAP · CSB buffer-carving · QoS-CCC — same wedge as qos architecture.</a:t>
+              <a:t>QoSMAP · CSB buffer-carving · QoS-CCC — aligned with qos architecture.</a:t>
             </a:r>
           </a:p>
           <a:p>
@@ -6008,7 +6008,7 @@
                 </a:solidFill>
                 <a:latin typeface="Arial"/>
               </a:rPr>
-              <a:t>• Center hub: Bugatti — Rupa · N · E org alignment (not wedge owners).</a:t>
+              <a:t>• Center hub: Bugatti — Rupa · N · E org alignment (not slice owners).</a:t>
             </a:r>
           </a:p>
           <a:p>
@@ -6024,7 +6024,7 @@
                 </a:solidFill>
                 <a:latin typeface="Arial"/>
               </a:rPr>
-              <a:t>• Wedge peers acknowledged in parentheses — schematic, not RACI.</a:t>
+              <a:t>• Peers acknowledged in parentheses — schematic only.</a:t>
             </a:r>
           </a:p>
           <a:p>
@@ -7578,7 +7578,7 @@
                 </a:solidFill>
                 <a:latin typeface="Arial"/>
               </a:rPr>
-              <a:t>• Orange rows: CSB wedge and fabric pool context — values TBD.</a:t>
+              <a:t>• Orange rows: CSB buffer-carving and fabric pool context — values TBD.</a:t>
             </a:r>
           </a:p>
           <a:p>
@@ -8582,7 +8582,7 @@
                 </a:solidFill>
                 <a:latin typeface="Arial"/>
               </a:rPr>
-              <a:t>Back to alignment · mandate checkpoints</a:t>
+              <a:t>Back to alignment · checkpoints</a:t>
             </a:r>
           </a:p>
           <a:p>
@@ -8598,7 +8598,7 @@
                 </a:solidFill>
                 <a:latin typeface="Arial"/>
               </a:rPr>
-              <a:t>Lock version 0 gates — resume qos architecture close.</a:t>
+              <a:t>Lock version 0 gates — continue qos architecture close.</a:t>
             </a:r>
           </a:p>
           <a:p>

</xml_diff>

<commit_message>
P0 DT122: B6 — drop Rupa·N·E and meta jargon from pipeline scope slide.
Pie hub is Bugatti only; scope slide bullets are schematic + peer decks — no internal org labels on-slide.

Co-authored-by: Cursor <cursoragent@cursor.com>
</commit_message>
<xml_diff>
--- a/dt122/bugatti-qos-ccc.pptx
+++ b/dt122/bugatti-qos-ccc.pptx
@@ -6008,23 +6008,7 @@
                 </a:solidFill>
                 <a:latin typeface="Arial"/>
               </a:rPr>
-              <a:t>• Center hub: Bugatti — Rupa · N · E org alignment (not slice owners).</a:t>
-            </a:r>
-          </a:p>
-          <a:p>
-            <a:pPr>
-              <a:spcAft>
-                <a:spcPts val="200"/>
-              </a:spcAft>
-            </a:pPr>
-            <a:r>
-              <a:rPr sz="1100">
-                <a:solidFill>
-                  <a:srgbClr val="333333"/>
-                </a:solidFill>
-                <a:latin typeface="Arial"/>
-              </a:rPr>
-              <a:t>• Peers acknowledged in parentheses — schematic only.</a:t>
+              <a:t>• Schematic only — equal slices, not sizing metrics.</a:t>
             </a:r>
           </a:p>
           <a:p>

</xml_diff>

<commit_message>
P0 DT122: B6 copy polish — Buffer-carving CCC hook, no walk jargon.
Cover leads with CCC; Guru pipeline slide unchanged; stronger datapath scope title; scrub speaker notes to meta md.

Co-authored-by: Cursor <cursoragent@cursor.com>
</commit_message>
<xml_diff>
--- a/dt122/bugatti-qos-ccc.pptx
+++ b/dt122/bugatti-qos-ccc.pptx
@@ -4068,7 +4068,7 @@
                 <a:cs typeface="Arial"/>
                 <a:sym typeface="Arial"/>
               </a:rPr>
-              <a:t>Quality of Service (QoS) buffer-carving architecture</a:t>
+              <a:t>Buffer-carving CCC</a:t>
             </a:r>
             <a:endParaRPr sz="1950" b="0" i="1" u="none" strike="noStrike" cap="none">
               <a:solidFill>
@@ -5490,23 +5490,7 @@
                 </a:solidFill>
                 <a:latin typeface="Arial"/>
               </a:rPr>
-              <a:t>Validated to tape-out · datapath context</a:t>
-            </a:r>
-          </a:p>
-          <a:p>
-            <a:pPr>
-              <a:spcAft>
-                <a:spcPts val="200"/>
-              </a:spcAft>
-            </a:pPr>
-            <a:r>
-              <a:rPr sz="1300">
-                <a:solidFill>
-                  <a:srgbClr val="556677"/>
-                </a:solidFill>
-                <a:latin typeface="Arial"/>
-              </a:rPr>
-              <a:t>QoSMAP, Queue, and buffer-carving at Central Scheduler Block (CSB) — aligned with qos architecture.</a:t>
+              <a:t>Program kickoff slide — unchanged</a:t>
             </a:r>
           </a:p>
         </p:txBody>
@@ -5951,7 +5935,7 @@
                 </a:solidFill>
                 <a:latin typeface="Calibri"/>
               </a:rPr>
-              <a:t>Pipeline scope</a:t>
+              <a:t>Datapath · CCC scope</a:t>
             </a:r>
             <a:endParaRPr sz="3000" b="0" i="0" u="none" strike="noStrike" cap="none">
               <a:solidFill>
@@ -5976,7 +5960,7 @@
                 </a:solidFill>
                 <a:latin typeface="Arial"/>
               </a:rPr>
-              <a:t>Orange slice = Dynamic Switch-Buffer Management scope</a:t>
+              <a:t>Orange slice = buffer-carving scope</a:t>
             </a:r>
           </a:p>
           <a:p>
@@ -7578,7 +7562,7 @@
                 </a:solidFill>
                 <a:latin typeface="Arial"/>
               </a:rPr>
-              <a:t>• Use-case-driven datapath may revise rows after qos-aware walk.</a:t>
+              <a:t>• Use-case-driven datapath may revise rows.</a:t>
             </a:r>
           </a:p>
         </p:txBody>
@@ -8048,7 +8032,7 @@
                 </a:solidFill>
                 <a:latin typeface="Arial"/>
               </a:rPr>
-              <a:t>In this walk versus deferred</a:t>
+              <a:t>In scope versus deferred</a:t>
             </a:r>
           </a:p>
           <a:p>
@@ -8064,7 +8048,7 @@
                 </a:solidFill>
                 <a:latin typeface="Arial"/>
               </a:rPr>
-              <a:t>What we cover today versus what stays on peer decks.</a:t>
+              <a:t>What this CCC covers versus peer decks.</a:t>
             </a:r>
           </a:p>
           <a:p>
@@ -8451,8 +8435,8 @@
         </p:blipFill>
         <p:spPr>
           <a:xfrm>
-            <a:off x="365760" y="1632886"/>
-            <a:ext cx="8412480" cy="2997868"/>
+            <a:off x="365760" y="1642683"/>
+            <a:ext cx="8412480" cy="2978274"/>
           </a:xfrm>
           <a:prstGeom prst="rect">
             <a:avLst/>

</xml_diff>

<commit_message>
P0 DT122: B6 post-Prabhu — QoS CCC scope, dark contrast, minimal next steps.
Replace datapath title and orange styling; QoSMAP → buffer-carving → QoS-CCC with emphasis; strip next-steps jargon for live delivery.

Co-authored-by: Cursor <cursoragent@cursor.com>
</commit_message>
<xml_diff>
--- a/dt122/bugatti-qos-ccc.pptx
+++ b/dt122/bugatti-qos-ccc.pptx
@@ -5486,7 +5486,7 @@
             <a:r>
               <a:rPr sz="1300">
                 <a:solidFill>
-                  <a:srgbClr val="FFE19E"/>
+                  <a:srgbClr val="051830"/>
                 </a:solidFill>
                 <a:latin typeface="Arial"/>
               </a:rPr>
@@ -5935,7 +5935,7 @@
                 </a:solidFill>
                 <a:latin typeface="Calibri"/>
               </a:rPr>
-              <a:t>Datapath · CCC scope</a:t>
+              <a:t>QoS CCC scope</a:t>
             </a:r>
             <a:endParaRPr sz="3000" b="0" i="0" u="none" strike="noStrike" cap="none">
               <a:solidFill>
@@ -5956,11 +5956,11 @@
             <a:r>
               <a:rPr sz="1300">
                 <a:solidFill>
-                  <a:srgbClr val="FFE19E"/>
+                  <a:srgbClr val="051830"/>
                 </a:solidFill>
                 <a:latin typeface="Arial"/>
               </a:rPr>
-              <a:t>Orange slice = buffer-carving scope</a:t>
+              <a:t>Highlighted slice = buffer-carving scope</a:t>
             </a:r>
           </a:p>
           <a:p>
@@ -5972,11 +5972,11 @@
             <a:r>
               <a:rPr sz="1300">
                 <a:solidFill>
-                  <a:srgbClr val="556677"/>
+                  <a:srgbClr val="333333"/>
                 </a:solidFill>
                 <a:latin typeface="Arial"/>
               </a:rPr>
-              <a:t>QoSMAP · CSB buffer-carving · QoS-CCC — aligned with qos architecture.</a:t>
+              <a:t>QoSMAP → CSB buffer-carving → QoS-CCC</a:t>
             </a:r>
           </a:p>
           <a:p>
@@ -6474,7 +6474,7 @@
             <a:r>
               <a:rPr sz="1300">
                 <a:solidFill>
-                  <a:srgbClr val="FFE19E"/>
+                  <a:srgbClr val="051830"/>
                 </a:solidFill>
                 <a:latin typeface="Arial"/>
               </a:rPr>
@@ -6490,7 +6490,7 @@
             <a:r>
               <a:rPr sz="1300">
                 <a:solidFill>
-                  <a:srgbClr val="556677"/>
+                  <a:srgbClr val="333333"/>
                 </a:solidFill>
                 <a:latin typeface="Arial"/>
               </a:rPr>
@@ -6992,11 +6992,11 @@
             <a:r>
               <a:rPr sz="1300">
                 <a:solidFill>
-                  <a:srgbClr val="FFE19E"/>
+                  <a:srgbClr val="051830"/>
                 </a:solidFill>
                 <a:latin typeface="Arial"/>
               </a:rPr>
-              <a:t>Egress buffer policy · version 0</a:t>
+              <a:t>Egress buffer policy</a:t>
             </a:r>
           </a:p>
           <a:p>
@@ -7008,7 +7008,7 @@
             <a:r>
               <a:rPr sz="1300">
                 <a:solidFill>
-                  <a:srgbClr val="556677"/>
+                  <a:srgbClr val="333333"/>
                 </a:solidFill>
                 <a:latin typeface="Arial"/>
               </a:rPr>
@@ -7028,7 +7028,7 @@
                 </a:solidFill>
                 <a:latin typeface="Arial"/>
               </a:rPr>
-              <a:t>• Near-term deliverable: buffer-carving plan and gate version 0 · next few days.</a:t>
+              <a:t>• Near-term deliverable: buffer-carving plan · next few days.</a:t>
             </a:r>
           </a:p>
           <a:p>
@@ -7399,8 +7399,8 @@
         </p:blipFill>
         <p:spPr>
           <a:xfrm>
-            <a:off x="3414719" y="1508760"/>
-            <a:ext cx="2314562" cy="3246120"/>
+            <a:off x="3364054" y="1508760"/>
+            <a:ext cx="2415891" cy="3246120"/>
           </a:xfrm>
           <a:prstGeom prst="rect">
             <a:avLst/>
@@ -7510,7 +7510,7 @@
             <a:r>
               <a:rPr sz="1300">
                 <a:solidFill>
-                  <a:srgbClr val="FFE19E"/>
+                  <a:srgbClr val="051830"/>
                 </a:solidFill>
                 <a:latin typeface="Arial"/>
               </a:rPr>
@@ -7526,11 +7526,11 @@
             <a:r>
               <a:rPr sz="1300">
                 <a:solidFill>
-                  <a:srgbClr val="556677"/>
+                  <a:srgbClr val="333333"/>
                 </a:solidFill>
                 <a:latin typeface="Arial"/>
               </a:rPr>
-              <a:t>Version 0 placeholders — refine from HW architecture, RTL, and c-models.</a:t>
+              <a:t>Placeholders — refine from HW architecture, RTL, and c-models.</a:t>
             </a:r>
           </a:p>
           <a:p>
@@ -7546,7 +7546,7 @@
                 </a:solidFill>
                 <a:latin typeface="Arial"/>
               </a:rPr>
-              <a:t>• Orange rows: CSB buffer-carving and fabric pool context — values TBD.</a:t>
+              <a:t>• Highlighted rows: CSB buffer-carving and fabric pool context — values TBD.</a:t>
             </a:r>
           </a:p>
           <a:p>
@@ -8028,7 +8028,7 @@
             <a:r>
               <a:rPr sz="1300">
                 <a:solidFill>
-                  <a:srgbClr val="FFE19E"/>
+                  <a:srgbClr val="051830"/>
                 </a:solidFill>
                 <a:latin typeface="Arial"/>
               </a:rPr>
@@ -8044,7 +8044,7 @@
             <a:r>
               <a:rPr sz="1300">
                 <a:solidFill>
-                  <a:srgbClr val="556677"/>
+                  <a:srgbClr val="333333"/>
                 </a:solidFill>
                 <a:latin typeface="Arial"/>
               </a:rPr>
@@ -8544,54 +8544,6 @@
               </a:spcAft>
             </a:pPr>
             <a:r>
-              <a:rPr sz="1300">
-                <a:solidFill>
-                  <a:srgbClr val="FFE19E"/>
-                </a:solidFill>
-                <a:latin typeface="Arial"/>
-              </a:rPr>
-              <a:t>Back to alignment · checkpoints</a:t>
-            </a:r>
-          </a:p>
-          <a:p>
-            <a:pPr>
-              <a:spcAft>
-                <a:spcPts val="200"/>
-              </a:spcAft>
-            </a:pPr>
-            <a:r>
-              <a:rPr sz="1300">
-                <a:solidFill>
-                  <a:srgbClr val="556677"/>
-                </a:solidFill>
-                <a:latin typeface="Arial"/>
-              </a:rPr>
-              <a:t>Lock version 0 gates — continue qos architecture close.</a:t>
-            </a:r>
-          </a:p>
-          <a:p>
-            <a:pPr>
-              <a:spcAft>
-                <a:spcPts val="200"/>
-              </a:spcAft>
-            </a:pPr>
-            <a:r>
-              <a:rPr sz="1100">
-                <a:solidFill>
-                  <a:srgbClr val="333333"/>
-                </a:solidFill>
-                <a:latin typeface="Arial"/>
-              </a:rPr>
-              <a:t>• Revision 0.1.</a:t>
-            </a:r>
-          </a:p>
-          <a:p>
-            <a:pPr>
-              <a:spcAft>
-                <a:spcPts val="200"/>
-              </a:spcAft>
-            </a:pPr>
-            <a:r>
               <a:rPr sz="1100">
                 <a:solidFill>
                   <a:srgbClr val="333333"/>
@@ -8953,8 +8905,8 @@
         </p:blipFill>
         <p:spPr>
           <a:xfrm>
-            <a:off x="3173671" y="1508760"/>
-            <a:ext cx="2796657" cy="3246120"/>
+            <a:off x="3128636" y="1508760"/>
+            <a:ext cx="2886728" cy="3246120"/>
           </a:xfrm>
           <a:prstGeom prst="rect">
             <a:avLst/>

</xml_diff>

<commit_message>
P0 DT122: B6 Hongal-ready — Cap/Cap/Con walk, minimal copy, SAMPLE tables.
Cover shows author and date; Guru pipeline is image-only; pie emphasizes CSB buffer-carving; scope and closing diagrams show don't tell.

Co-authored-by: Cursor <cursoragent@cursor.com>
</commit_message>
<xml_diff>
--- a/dt122/bugatti-qos-ccc.pptx
+++ b/dt122/bugatti-qos-ccc.pptx
@@ -4167,14 +4167,14 @@
             <a:r>
               <a:rPr lang="en-US" sz="1100" b="0" i="1" u="none" strike="noStrike" cap="none">
                 <a:solidFill>
-                  <a:srgbClr val="AABBCC"/>
+                  <a:srgbClr val="EF6C00"/>
                 </a:solidFill>
                 <a:latin typeface="Calibri"/>
                 <a:ea typeface="Calibri"/>
                 <a:cs typeface="Calibri"/>
                 <a:sym typeface="Calibri"/>
               </a:rPr>
-              <a:t>Follows qos architecture · Revision 0.1</a:t>
+              <a:t>Diwakar Tundlam · 5 Jun 2026</a:t>
             </a:r>
             <a:endParaRPr sz="1100" b="0" i="0" u="none" strike="noStrike" cap="none">
               <a:solidFill>
@@ -5425,7 +5425,7 @@
         <p:spPr>
           <a:xfrm>
             <a:off x="411480" y="201168"/>
-            <a:ext cx="8321100" cy="594300"/>
+            <a:ext cx="0" cy="0"/>
           </a:xfrm>
           <a:prstGeom prst="rect">
             <a:avLst/>
@@ -5441,15 +5441,15 @@
           </a:bodyPr>
           <a:lstStyle/>
           <a:p>
-            <a:pPr marL="0" marR="0" indent="0" algn="l" rtl="0">
-              <a:lnSpc>
-                <a:spcPct val="100000"/>
-              </a:lnSpc>
-              <a:spcBef>
-                <a:spcPts val="0"/>
-              </a:spcBef>
-              <a:spcAft>
-                <a:spcPts val="200"/>
+            <a:pPr marL="0" marR="0" lvl="0" indent="0" algn="l" rtl="0">
+              <a:lnSpc>
+                <a:spcPct val="100000"/>
+              </a:lnSpc>
+              <a:spcBef>
+                <a:spcPts val="0"/>
+              </a:spcBef>
+              <a:spcAft>
+                <a:spcPts val="0"/>
               </a:spcAft>
               <a:buClr>
                 <a:srgbClr val="051830"/>
@@ -5458,15 +5458,6 @@
               <a:buFont typeface="Calibri"/>
               <a:buNone/>
             </a:pPr>
-            <a:r>
-              <a:rPr sz="2600">
-                <a:solidFill>
-                  <a:srgbClr val="051830"/>
-                </a:solidFill>
-                <a:latin typeface="Calibri"/>
-              </a:rPr>
-              <a:t>Logical pipeline</a:t>
-            </a:r>
             <a:endParaRPr sz="3000" b="0" i="0" u="none" strike="noStrike" cap="none">
               <a:solidFill>
                 <a:schemeClr val="dk1"/>
@@ -5476,22 +5467,6 @@
               <a:cs typeface="Calibri"/>
               <a:sym typeface="Calibri"/>
             </a:endParaRPr>
-          </a:p>
-          <a:p>
-            <a:pPr>
-              <a:spcAft>
-                <a:spcPts val="200"/>
-              </a:spcAft>
-            </a:pPr>
-            <a:r>
-              <a:rPr sz="1300">
-                <a:solidFill>
-                  <a:srgbClr val="051830"/>
-                </a:solidFill>
-                <a:latin typeface="Arial"/>
-              </a:rPr>
-              <a:t>Program kickoff slide — unchanged</a:t>
-            </a:r>
           </a:p>
         </p:txBody>
       </p:sp>
@@ -5845,8 +5820,8 @@
         </p:blipFill>
         <p:spPr>
           <a:xfrm>
-            <a:off x="1681542" y="1508760"/>
-            <a:ext cx="5780916" cy="3246120"/>
+            <a:off x="623064" y="320040"/>
+            <a:ext cx="7897871" cy="4434840"/>
           </a:xfrm>
           <a:prstGeom prst="rect">
             <a:avLst/>
@@ -5956,59 +5931,11 @@
             <a:r>
               <a:rPr sz="1300">
                 <a:solidFill>
-                  <a:srgbClr val="051830"/>
-                </a:solidFill>
-                <a:latin typeface="Arial"/>
-              </a:rPr>
-              <a:t>Highlighted slice = buffer-carving scope</a:t>
-            </a:r>
-          </a:p>
-          <a:p>
-            <a:pPr>
-              <a:spcAft>
-                <a:spcPts val="200"/>
-              </a:spcAft>
-            </a:pPr>
-            <a:r>
-              <a:rPr sz="1300">
-                <a:solidFill>
                   <a:srgbClr val="333333"/>
                 </a:solidFill>
                 <a:latin typeface="Arial"/>
               </a:rPr>
               <a:t>QoSMAP → CSB buffer-carving → QoS-CCC</a:t>
-            </a:r>
-          </a:p>
-          <a:p>
-            <a:pPr>
-              <a:spcAft>
-                <a:spcPts val="200"/>
-              </a:spcAft>
-            </a:pPr>
-            <a:r>
-              <a:rPr sz="1100">
-                <a:solidFill>
-                  <a:srgbClr val="333333"/>
-                </a:solidFill>
-                <a:latin typeface="Arial"/>
-              </a:rPr>
-              <a:t>• Schematic only — equal slices, not sizing metrics.</a:t>
-            </a:r>
-          </a:p>
-          <a:p>
-            <a:pPr>
-              <a:spcAft>
-                <a:spcPts val="200"/>
-              </a:spcAft>
-            </a:pPr>
-            <a:r>
-              <a:rPr sz="1100">
-                <a:solidFill>
-                  <a:srgbClr val="333333"/>
-                </a:solidFill>
-                <a:latin typeface="Arial"/>
-              </a:rPr>
-              <a:t>• Other pipeline blocks covered on peer architecture decks (SharePoint).</a:t>
             </a:r>
           </a:p>
         </p:txBody>
@@ -6453,7 +6380,7 @@
                 </a:solidFill>
                 <a:latin typeface="Calibri"/>
               </a:rPr>
-              <a:t>QoS classify and remark</a:t>
+              <a:t>Capabilities · QoS classify and remark</a:t>
             </a:r>
             <a:endParaRPr sz="3000" b="0" i="0" u="none" strike="noStrike" cap="none">
               <a:solidFill>
@@ -6474,27 +6401,11 @@
             <a:r>
               <a:rPr sz="1300">
                 <a:solidFill>
-                  <a:srgbClr val="051830"/>
-                </a:solidFill>
-                <a:latin typeface="Arial"/>
-              </a:rPr>
-              <a:t>Upstream of buffer-carving</a:t>
-            </a:r>
-          </a:p>
-          <a:p>
-            <a:pPr>
-              <a:spcAft>
-                <a:spcPts val="200"/>
-              </a:spcAft>
-            </a:pPr>
-            <a:r>
-              <a:rPr sz="1300">
-                <a:solidFill>
                   <a:srgbClr val="333333"/>
                 </a:solidFill>
                 <a:latin typeface="Arial"/>
               </a:rPr>
-              <a:t>VLAN priority, Differentiated Services Code Point (DSCP), ESUN class of service, and Unified Forwarding Header (UFH) → Traffic Class (TC) on egress.</a:t>
+              <a:t>VLAN · DSCP · ESUN · UFH → TC on egress.</a:t>
             </a:r>
           </a:p>
           <a:p>
@@ -6510,23 +6421,7 @@
                 </a:solidFill>
                 <a:latin typeface="Arial"/>
               </a:rPr>
-              <a:t>• Access Control List (ACL) can override remark policy.</a:t>
-            </a:r>
-          </a:p>
-          <a:p>
-            <a:pPr>
-              <a:spcAft>
-                <a:spcPts val="200"/>
-              </a:spcAft>
-            </a:pPr>
-            <a:r>
-              <a:rPr sz="1100">
-                <a:solidFill>
-                  <a:srgbClr val="333333"/>
-                </a:solidFill>
-                <a:latin typeface="Arial"/>
-              </a:rPr>
-              <a:t>• Handoff: classify → remark → Queue → buffer-carving at CSB.</a:t>
+              <a:t>• ACL can override remark policy.</a:t>
             </a:r>
           </a:p>
         </p:txBody>
@@ -6881,8 +6776,8 @@
         </p:blipFill>
         <p:spPr>
           <a:xfrm>
-            <a:off x="365760" y="2816895"/>
-            <a:ext cx="8412480" cy="629850"/>
+            <a:off x="365760" y="2792355"/>
+            <a:ext cx="8412480" cy="678929"/>
           </a:xfrm>
           <a:prstGeom prst="rect">
             <a:avLst/>
@@ -6971,7 +6866,7 @@
                 </a:solidFill>
                 <a:latin typeface="Calibri"/>
               </a:rPr>
-              <a:t>Buffer-carving at Central Scheduler Block (CSB)</a:t>
+              <a:t>Capacities · Buffer-carving at CSB</a:t>
             </a:r>
             <a:endParaRPr sz="3000" b="0" i="0" u="none" strike="noStrike" cap="none">
               <a:solidFill>
@@ -6992,59 +6887,11 @@
             <a:r>
               <a:rPr sz="1300">
                 <a:solidFill>
-                  <a:srgbClr val="051830"/>
-                </a:solidFill>
-                <a:latin typeface="Arial"/>
-              </a:rPr>
-              <a:t>Egress buffer policy</a:t>
-            </a:r>
-          </a:p>
-          <a:p>
-            <a:pPr>
-              <a:spcAft>
-                <a:spcPts val="200"/>
-              </a:spcAft>
-            </a:pPr>
-            <a:r>
-              <a:rPr sz="1300">
-                <a:solidFill>
                   <a:srgbClr val="333333"/>
                 </a:solidFill>
                 <a:latin typeface="Arial"/>
               </a:rPr>
-              <a:t>Pool modes, buffer-carving sizes, admission, Priority Flow Control (PFC), port-speed coherence.</a:t>
-            </a:r>
-          </a:p>
-          <a:p>
-            <a:pPr>
-              <a:spcAft>
-                <a:spcPts val="200"/>
-              </a:spcAft>
-            </a:pPr>
-            <a:r>
-              <a:rPr sz="1100">
-                <a:solidFill>
-                  <a:srgbClr val="333333"/>
-                </a:solidFill>
-                <a:latin typeface="Arial"/>
-              </a:rPr>
-              <a:t>• Near-term deliverable: buffer-carving plan · next few days.</a:t>
-            </a:r>
-          </a:p>
-          <a:p>
-            <a:pPr>
-              <a:spcAft>
-                <a:spcPts val="200"/>
-              </a:spcAft>
-            </a:pPr>
-            <a:r>
-              <a:rPr sz="1100">
-                <a:solidFill>
-                  <a:srgbClr val="333333"/>
-                </a:solidFill>
-                <a:latin typeface="Arial"/>
-              </a:rPr>
-              <a:t>• Hardware pool and register-transfer-level (RTL) sizing — in progress with architecture.</a:t>
+              <a:t>Pool modes, carve sizes, admission, PFC — HW arch limits.</a:t>
             </a:r>
           </a:p>
         </p:txBody>
@@ -7489,7 +7336,7 @@
                 </a:solidFill>
                 <a:latin typeface="Calibri"/>
               </a:rPr>
-              <a:t>CSB buffer-carving · CCC</a:t>
+              <a:t>Constraints · CSB buffer-carving</a:t>
             </a:r>
             <a:endParaRPr sz="3000" b="0" i="0" u="none" strike="noStrike" cap="none">
               <a:solidFill>
@@ -7500,70 +7347,6 @@
               <a:cs typeface="Calibri"/>
               <a:sym typeface="Calibri"/>
             </a:endParaRPr>
-          </a:p>
-          <a:p>
-            <a:pPr>
-              <a:spcAft>
-                <a:spcPts val="200"/>
-              </a:spcAft>
-            </a:pPr>
-            <a:r>
-              <a:rPr sz="1300">
-                <a:solidFill>
-                  <a:srgbClr val="051830"/>
-                </a:solidFill>
-                <a:latin typeface="Arial"/>
-              </a:rPr>
-              <a:t>Capabilities · Capacities · Constraints</a:t>
-            </a:r>
-          </a:p>
-          <a:p>
-            <a:pPr>
-              <a:spcAft>
-                <a:spcPts val="200"/>
-              </a:spcAft>
-            </a:pPr>
-            <a:r>
-              <a:rPr sz="1300">
-                <a:solidFill>
-                  <a:srgbClr val="333333"/>
-                </a:solidFill>
-                <a:latin typeface="Arial"/>
-              </a:rPr>
-              <a:t>Placeholders — refine from HW architecture, RTL, and c-models.</a:t>
-            </a:r>
-          </a:p>
-          <a:p>
-            <a:pPr>
-              <a:spcAft>
-                <a:spcPts val="200"/>
-              </a:spcAft>
-            </a:pPr>
-            <a:r>
-              <a:rPr sz="1100">
-                <a:solidFill>
-                  <a:srgbClr val="333333"/>
-                </a:solidFill>
-                <a:latin typeface="Arial"/>
-              </a:rPr>
-              <a:t>• Highlighted rows: CSB buffer-carving and fabric pool context — values TBD.</a:t>
-            </a:r>
-          </a:p>
-          <a:p>
-            <a:pPr>
-              <a:spcAft>
-                <a:spcPts val="200"/>
-              </a:spcAft>
-            </a:pPr>
-            <a:r>
-              <a:rPr sz="1100">
-                <a:solidFill>
-                  <a:srgbClr val="333333"/>
-                </a:solidFill>
-                <a:latin typeface="Arial"/>
-              </a:rPr>
-              <a:t>• Use-case-driven datapath may revise rows.</a:t>
-            </a:r>
           </a:p>
         </p:txBody>
       </p:sp>
@@ -8007,7 +7790,7 @@
                 </a:solidFill>
                 <a:latin typeface="Calibri"/>
               </a:rPr>
-              <a:t>Scope and open items</a:t>
+              <a:t>Scope</a:t>
             </a:r>
             <a:endParaRPr sz="3000" b="0" i="0" u="none" strike="noStrike" cap="none">
               <a:solidFill>
@@ -8018,70 +7801,6 @@
               <a:cs typeface="Calibri"/>
               <a:sym typeface="Calibri"/>
             </a:endParaRPr>
-          </a:p>
-          <a:p>
-            <a:pPr>
-              <a:spcAft>
-                <a:spcPts val="200"/>
-              </a:spcAft>
-            </a:pPr>
-            <a:r>
-              <a:rPr sz="1300">
-                <a:solidFill>
-                  <a:srgbClr val="051830"/>
-                </a:solidFill>
-                <a:latin typeface="Arial"/>
-              </a:rPr>
-              <a:t>In scope versus deferred</a:t>
-            </a:r>
-          </a:p>
-          <a:p>
-            <a:pPr>
-              <a:spcAft>
-                <a:spcPts val="200"/>
-              </a:spcAft>
-            </a:pPr>
-            <a:r>
-              <a:rPr sz="1300">
-                <a:solidFill>
-                  <a:srgbClr val="333333"/>
-                </a:solidFill>
-                <a:latin typeface="Arial"/>
-              </a:rPr>
-              <a:t>What this CCC covers versus peer decks.</a:t>
-            </a:r>
-          </a:p>
-          <a:p>
-            <a:pPr>
-              <a:spcAft>
-                <a:spcPts val="200"/>
-              </a:spcAft>
-            </a:pPr>
-            <a:r>
-              <a:rPr sz="1100">
-                <a:solidFill>
-                  <a:srgbClr val="333333"/>
-                </a:solidFill>
-                <a:latin typeface="Arial"/>
-              </a:rPr>
-              <a:t>• Open: Ingress Fabric Port (IFP), Ingress Switch Buffer (ISB), CSB, and Egress Fabric Port (EFP) pool sizing.</a:t>
-            </a:r>
-          </a:p>
-          <a:p>
-            <a:pPr>
-              <a:spcAft>
-                <a:spcPts val="200"/>
-              </a:spcAft>
-            </a:pPr>
-            <a:r>
-              <a:rPr sz="1100">
-                <a:solidFill>
-                  <a:srgbClr val="333333"/>
-                </a:solidFill>
-                <a:latin typeface="Arial"/>
-              </a:rPr>
-              <a:t>• Deferred: software development kit (SDK) swimlanes and duplicating full peer deck bodies.</a:t>
-            </a:r>
           </a:p>
         </p:txBody>
       </p:sp>
@@ -8435,8 +8154,8 @@
         </p:blipFill>
         <p:spPr>
           <a:xfrm>
-            <a:off x="365760" y="1642683"/>
-            <a:ext cx="8412480" cy="2978274"/>
+            <a:off x="365760" y="1693066"/>
+            <a:ext cx="8412480" cy="2877508"/>
           </a:xfrm>
           <a:prstGeom prst="rect">
             <a:avLst/>
@@ -8525,7 +8244,7 @@
                 </a:solidFill>
                 <a:latin typeface="Calibri"/>
               </a:rPr>
-              <a:t>Next steps</a:t>
+              <a:t>Closing</a:t>
             </a:r>
             <a:endParaRPr sz="3000" b="0" i="0" u="none" strike="noStrike" cap="none">
               <a:solidFill>
@@ -8536,22 +8255,6 @@
               <a:cs typeface="Calibri"/>
               <a:sym typeface="Calibri"/>
             </a:endParaRPr>
-          </a:p>
-          <a:p>
-            <a:pPr>
-              <a:spcAft>
-                <a:spcPts val="200"/>
-              </a:spcAft>
-            </a:pPr>
-            <a:r>
-              <a:rPr sz="1100">
-                <a:solidFill>
-                  <a:srgbClr val="333333"/>
-                </a:solidFill>
-                <a:latin typeface="Arial"/>
-              </a:rPr>
-              <a:t>• Publish to SharePoint after group review.</a:t>
-            </a:r>
           </a:p>
         </p:txBody>
       </p:sp>
@@ -8905,8 +8608,8 @@
         </p:blipFill>
         <p:spPr>
           <a:xfrm>
-            <a:off x="3128636" y="1508760"/>
-            <a:ext cx="2886728" cy="3246120"/>
+            <a:off x="523897" y="1508760"/>
+            <a:ext cx="8096205" cy="3246120"/>
           </a:xfrm>
           <a:prstGeom prst="rect">
             <a:avLst/>

</xml_diff>

<commit_message>
P0 DT122: B6 sharp flow diagrams + mandate checkpoint.
Replace tiny mermaid PNGs with 1800×720 Pillow renders (uniform boxes); update CHECKPOINT for Datapath DRI/XLS and Hongal 3pm path; add DT126 Friday scheduling.

Co-authored-by: Cursor <cursoragent@cursor.com>
</commit_message>
<xml_diff>
--- a/dt122/bugatti-qos-ccc.pptx
+++ b/dt122/bugatti-qos-ccc.pptx
@@ -6290,8 +6290,8 @@
         </p:blipFill>
         <p:spPr>
           <a:xfrm>
-            <a:off x="1325880" y="1508760"/>
-            <a:ext cx="6492239" cy="3246119"/>
+            <a:off x="514350" y="1508760"/>
+            <a:ext cx="8115300" cy="3246120"/>
           </a:xfrm>
           <a:prstGeom prst="rect">
             <a:avLst/>
@@ -6776,8 +6776,8 @@
         </p:blipFill>
         <p:spPr>
           <a:xfrm>
-            <a:off x="365760" y="2792355"/>
-            <a:ext cx="8412480" cy="678929"/>
+            <a:off x="514350" y="1508760"/>
+            <a:ext cx="8115300" cy="3246120"/>
           </a:xfrm>
           <a:prstGeom prst="rect">
             <a:avLst/>
@@ -7246,8 +7246,8 @@
         </p:blipFill>
         <p:spPr>
           <a:xfrm>
-            <a:off x="3364054" y="1508760"/>
-            <a:ext cx="2415891" cy="3246120"/>
+            <a:off x="514350" y="1508760"/>
+            <a:ext cx="8115300" cy="3246120"/>
           </a:xfrm>
           <a:prstGeom prst="rect">
             <a:avLst/>
@@ -7701,7 +7701,7 @@
         <p:spPr>
           <a:xfrm>
             <a:off x="1325880" y="1508760"/>
-            <a:ext cx="6492239" cy="3246119"/>
+            <a:ext cx="6492240" cy="3246120"/>
           </a:xfrm>
           <a:prstGeom prst="rect">
             <a:avLst/>
@@ -8154,8 +8154,8 @@
         </p:blipFill>
         <p:spPr>
           <a:xfrm>
-            <a:off x="365760" y="1693066"/>
-            <a:ext cx="8412480" cy="2877508"/>
+            <a:off x="514350" y="1508760"/>
+            <a:ext cx="8115300" cy="3246120"/>
           </a:xfrm>
           <a:prstGeom prst="rect">
             <a:avLst/>
@@ -8608,8 +8608,8 @@
         </p:blipFill>
         <p:spPr>
           <a:xfrm>
-            <a:off x="523897" y="1508760"/>
-            <a:ext cx="8096205" cy="3246120"/>
+            <a:off x="514350" y="1508760"/>
+            <a:ext cx="8115300" cy="3246120"/>
           </a:xfrm>
           <a:prstGeom prst="rect">
             <a:avLst/>

</xml_diff>